<commit_message>
recommender fix and polish
</commit_message>
<xml_diff>
--- a/ml-examples/recommender/slides/recommender.pptx
+++ b/ml-examples/recommender/slides/recommender.pptx
@@ -5,7 +5,7 @@
     <p:sldMasterId id="2147483678" r:id="rId1"/>
   </p:sldMasterIdLst>
   <p:notesMasterIdLst>
-    <p:notesMasterId r:id="rId12"/>
+    <p:notesMasterId r:id="rId13"/>
   </p:notesMasterIdLst>
   <p:sldIdLst>
     <p:sldId id="256" r:id="rId2"/>
@@ -17,7 +17,8 @@
     <p:sldId id="264" r:id="rId8"/>
     <p:sldId id="263" r:id="rId9"/>
     <p:sldId id="265" r:id="rId10"/>
-    <p:sldId id="266" r:id="rId11"/>
+    <p:sldId id="280" r:id="rId11"/>
+    <p:sldId id="266" r:id="rId12"/>
   </p:sldIdLst>
   <p:sldSz cx="12192000" cy="6858000"/>
   <p:notesSz cx="6858000" cy="9144000"/>
@@ -134,6 +135,7 @@
         </p14:section>
         <p14:section name="Appendix" id="{AA17D5B7-4E6B-422C-AAAE-D7B40BF83B53}">
           <p14:sldIdLst>
+            <p14:sldId id="280"/>
             <p14:sldId id="266"/>
           </p14:sldIdLst>
         </p14:section>
@@ -5376,6 +5378,753 @@
 </file>
 
 <file path=ppt/diagrams/colors8.xml><?xml version="1.0" encoding="utf-8"?>
+<dgm:colorsDef xmlns:dgm="http://schemas.openxmlformats.org/drawingml/2006/diagram" xmlns:a="http://schemas.openxmlformats.org/drawingml/2006/main" uniqueId="urn:microsoft.com/office/officeart/2005/8/colors/accent1_2">
+  <dgm:title val=""/>
+  <dgm:desc val=""/>
+  <dgm:catLst>
+    <dgm:cat type="accent1" pri="11200"/>
+  </dgm:catLst>
+  <dgm:styleLbl name="node0">
+    <dgm:fillClrLst meth="repeat">
+      <a:schemeClr val="accent1"/>
+    </dgm:fillClrLst>
+    <dgm:linClrLst meth="repeat">
+      <a:schemeClr val="lt1"/>
+    </dgm:linClrLst>
+    <dgm:effectClrLst/>
+    <dgm:txLinClrLst/>
+    <dgm:txFillClrLst/>
+    <dgm:txEffectClrLst/>
+  </dgm:styleLbl>
+  <dgm:styleLbl name="alignNode1">
+    <dgm:fillClrLst meth="repeat">
+      <a:schemeClr val="accent1"/>
+    </dgm:fillClrLst>
+    <dgm:linClrLst meth="repeat">
+      <a:schemeClr val="accent1"/>
+    </dgm:linClrLst>
+    <dgm:effectClrLst/>
+    <dgm:txLinClrLst/>
+    <dgm:txFillClrLst/>
+    <dgm:txEffectClrLst/>
+  </dgm:styleLbl>
+  <dgm:styleLbl name="node1">
+    <dgm:fillClrLst meth="repeat">
+      <a:schemeClr val="accent1"/>
+    </dgm:fillClrLst>
+    <dgm:linClrLst meth="repeat">
+      <a:schemeClr val="lt1"/>
+    </dgm:linClrLst>
+    <dgm:effectClrLst/>
+    <dgm:txLinClrLst/>
+    <dgm:txFillClrLst/>
+    <dgm:txEffectClrLst/>
+  </dgm:styleLbl>
+  <dgm:styleLbl name="lnNode1">
+    <dgm:fillClrLst meth="repeat">
+      <a:schemeClr val="accent1"/>
+    </dgm:fillClrLst>
+    <dgm:linClrLst meth="repeat">
+      <a:schemeClr val="lt1"/>
+    </dgm:linClrLst>
+    <dgm:effectClrLst/>
+    <dgm:txLinClrLst/>
+    <dgm:txFillClrLst/>
+    <dgm:txEffectClrLst/>
+  </dgm:styleLbl>
+  <dgm:styleLbl name="vennNode1">
+    <dgm:fillClrLst meth="repeat">
+      <a:schemeClr val="accent1">
+        <a:alpha val="50000"/>
+      </a:schemeClr>
+    </dgm:fillClrLst>
+    <dgm:linClrLst meth="repeat">
+      <a:schemeClr val="lt1"/>
+    </dgm:linClrLst>
+    <dgm:effectClrLst/>
+    <dgm:txLinClrLst/>
+    <dgm:txFillClrLst/>
+    <dgm:txEffectClrLst/>
+  </dgm:styleLbl>
+  <dgm:styleLbl name="node2">
+    <dgm:fillClrLst meth="repeat">
+      <a:schemeClr val="accent1"/>
+    </dgm:fillClrLst>
+    <dgm:linClrLst meth="repeat">
+      <a:schemeClr val="lt1"/>
+    </dgm:linClrLst>
+    <dgm:effectClrLst/>
+    <dgm:txLinClrLst/>
+    <dgm:txFillClrLst/>
+    <dgm:txEffectClrLst/>
+  </dgm:styleLbl>
+  <dgm:styleLbl name="node3">
+    <dgm:fillClrLst meth="repeat">
+      <a:schemeClr val="accent1"/>
+    </dgm:fillClrLst>
+    <dgm:linClrLst meth="repeat">
+      <a:schemeClr val="lt1"/>
+    </dgm:linClrLst>
+    <dgm:effectClrLst/>
+    <dgm:txLinClrLst/>
+    <dgm:txFillClrLst/>
+    <dgm:txEffectClrLst/>
+  </dgm:styleLbl>
+  <dgm:styleLbl name="node4">
+    <dgm:fillClrLst meth="repeat">
+      <a:schemeClr val="accent1"/>
+    </dgm:fillClrLst>
+    <dgm:linClrLst meth="repeat">
+      <a:schemeClr val="lt1"/>
+    </dgm:linClrLst>
+    <dgm:effectClrLst/>
+    <dgm:txLinClrLst/>
+    <dgm:txFillClrLst/>
+    <dgm:txEffectClrLst/>
+  </dgm:styleLbl>
+  <dgm:styleLbl name="fgImgPlace1">
+    <dgm:fillClrLst meth="repeat">
+      <a:schemeClr val="accent1">
+        <a:tint val="50000"/>
+      </a:schemeClr>
+    </dgm:fillClrLst>
+    <dgm:linClrLst meth="repeat">
+      <a:schemeClr val="lt1"/>
+    </dgm:linClrLst>
+    <dgm:effectClrLst/>
+    <dgm:txLinClrLst/>
+    <dgm:txFillClrLst meth="repeat">
+      <a:schemeClr val="lt1"/>
+    </dgm:txFillClrLst>
+    <dgm:txEffectClrLst/>
+  </dgm:styleLbl>
+  <dgm:styleLbl name="alignImgPlace1">
+    <dgm:fillClrLst meth="repeat">
+      <a:schemeClr val="accent1">
+        <a:tint val="50000"/>
+      </a:schemeClr>
+    </dgm:fillClrLst>
+    <dgm:linClrLst meth="repeat">
+      <a:schemeClr val="lt1"/>
+    </dgm:linClrLst>
+    <dgm:effectClrLst/>
+    <dgm:txLinClrLst/>
+    <dgm:txFillClrLst meth="repeat">
+      <a:schemeClr val="lt1"/>
+    </dgm:txFillClrLst>
+    <dgm:txEffectClrLst/>
+  </dgm:styleLbl>
+  <dgm:styleLbl name="bgImgPlace1">
+    <dgm:fillClrLst meth="repeat">
+      <a:schemeClr val="accent1">
+        <a:tint val="50000"/>
+      </a:schemeClr>
+    </dgm:fillClrLst>
+    <dgm:linClrLst meth="repeat">
+      <a:schemeClr val="lt1"/>
+    </dgm:linClrLst>
+    <dgm:effectClrLst/>
+    <dgm:txLinClrLst/>
+    <dgm:txFillClrLst meth="repeat">
+      <a:schemeClr val="lt1"/>
+    </dgm:txFillClrLst>
+    <dgm:txEffectClrLst/>
+  </dgm:styleLbl>
+  <dgm:styleLbl name="sibTrans2D1">
+    <dgm:fillClrLst meth="repeat">
+      <a:schemeClr val="accent1">
+        <a:tint val="60000"/>
+      </a:schemeClr>
+    </dgm:fillClrLst>
+    <dgm:linClrLst meth="repeat">
+      <a:schemeClr val="accent1">
+        <a:tint val="60000"/>
+      </a:schemeClr>
+    </dgm:linClrLst>
+    <dgm:effectClrLst/>
+    <dgm:txLinClrLst/>
+    <dgm:txFillClrLst/>
+    <dgm:txEffectClrLst/>
+  </dgm:styleLbl>
+  <dgm:styleLbl name="fgSibTrans2D1">
+    <dgm:fillClrLst meth="repeat">
+      <a:schemeClr val="accent1">
+        <a:tint val="60000"/>
+      </a:schemeClr>
+    </dgm:fillClrLst>
+    <dgm:linClrLst meth="repeat">
+      <a:schemeClr val="accent1">
+        <a:tint val="60000"/>
+      </a:schemeClr>
+    </dgm:linClrLst>
+    <dgm:effectClrLst/>
+    <dgm:txLinClrLst/>
+    <dgm:txFillClrLst/>
+    <dgm:txEffectClrLst/>
+  </dgm:styleLbl>
+  <dgm:styleLbl name="bgSibTrans2D1">
+    <dgm:fillClrLst meth="repeat">
+      <a:schemeClr val="accent1">
+        <a:tint val="60000"/>
+      </a:schemeClr>
+    </dgm:fillClrLst>
+    <dgm:linClrLst meth="repeat">
+      <a:schemeClr val="accent1">
+        <a:tint val="60000"/>
+      </a:schemeClr>
+    </dgm:linClrLst>
+    <dgm:effectClrLst/>
+    <dgm:txLinClrLst/>
+    <dgm:txFillClrLst/>
+    <dgm:txEffectClrLst/>
+  </dgm:styleLbl>
+  <dgm:styleLbl name="sibTrans1D1">
+    <dgm:fillClrLst meth="repeat">
+      <a:schemeClr val="accent1"/>
+    </dgm:fillClrLst>
+    <dgm:linClrLst meth="repeat">
+      <a:schemeClr val="accent1"/>
+    </dgm:linClrLst>
+    <dgm:effectClrLst/>
+    <dgm:txLinClrLst/>
+    <dgm:txFillClrLst meth="repeat">
+      <a:schemeClr val="tx1"/>
+    </dgm:txFillClrLst>
+    <dgm:txEffectClrLst/>
+  </dgm:styleLbl>
+  <dgm:styleLbl name="callout">
+    <dgm:fillClrLst meth="repeat">
+      <a:schemeClr val="accent1"/>
+    </dgm:fillClrLst>
+    <dgm:linClrLst meth="repeat">
+      <a:schemeClr val="accent1">
+        <a:tint val="50000"/>
+      </a:schemeClr>
+    </dgm:linClrLst>
+    <dgm:effectClrLst/>
+    <dgm:txLinClrLst/>
+    <dgm:txFillClrLst meth="repeat">
+      <a:schemeClr val="tx1"/>
+    </dgm:txFillClrLst>
+    <dgm:txEffectClrLst/>
+  </dgm:styleLbl>
+  <dgm:styleLbl name="asst0">
+    <dgm:fillClrLst meth="repeat">
+      <a:schemeClr val="accent1"/>
+    </dgm:fillClrLst>
+    <dgm:linClrLst meth="repeat">
+      <a:schemeClr val="lt1"/>
+    </dgm:linClrLst>
+    <dgm:effectClrLst/>
+    <dgm:txLinClrLst/>
+    <dgm:txFillClrLst/>
+    <dgm:txEffectClrLst/>
+  </dgm:styleLbl>
+  <dgm:styleLbl name="asst1">
+    <dgm:fillClrLst meth="repeat">
+      <a:schemeClr val="accent1"/>
+    </dgm:fillClrLst>
+    <dgm:linClrLst meth="repeat">
+      <a:schemeClr val="lt1"/>
+    </dgm:linClrLst>
+    <dgm:effectClrLst/>
+    <dgm:txLinClrLst/>
+    <dgm:txFillClrLst/>
+    <dgm:txEffectClrLst/>
+  </dgm:styleLbl>
+  <dgm:styleLbl name="asst2">
+    <dgm:fillClrLst meth="repeat">
+      <a:schemeClr val="accent1"/>
+    </dgm:fillClrLst>
+    <dgm:linClrLst meth="repeat">
+      <a:schemeClr val="lt1"/>
+    </dgm:linClrLst>
+    <dgm:effectClrLst/>
+    <dgm:txLinClrLst/>
+    <dgm:txFillClrLst/>
+    <dgm:txEffectClrLst/>
+  </dgm:styleLbl>
+  <dgm:styleLbl name="asst3">
+    <dgm:fillClrLst meth="repeat">
+      <a:schemeClr val="accent1"/>
+    </dgm:fillClrLst>
+    <dgm:linClrLst meth="repeat">
+      <a:schemeClr val="lt1"/>
+    </dgm:linClrLst>
+    <dgm:effectClrLst/>
+    <dgm:txLinClrLst/>
+    <dgm:txFillClrLst/>
+    <dgm:txEffectClrLst/>
+  </dgm:styleLbl>
+  <dgm:styleLbl name="asst4">
+    <dgm:fillClrLst meth="repeat">
+      <a:schemeClr val="accent1"/>
+    </dgm:fillClrLst>
+    <dgm:linClrLst meth="repeat">
+      <a:schemeClr val="lt1"/>
+    </dgm:linClrLst>
+    <dgm:effectClrLst/>
+    <dgm:txLinClrLst/>
+    <dgm:txFillClrLst/>
+    <dgm:txEffectClrLst/>
+  </dgm:styleLbl>
+  <dgm:styleLbl name="parChTrans2D1">
+    <dgm:fillClrLst meth="repeat">
+      <a:schemeClr val="accent1">
+        <a:tint val="60000"/>
+      </a:schemeClr>
+    </dgm:fillClrLst>
+    <dgm:linClrLst meth="repeat">
+      <a:schemeClr val="accent1">
+        <a:tint val="60000"/>
+      </a:schemeClr>
+    </dgm:linClrLst>
+    <dgm:effectClrLst/>
+    <dgm:txLinClrLst/>
+    <dgm:txFillClrLst meth="repeat">
+      <a:schemeClr val="lt1"/>
+    </dgm:txFillClrLst>
+    <dgm:txEffectClrLst/>
+  </dgm:styleLbl>
+  <dgm:styleLbl name="parChTrans2D2">
+    <dgm:fillClrLst meth="repeat">
+      <a:schemeClr val="accent1"/>
+    </dgm:fillClrLst>
+    <dgm:linClrLst meth="repeat">
+      <a:schemeClr val="accent1"/>
+    </dgm:linClrLst>
+    <dgm:effectClrLst/>
+    <dgm:txLinClrLst/>
+    <dgm:txFillClrLst meth="repeat">
+      <a:schemeClr val="lt1"/>
+    </dgm:txFillClrLst>
+    <dgm:txEffectClrLst/>
+  </dgm:styleLbl>
+  <dgm:styleLbl name="parChTrans2D3">
+    <dgm:fillClrLst meth="repeat">
+      <a:schemeClr val="accent1"/>
+    </dgm:fillClrLst>
+    <dgm:linClrLst meth="repeat">
+      <a:schemeClr val="accent1"/>
+    </dgm:linClrLst>
+    <dgm:effectClrLst/>
+    <dgm:txLinClrLst/>
+    <dgm:txFillClrLst meth="repeat">
+      <a:schemeClr val="lt1"/>
+    </dgm:txFillClrLst>
+    <dgm:txEffectClrLst/>
+  </dgm:styleLbl>
+  <dgm:styleLbl name="parChTrans2D4">
+    <dgm:fillClrLst meth="repeat">
+      <a:schemeClr val="accent1"/>
+    </dgm:fillClrLst>
+    <dgm:linClrLst meth="repeat">
+      <a:schemeClr val="accent1"/>
+    </dgm:linClrLst>
+    <dgm:effectClrLst/>
+    <dgm:txLinClrLst/>
+    <dgm:txFillClrLst meth="repeat">
+      <a:schemeClr val="lt1"/>
+    </dgm:txFillClrLst>
+    <dgm:txEffectClrLst/>
+  </dgm:styleLbl>
+  <dgm:styleLbl name="parChTrans1D1">
+    <dgm:fillClrLst meth="repeat">
+      <a:schemeClr val="accent1"/>
+    </dgm:fillClrLst>
+    <dgm:linClrLst meth="repeat">
+      <a:schemeClr val="accent1">
+        <a:shade val="60000"/>
+      </a:schemeClr>
+    </dgm:linClrLst>
+    <dgm:effectClrLst/>
+    <dgm:txLinClrLst/>
+    <dgm:txFillClrLst meth="repeat">
+      <a:schemeClr val="tx1"/>
+    </dgm:txFillClrLst>
+    <dgm:txEffectClrLst/>
+  </dgm:styleLbl>
+  <dgm:styleLbl name="parChTrans1D2">
+    <dgm:fillClrLst meth="repeat">
+      <a:schemeClr val="accent1"/>
+    </dgm:fillClrLst>
+    <dgm:linClrLst meth="repeat">
+      <a:schemeClr val="accent1">
+        <a:shade val="60000"/>
+      </a:schemeClr>
+    </dgm:linClrLst>
+    <dgm:effectClrLst/>
+    <dgm:txLinClrLst/>
+    <dgm:txFillClrLst meth="repeat">
+      <a:schemeClr val="tx1"/>
+    </dgm:txFillClrLst>
+    <dgm:txEffectClrLst/>
+  </dgm:styleLbl>
+  <dgm:styleLbl name="parChTrans1D3">
+    <dgm:fillClrLst meth="repeat">
+      <a:schemeClr val="accent1"/>
+    </dgm:fillClrLst>
+    <dgm:linClrLst meth="repeat">
+      <a:schemeClr val="accent1">
+        <a:shade val="80000"/>
+      </a:schemeClr>
+    </dgm:linClrLst>
+    <dgm:effectClrLst/>
+    <dgm:txLinClrLst/>
+    <dgm:txFillClrLst meth="repeat">
+      <a:schemeClr val="tx1"/>
+    </dgm:txFillClrLst>
+    <dgm:txEffectClrLst/>
+  </dgm:styleLbl>
+  <dgm:styleLbl name="parChTrans1D4">
+    <dgm:fillClrLst meth="repeat">
+      <a:schemeClr val="accent1"/>
+    </dgm:fillClrLst>
+    <dgm:linClrLst meth="repeat">
+      <a:schemeClr val="accent1">
+        <a:shade val="80000"/>
+      </a:schemeClr>
+    </dgm:linClrLst>
+    <dgm:effectClrLst/>
+    <dgm:txLinClrLst/>
+    <dgm:txFillClrLst meth="repeat">
+      <a:schemeClr val="tx1"/>
+    </dgm:txFillClrLst>
+    <dgm:txEffectClrLst/>
+  </dgm:styleLbl>
+  <dgm:styleLbl name="fgAcc1">
+    <dgm:fillClrLst meth="repeat">
+      <a:schemeClr val="lt1">
+        <a:alpha val="90000"/>
+      </a:schemeClr>
+    </dgm:fillClrLst>
+    <dgm:linClrLst meth="repeat">
+      <a:schemeClr val="accent1"/>
+    </dgm:linClrLst>
+    <dgm:effectClrLst/>
+    <dgm:txLinClrLst/>
+    <dgm:txFillClrLst meth="repeat">
+      <a:schemeClr val="dk1"/>
+    </dgm:txFillClrLst>
+    <dgm:txEffectClrLst/>
+  </dgm:styleLbl>
+  <dgm:styleLbl name="conFgAcc1">
+    <dgm:fillClrLst meth="repeat">
+      <a:schemeClr val="lt1">
+        <a:alpha val="90000"/>
+      </a:schemeClr>
+    </dgm:fillClrLst>
+    <dgm:linClrLst meth="repeat">
+      <a:schemeClr val="accent1"/>
+    </dgm:linClrLst>
+    <dgm:effectClrLst/>
+    <dgm:txLinClrLst/>
+    <dgm:txFillClrLst meth="repeat">
+      <a:schemeClr val="dk1"/>
+    </dgm:txFillClrLst>
+    <dgm:txEffectClrLst/>
+  </dgm:styleLbl>
+  <dgm:styleLbl name="alignAcc1">
+    <dgm:fillClrLst meth="repeat">
+      <a:schemeClr val="lt1">
+        <a:alpha val="90000"/>
+      </a:schemeClr>
+    </dgm:fillClrLst>
+    <dgm:linClrLst meth="repeat">
+      <a:schemeClr val="accent1"/>
+    </dgm:linClrLst>
+    <dgm:effectClrLst/>
+    <dgm:txLinClrLst/>
+    <dgm:txFillClrLst meth="repeat">
+      <a:schemeClr val="dk1"/>
+    </dgm:txFillClrLst>
+    <dgm:txEffectClrLst/>
+  </dgm:styleLbl>
+  <dgm:styleLbl name="trAlignAcc1">
+    <dgm:fillClrLst meth="repeat">
+      <a:schemeClr val="lt1">
+        <a:alpha val="40000"/>
+      </a:schemeClr>
+    </dgm:fillClrLst>
+    <dgm:linClrLst meth="repeat">
+      <a:schemeClr val="accent1"/>
+    </dgm:linClrLst>
+    <dgm:effectClrLst/>
+    <dgm:txLinClrLst/>
+    <dgm:txFillClrLst meth="repeat">
+      <a:schemeClr val="dk1"/>
+    </dgm:txFillClrLst>
+    <dgm:txEffectClrLst/>
+  </dgm:styleLbl>
+  <dgm:styleLbl name="bgAcc1">
+    <dgm:fillClrLst meth="repeat">
+      <a:schemeClr val="lt1">
+        <a:alpha val="90000"/>
+      </a:schemeClr>
+    </dgm:fillClrLst>
+    <dgm:linClrLst meth="repeat">
+      <a:schemeClr val="accent1"/>
+    </dgm:linClrLst>
+    <dgm:effectClrLst/>
+    <dgm:txLinClrLst/>
+    <dgm:txFillClrLst meth="repeat">
+      <a:schemeClr val="dk1"/>
+    </dgm:txFillClrLst>
+    <dgm:txEffectClrLst/>
+  </dgm:styleLbl>
+  <dgm:styleLbl name="solidFgAcc1">
+    <dgm:fillClrLst meth="repeat">
+      <a:schemeClr val="lt1"/>
+    </dgm:fillClrLst>
+    <dgm:linClrLst meth="repeat">
+      <a:schemeClr val="accent1"/>
+    </dgm:linClrLst>
+    <dgm:effectClrLst/>
+    <dgm:txLinClrLst/>
+    <dgm:txFillClrLst meth="repeat">
+      <a:schemeClr val="dk1"/>
+    </dgm:txFillClrLst>
+    <dgm:txEffectClrLst/>
+  </dgm:styleLbl>
+  <dgm:styleLbl name="solidAlignAcc1">
+    <dgm:fillClrLst meth="repeat">
+      <a:schemeClr val="lt1"/>
+    </dgm:fillClrLst>
+    <dgm:linClrLst meth="repeat">
+      <a:schemeClr val="accent1"/>
+    </dgm:linClrLst>
+    <dgm:effectClrLst/>
+    <dgm:txLinClrLst/>
+    <dgm:txFillClrLst meth="repeat">
+      <a:schemeClr val="dk1"/>
+    </dgm:txFillClrLst>
+    <dgm:txEffectClrLst/>
+  </dgm:styleLbl>
+  <dgm:styleLbl name="solidBgAcc1">
+    <dgm:fillClrLst meth="repeat">
+      <a:schemeClr val="lt1"/>
+    </dgm:fillClrLst>
+    <dgm:linClrLst meth="repeat">
+      <a:schemeClr val="accent1"/>
+    </dgm:linClrLst>
+    <dgm:effectClrLst/>
+    <dgm:txLinClrLst/>
+    <dgm:txFillClrLst meth="repeat">
+      <a:schemeClr val="dk1"/>
+    </dgm:txFillClrLst>
+    <dgm:txEffectClrLst/>
+  </dgm:styleLbl>
+  <dgm:styleLbl name="fgAccFollowNode1">
+    <dgm:fillClrLst meth="repeat">
+      <a:schemeClr val="accent1">
+        <a:alpha val="90000"/>
+        <a:tint val="40000"/>
+      </a:schemeClr>
+    </dgm:fillClrLst>
+    <dgm:linClrLst meth="repeat">
+      <a:schemeClr val="accent1">
+        <a:alpha val="90000"/>
+        <a:tint val="40000"/>
+      </a:schemeClr>
+    </dgm:linClrLst>
+    <dgm:effectClrLst/>
+    <dgm:txLinClrLst/>
+    <dgm:txFillClrLst meth="repeat">
+      <a:schemeClr val="dk1"/>
+    </dgm:txFillClrLst>
+    <dgm:txEffectClrLst/>
+  </dgm:styleLbl>
+  <dgm:styleLbl name="alignAccFollowNode1">
+    <dgm:fillClrLst meth="repeat">
+      <a:schemeClr val="accent1">
+        <a:alpha val="90000"/>
+        <a:tint val="40000"/>
+      </a:schemeClr>
+    </dgm:fillClrLst>
+    <dgm:linClrLst meth="repeat">
+      <a:schemeClr val="accent1">
+        <a:alpha val="90000"/>
+        <a:tint val="40000"/>
+      </a:schemeClr>
+    </dgm:linClrLst>
+    <dgm:effectClrLst/>
+    <dgm:txLinClrLst/>
+    <dgm:txFillClrLst meth="repeat">
+      <a:schemeClr val="dk1"/>
+    </dgm:txFillClrLst>
+    <dgm:txEffectClrLst/>
+  </dgm:styleLbl>
+  <dgm:styleLbl name="bgAccFollowNode1">
+    <dgm:fillClrLst meth="repeat">
+      <a:schemeClr val="accent1">
+        <a:alpha val="90000"/>
+        <a:tint val="40000"/>
+      </a:schemeClr>
+    </dgm:fillClrLst>
+    <dgm:linClrLst meth="repeat">
+      <a:schemeClr val="accent1">
+        <a:alpha val="90000"/>
+        <a:tint val="40000"/>
+      </a:schemeClr>
+    </dgm:linClrLst>
+    <dgm:effectClrLst/>
+    <dgm:txLinClrLst/>
+    <dgm:txFillClrLst meth="repeat">
+      <a:schemeClr val="dk1"/>
+    </dgm:txFillClrLst>
+    <dgm:txEffectClrLst/>
+  </dgm:styleLbl>
+  <dgm:styleLbl name="fgAcc0">
+    <dgm:fillClrLst meth="repeat">
+      <a:schemeClr val="lt1">
+        <a:alpha val="90000"/>
+      </a:schemeClr>
+    </dgm:fillClrLst>
+    <dgm:linClrLst meth="repeat">
+      <a:schemeClr val="accent1"/>
+    </dgm:linClrLst>
+    <dgm:effectClrLst/>
+    <dgm:txLinClrLst/>
+    <dgm:txFillClrLst meth="repeat">
+      <a:schemeClr val="dk1"/>
+    </dgm:txFillClrLst>
+    <dgm:txEffectClrLst/>
+  </dgm:styleLbl>
+  <dgm:styleLbl name="fgAcc2">
+    <dgm:fillClrLst meth="repeat">
+      <a:schemeClr val="lt1">
+        <a:alpha val="90000"/>
+      </a:schemeClr>
+    </dgm:fillClrLst>
+    <dgm:linClrLst meth="repeat">
+      <a:schemeClr val="accent1"/>
+    </dgm:linClrLst>
+    <dgm:effectClrLst/>
+    <dgm:txLinClrLst/>
+    <dgm:txFillClrLst meth="repeat">
+      <a:schemeClr val="dk1"/>
+    </dgm:txFillClrLst>
+    <dgm:txEffectClrLst/>
+  </dgm:styleLbl>
+  <dgm:styleLbl name="fgAcc3">
+    <dgm:fillClrLst meth="repeat">
+      <a:schemeClr val="lt1">
+        <a:alpha val="90000"/>
+      </a:schemeClr>
+    </dgm:fillClrLst>
+    <dgm:linClrLst meth="repeat">
+      <a:schemeClr val="accent1"/>
+    </dgm:linClrLst>
+    <dgm:effectClrLst/>
+    <dgm:txLinClrLst/>
+    <dgm:txFillClrLst meth="repeat">
+      <a:schemeClr val="dk1"/>
+    </dgm:txFillClrLst>
+    <dgm:txEffectClrLst/>
+  </dgm:styleLbl>
+  <dgm:styleLbl name="fgAcc4">
+    <dgm:fillClrLst meth="repeat">
+      <a:schemeClr val="lt1">
+        <a:alpha val="90000"/>
+      </a:schemeClr>
+    </dgm:fillClrLst>
+    <dgm:linClrLst meth="repeat">
+      <a:schemeClr val="accent1"/>
+    </dgm:linClrLst>
+    <dgm:effectClrLst/>
+    <dgm:txLinClrLst/>
+    <dgm:txFillClrLst meth="repeat">
+      <a:schemeClr val="dk1"/>
+    </dgm:txFillClrLst>
+    <dgm:txEffectClrLst/>
+  </dgm:styleLbl>
+  <dgm:styleLbl name="bgShp">
+    <dgm:fillClrLst meth="repeat">
+      <a:schemeClr val="accent1">
+        <a:tint val="40000"/>
+      </a:schemeClr>
+    </dgm:fillClrLst>
+    <dgm:linClrLst meth="repeat">
+      <a:schemeClr val="accent1"/>
+    </dgm:linClrLst>
+    <dgm:effectClrLst/>
+    <dgm:txLinClrLst/>
+    <dgm:txFillClrLst meth="repeat">
+      <a:schemeClr val="dk1"/>
+    </dgm:txFillClrLst>
+    <dgm:txEffectClrLst/>
+  </dgm:styleLbl>
+  <dgm:styleLbl name="dkBgShp">
+    <dgm:fillClrLst meth="repeat">
+      <a:schemeClr val="accent1">
+        <a:shade val="80000"/>
+      </a:schemeClr>
+    </dgm:fillClrLst>
+    <dgm:linClrLst meth="repeat">
+      <a:schemeClr val="accent1"/>
+    </dgm:linClrLst>
+    <dgm:effectClrLst/>
+    <dgm:txLinClrLst/>
+    <dgm:txFillClrLst meth="repeat">
+      <a:schemeClr val="lt1"/>
+    </dgm:txFillClrLst>
+    <dgm:txEffectClrLst/>
+  </dgm:styleLbl>
+  <dgm:styleLbl name="trBgShp">
+    <dgm:fillClrLst meth="repeat">
+      <a:schemeClr val="accent1">
+        <a:tint val="50000"/>
+        <a:alpha val="40000"/>
+      </a:schemeClr>
+    </dgm:fillClrLst>
+    <dgm:linClrLst meth="repeat">
+      <a:schemeClr val="accent1"/>
+    </dgm:linClrLst>
+    <dgm:effectClrLst/>
+    <dgm:txLinClrLst/>
+    <dgm:txFillClrLst meth="repeat">
+      <a:schemeClr val="lt1"/>
+    </dgm:txFillClrLst>
+    <dgm:txEffectClrLst/>
+  </dgm:styleLbl>
+  <dgm:styleLbl name="fgShp">
+    <dgm:fillClrLst meth="repeat">
+      <a:schemeClr val="accent1">
+        <a:tint val="60000"/>
+      </a:schemeClr>
+    </dgm:fillClrLst>
+    <dgm:linClrLst meth="repeat">
+      <a:schemeClr val="lt1"/>
+    </dgm:linClrLst>
+    <dgm:effectClrLst/>
+    <dgm:txLinClrLst/>
+    <dgm:txFillClrLst meth="repeat">
+      <a:schemeClr val="dk1"/>
+    </dgm:txFillClrLst>
+    <dgm:txEffectClrLst/>
+  </dgm:styleLbl>
+  <dgm:styleLbl name="revTx">
+    <dgm:fillClrLst meth="repeat">
+      <a:schemeClr val="lt1">
+        <a:alpha val="0"/>
+      </a:schemeClr>
+    </dgm:fillClrLst>
+    <dgm:linClrLst meth="repeat">
+      <a:schemeClr val="dk1">
+        <a:alpha val="0"/>
+      </a:schemeClr>
+    </dgm:linClrLst>
+    <dgm:effectClrLst/>
+    <dgm:txLinClrLst/>
+    <dgm:txFillClrLst meth="repeat">
+      <a:schemeClr val="tx1"/>
+    </dgm:txFillClrLst>
+    <dgm:txEffectClrLst/>
+  </dgm:styleLbl>
+</dgm:colorsDef>
+</file>
+
+<file path=ppt/diagrams/colors9.xml><?xml version="1.0" encoding="utf-8"?>
 <dgm:colorsDef xmlns:dgm="http://schemas.openxmlformats.org/drawingml/2006/diagram" xmlns:a="http://schemas.openxmlformats.org/drawingml/2006/main" uniqueId="urn:microsoft.com/office/officeart/2005/8/colors/accent1_2">
   <dgm:title val=""/>
   <dgm:desc val=""/>
@@ -7877,15 +8626,7 @@
           </a:pPr>
           <a:r>
             <a:rPr lang="en-SG" sz="1400" b="1" dirty="0"/>
-            <a:t>Potential Extensions </a:t>
-          </a:r>
-          <a:r>
-            <a:rPr lang="en-SG" sz="1400" dirty="0"/>
-            <a:t>— </a:t>
-          </a:r>
-          <a:r>
-            <a:rPr lang="en-SG" sz="1400" b="1" dirty="0"/>
-            <a:t>Deep Models (Two-Tower) with rich features</a:t>
+            <a:t>Potential Extensions</a:t>
           </a:r>
           <a:endParaRPr lang="en-SG" sz="1400" dirty="0"/>
         </a:p>
@@ -8249,6 +8990,95 @@
         </a:p>
       </dgm:t>
     </dgm:pt>
+    <dgm:pt modelId="{B4339A46-E72C-444C-8144-19DA4BB05523}">
+      <dgm:prSet custT="1"/>
+      <dgm:spPr/>
+      <dgm:t>
+        <a:bodyPr/>
+        <a:lstStyle/>
+        <a:p>
+          <a:pPr algn="just">
+            <a:buFont typeface="Wingdings" panose="05000000000000000000" pitchFamily="2" charset="2"/>
+            <a:buChar char="Ø"/>
+          </a:pPr>
+          <a:r>
+            <a:rPr lang="en-SG" sz="1400" b="1" dirty="0"/>
+            <a:t> Deep Models (Two-Tower) with rich features</a:t>
+          </a:r>
+          <a:endParaRPr lang="en-SG" sz="1400" dirty="0"/>
+        </a:p>
+      </dgm:t>
+    </dgm:pt>
+    <dgm:pt modelId="{5F893543-BCDA-47F2-9049-568E0544FBC9}" type="parTrans" cxnId="{025EFF84-1E1A-4F56-A07F-E742985861AF}">
+      <dgm:prSet/>
+      <dgm:spPr/>
+      <dgm:t>
+        <a:bodyPr/>
+        <a:lstStyle/>
+        <a:p>
+          <a:endParaRPr lang="en-SG"/>
+        </a:p>
+      </dgm:t>
+    </dgm:pt>
+    <dgm:pt modelId="{459A3A2B-8C6A-49E1-95B3-9E0BC40D701B}" type="sibTrans" cxnId="{025EFF84-1E1A-4F56-A07F-E742985861AF}">
+      <dgm:prSet/>
+      <dgm:spPr/>
+      <dgm:t>
+        <a:bodyPr/>
+        <a:lstStyle/>
+        <a:p>
+          <a:endParaRPr lang="en-SG"/>
+        </a:p>
+      </dgm:t>
+    </dgm:pt>
+    <dgm:pt modelId="{988661ED-9442-4B8C-B355-FB4A6315776A}">
+      <dgm:prSet custT="1"/>
+      <dgm:spPr/>
+      <dgm:t>
+        <a:bodyPr/>
+        <a:lstStyle/>
+        <a:p>
+          <a:pPr algn="just">
+            <a:buFont typeface="Wingdings" panose="05000000000000000000" pitchFamily="2" charset="2"/>
+            <a:buChar char="Ø"/>
+          </a:pPr>
+          <a:r>
+            <a:rPr lang="en-SG" sz="1400" dirty="0"/>
+            <a:t> </a:t>
+          </a:r>
+          <a:r>
+            <a:rPr lang="en-SG" sz="1400" b="0" dirty="0"/>
+            <a:t>Introduce </a:t>
+          </a:r>
+          <a:r>
+            <a:rPr lang="en-SG" sz="1400" b="1" dirty="0"/>
+            <a:t>train/validation/test split with hyperparameter tuning and calibration to improve generalization</a:t>
+          </a:r>
+        </a:p>
+      </dgm:t>
+    </dgm:pt>
+    <dgm:pt modelId="{80EC42B1-6863-4DB7-942C-BA2972B645EA}" type="parTrans" cxnId="{EB6134C1-5E84-45B8-B9D7-578F3A5E8D24}">
+      <dgm:prSet/>
+      <dgm:spPr/>
+      <dgm:t>
+        <a:bodyPr/>
+        <a:lstStyle/>
+        <a:p>
+          <a:endParaRPr lang="en-SG"/>
+        </a:p>
+      </dgm:t>
+    </dgm:pt>
+    <dgm:pt modelId="{B17A6939-9322-49E7-8AEB-20E9EF5EABF3}" type="sibTrans" cxnId="{EB6134C1-5E84-45B8-B9D7-578F3A5E8D24}">
+      <dgm:prSet/>
+      <dgm:spPr/>
+      <dgm:t>
+        <a:bodyPr/>
+        <a:lstStyle/>
+        <a:p>
+          <a:endParaRPr lang="en-SG"/>
+        </a:p>
+      </dgm:t>
+    </dgm:pt>
     <dgm:pt modelId="{62164023-8E99-4F71-BD2A-791F1474B772}" type="pres">
       <dgm:prSet presAssocID="{205EE61C-438B-41C8-BE25-8DECCE34A6EA}" presName="linear" presStyleCnt="0">
         <dgm:presLayoutVars>
@@ -8331,22 +9161,26 @@
     <dgm:cxn modelId="{AEB63729-E658-4217-8E63-C5B26BBEA7EC}" srcId="{205EE61C-438B-41C8-BE25-8DECCE34A6EA}" destId="{B7900EB0-D2E2-4F0E-A239-89D4ACB40052}" srcOrd="0" destOrd="0" parTransId="{FB657700-DB71-4BD4-A9C6-4597A0B93C39}" sibTransId="{5217AD5E-50CC-43CE-92CD-CF933F83CA0E}"/>
     <dgm:cxn modelId="{5DE75038-03DC-415B-95D8-FA5567E5DCBF}" type="presOf" srcId="{1F2612E7-09B3-4BBD-9AB0-07DFA01E26FB}" destId="{167C0D67-C45F-4957-A966-A50361F3B41B}" srcOrd="0" destOrd="0" presId="urn:microsoft.com/office/officeart/2005/8/layout/list1"/>
     <dgm:cxn modelId="{63C4AB3F-8EC4-47E9-8FCB-812C7929007E}" srcId="{205EE61C-438B-41C8-BE25-8DECCE34A6EA}" destId="{1F2612E7-09B3-4BBD-9AB0-07DFA01E26FB}" srcOrd="1" destOrd="0" parTransId="{13A90BBB-E33C-450E-A635-6ECB687CBBCC}" sibTransId="{2C2E732D-2754-4839-8F39-EE623931EC1F}"/>
+    <dgm:cxn modelId="{6794E763-79FA-4379-8BDE-CE2706D76461}" type="presOf" srcId="{B4339A46-E72C-444C-8144-19DA4BB05523}" destId="{D1A5B676-22D0-4E16-BC31-0A5FEB3553E0}" srcOrd="0" destOrd="10" presId="urn:microsoft.com/office/officeart/2005/8/layout/list1"/>
     <dgm:cxn modelId="{52CCE646-09F9-4471-8D62-8C9A9C26A176}" srcId="{B7900EB0-D2E2-4F0E-A239-89D4ACB40052}" destId="{10222940-1035-49DE-8247-51866F9EB575}" srcOrd="1" destOrd="0" parTransId="{4868D19D-9335-4F13-BE56-899442AA0542}" sibTransId="{C91F4BF3-6146-4A3A-B5EC-7B0228A2D6EB}"/>
     <dgm:cxn modelId="{CA0FC34A-25CA-4331-8F70-EFA929C8B39A}" type="presOf" srcId="{7D94AA61-D162-489A-B1E8-809ED88DF5C9}" destId="{D1A5B676-22D0-4E16-BC31-0A5FEB3553E0}" srcOrd="0" destOrd="7" presId="urn:microsoft.com/office/officeart/2005/8/layout/list1"/>
     <dgm:cxn modelId="{4A50627B-88D2-44E2-8218-387781569DAA}" srcId="{B7900EB0-D2E2-4F0E-A239-89D4ACB40052}" destId="{0EA97262-3BFD-4328-B833-24F5A6C73F9D}" srcOrd="3" destOrd="0" parTransId="{D665A372-BF2B-4F0E-A44E-3A87863B4EC1}" sibTransId="{B619E1D7-7438-4CE9-811F-31B08A552FF1}"/>
     <dgm:cxn modelId="{01A40580-7DB5-4CCC-9EA3-33F697AC0964}" type="presOf" srcId="{10222940-1035-49DE-8247-51866F9EB575}" destId="{D1A5B676-22D0-4E16-BC31-0A5FEB3553E0}" srcOrd="0" destOrd="1" presId="urn:microsoft.com/office/officeart/2005/8/layout/list1"/>
     <dgm:cxn modelId="{10F6BE80-C217-4E51-B990-2C529CCBF493}" type="presOf" srcId="{205EE61C-438B-41C8-BE25-8DECCE34A6EA}" destId="{62164023-8E99-4F71-BD2A-791F1474B772}" srcOrd="0" destOrd="0" presId="urn:microsoft.com/office/officeart/2005/8/layout/list1"/>
+    <dgm:cxn modelId="{025EFF84-1E1A-4F56-A07F-E742985861AF}" srcId="{B7900EB0-D2E2-4F0E-A239-89D4ACB40052}" destId="{B4339A46-E72C-444C-8144-19DA4BB05523}" srcOrd="10" destOrd="0" parTransId="{5F893543-BCDA-47F2-9049-568E0544FBC9}" sibTransId="{459A3A2B-8C6A-49E1-95B3-9E0BC40D701B}"/>
     <dgm:cxn modelId="{F02A8593-6360-4F66-932C-EFE124F35B3C}" srcId="{1F2612E7-09B3-4BBD-9AB0-07DFA01E26FB}" destId="{A6B0FAD8-94F1-41C6-A853-A87C28C0F9E0}" srcOrd="0" destOrd="0" parTransId="{BA9D2F48-C9E7-4B5A-AEDC-3FF21A6BC5C8}" sibTransId="{0883FDAC-1010-4989-8CEB-7DB3C74553F1}"/>
     <dgm:cxn modelId="{8D898397-CBC0-4DEF-9FF8-220D614F4C9C}" srcId="{B7900EB0-D2E2-4F0E-A239-89D4ACB40052}" destId="{B8159426-5908-4543-8C4C-55B1F93D62C2}" srcOrd="0" destOrd="0" parTransId="{E080C7E5-E97B-4678-913B-37D284093FB7}" sibTransId="{46FCCB43-510B-4182-9DC5-9F41FB1FADD1}"/>
     <dgm:cxn modelId="{CFE5389E-D4DB-4DB6-9952-531CDD077B37}" type="presOf" srcId="{B7900EB0-D2E2-4F0E-A239-89D4ACB40052}" destId="{098EEF58-BE4A-4205-A3D1-3F9A5D14AD06}" srcOrd="1" destOrd="0" presId="urn:microsoft.com/office/officeart/2005/8/layout/list1"/>
     <dgm:cxn modelId="{1D5076A8-D84B-4AF5-928D-C05469A7674A}" type="presOf" srcId="{2A7F367A-C407-4A95-BF2E-25440CFC297A}" destId="{D1A5B676-22D0-4E16-BC31-0A5FEB3553E0}" srcOrd="0" destOrd="9" presId="urn:microsoft.com/office/officeart/2005/8/layout/list1"/>
     <dgm:cxn modelId="{F4304FB2-D63A-4C24-AC80-64B09939A976}" type="presOf" srcId="{0F42DE06-6853-4C89-BD29-4B7BBA841253}" destId="{2981F39D-A336-4BB9-9956-AE5D996342D5}" srcOrd="0" destOrd="2" presId="urn:microsoft.com/office/officeart/2005/8/layout/list1"/>
+    <dgm:cxn modelId="{EB6134C1-5E84-45B8-B9D7-578F3A5E8D24}" srcId="{B7900EB0-D2E2-4F0E-A239-89D4ACB40052}" destId="{988661ED-9442-4B8C-B355-FB4A6315776A}" srcOrd="11" destOrd="0" parTransId="{80EC42B1-6863-4DB7-942C-BA2972B645EA}" sibTransId="{B17A6939-9322-49E7-8AEB-20E9EF5EABF3}"/>
     <dgm:cxn modelId="{B3A363C1-D25A-4E89-87AB-507C65818710}" srcId="{1F2612E7-09B3-4BBD-9AB0-07DFA01E26FB}" destId="{0F42DE06-6853-4C89-BD29-4B7BBA841253}" srcOrd="2" destOrd="0" parTransId="{13E234CA-A940-4884-BD9F-A5DEF488A7DD}" sibTransId="{012DEA0F-A3B1-40C2-9ADC-A2780B805A19}"/>
     <dgm:cxn modelId="{E715DFCA-C8CE-4E16-8B9A-C68CED87C35C}" type="presOf" srcId="{B5601511-DFF3-4143-82C7-97D5672C2478}" destId="{D1A5B676-22D0-4E16-BC31-0A5FEB3553E0}" srcOrd="0" destOrd="2" presId="urn:microsoft.com/office/officeart/2005/8/layout/list1"/>
     <dgm:cxn modelId="{00AB52CD-CF12-4347-A2EE-EC065EA4E3E3}" type="presOf" srcId="{100E1EC3-7D70-4742-995D-C1CF01E5FF66}" destId="{D1A5B676-22D0-4E16-BC31-0A5FEB3553E0}" srcOrd="0" destOrd="8" presId="urn:microsoft.com/office/officeart/2005/8/layout/list1"/>
     <dgm:cxn modelId="{3DFD93D5-EE20-4859-B4AC-B19A402E013C}" type="presOf" srcId="{AE8ED719-FA5F-4479-B0D1-CC0184AEF5BB}" destId="{2981F39D-A336-4BB9-9956-AE5D996342D5}" srcOrd="0" destOrd="1" presId="urn:microsoft.com/office/officeart/2005/8/layout/list1"/>
     <dgm:cxn modelId="{29819FD8-B9F9-46EF-BD17-5461FDE01DC3}" type="presOf" srcId="{6C515C4F-D75D-4B78-A0A9-7B2BBF9A3A17}" destId="{D1A5B676-22D0-4E16-BC31-0A5FEB3553E0}" srcOrd="0" destOrd="5" presId="urn:microsoft.com/office/officeart/2005/8/layout/list1"/>
     <dgm:cxn modelId="{684C71DC-B0FD-4FE0-B999-948A7B68A409}" srcId="{B7900EB0-D2E2-4F0E-A239-89D4ACB40052}" destId="{100E1EC3-7D70-4742-995D-C1CF01E5FF66}" srcOrd="8" destOrd="0" parTransId="{FE98C6E2-2B37-4A37-B6FC-A1D4DB24401C}" sibTransId="{E3D68F22-5617-4473-B40E-535EBD006722}"/>
+    <dgm:cxn modelId="{467CD6DE-2313-4471-80F3-D91428873E06}" type="presOf" srcId="{988661ED-9442-4B8C-B355-FB4A6315776A}" destId="{D1A5B676-22D0-4E16-BC31-0A5FEB3553E0}" srcOrd="0" destOrd="11" presId="urn:microsoft.com/office/officeart/2005/8/layout/list1"/>
     <dgm:cxn modelId="{DC7DEBDE-7EEA-40B4-93B6-1D9D4CE23600}" srcId="{B7900EB0-D2E2-4F0E-A239-89D4ACB40052}" destId="{2A7F367A-C407-4A95-BF2E-25440CFC297A}" srcOrd="9" destOrd="0" parTransId="{10651B79-875F-4877-9020-CECC9C1F165E}" sibTransId="{EDA5C25F-207B-4586-8972-C7F7CCE5ED71}"/>
     <dgm:cxn modelId="{A2EF63E1-677C-4236-9896-A70900DE4AAD}" type="presOf" srcId="{A6B0FAD8-94F1-41C6-A853-A87C28C0F9E0}" destId="{2981F39D-A336-4BB9-9956-AE5D996342D5}" srcOrd="0" destOrd="0" presId="urn:microsoft.com/office/officeart/2005/8/layout/list1"/>
     <dgm:cxn modelId="{1D64F4EB-B2ED-4336-B3A9-AC4ACFA399CF}" srcId="{B7900EB0-D2E2-4F0E-A239-89D4ACB40052}" destId="{6C515C4F-D75D-4B78-A0A9-7B2BBF9A3A17}" srcOrd="5" destOrd="0" parTransId="{FE12F445-E472-4268-B8BD-FDC2CD151262}" sibTransId="{9BE63BA3-3E28-4854-BA77-9A5AC58C8709}"/>
@@ -10187,7 +11021,7 @@
           </a:pPr>
           <a:r>
             <a:rPr lang="en-SG" sz="1400" b="1" dirty="0"/>
-            <a:t>Prioritize personalized ranking when sufficient data is observed</a:t>
+            <a:t>Modeling robustness &amp; generalization</a:t>
           </a:r>
         </a:p>
       </dgm:t>
@@ -10313,13 +11147,8 @@
           <a:r>
             <a:rPr lang="en-SG" sz="1400" b="0" dirty="0"/>
             <a:t> Start with a simple single-stage ranking setup
- Transition to multi-stage retrieval + ranking only when scale </a:t>
+ Transition to multi-stage retrieval + ranking only when scale justifies it</a:t>
           </a:r>
-          <a:r>
-            <a:rPr lang="en-SG" sz="1400" b="0"/>
-            <a:t>justifies it</a:t>
-          </a:r>
-          <a:endParaRPr lang="en-SG" sz="1400" b="0" dirty="0"/>
         </a:p>
       </dgm:t>
     </dgm:pt>
@@ -10548,6 +11377,87 @@
         </a:p>
       </dgm:t>
     </dgm:pt>
+    <dgm:pt modelId="{6937D720-2DCE-44A8-ACE1-57064280186A}">
+      <dgm:prSet custT="1"/>
+      <dgm:spPr/>
+      <dgm:t>
+        <a:bodyPr/>
+        <a:lstStyle/>
+        <a:p>
+          <a:pPr>
+            <a:buFont typeface="Wingdings" panose="05000000000000000000" pitchFamily="2" charset="2"/>
+            <a:buNone/>
+          </a:pPr>
+          <a:r>
+            <a:rPr lang="en-SG" sz="1400" b="1"/>
+            <a:t>Prioritize personalized ranking when sufficient data is observed</a:t>
+          </a:r>
+          <a:endParaRPr lang="en-SG" sz="1400" b="1" dirty="0"/>
+        </a:p>
+      </dgm:t>
+    </dgm:pt>
+    <dgm:pt modelId="{5E6B6DC4-1FB1-49A4-880B-287545157D07}" type="parTrans" cxnId="{AF3F18EA-F912-4416-BDCD-3971C5023534}">
+      <dgm:prSet/>
+      <dgm:spPr/>
+      <dgm:t>
+        <a:bodyPr/>
+        <a:lstStyle/>
+        <a:p>
+          <a:endParaRPr lang="en-SG"/>
+        </a:p>
+      </dgm:t>
+    </dgm:pt>
+    <dgm:pt modelId="{B6823A25-2202-44D5-B956-E330B2C309D1}" type="sibTrans" cxnId="{AF3F18EA-F912-4416-BDCD-3971C5023534}">
+      <dgm:prSet/>
+      <dgm:spPr/>
+      <dgm:t>
+        <a:bodyPr/>
+        <a:lstStyle/>
+        <a:p>
+          <a:endParaRPr lang="en-SG"/>
+        </a:p>
+      </dgm:t>
+    </dgm:pt>
+    <dgm:pt modelId="{6D66A3A7-0B33-485E-A5F8-C84599619975}">
+      <dgm:prSet custT="1"/>
+      <dgm:spPr/>
+      <dgm:t>
+        <a:bodyPr/>
+        <a:lstStyle/>
+        <a:p>
+          <a:pPr>
+            <a:buFont typeface="Wingdings" panose="05000000000000000000" pitchFamily="2" charset="2"/>
+            <a:buChar char="Ø"/>
+          </a:pPr>
+          <a:r>
+            <a:rPr lang="en-SG" sz="1400" b="0" dirty="0"/>
+            <a:t> Introduce train/validation/test split with hyperparameter tuning and calibration to improve generalization</a:t>
+          </a:r>
+        </a:p>
+      </dgm:t>
+    </dgm:pt>
+    <dgm:pt modelId="{79D53AFA-F5B3-4421-822C-6560FA3543B2}" type="parTrans" cxnId="{81D29D7B-E23B-4111-A790-0918DB523363}">
+      <dgm:prSet/>
+      <dgm:spPr/>
+      <dgm:t>
+        <a:bodyPr/>
+        <a:lstStyle/>
+        <a:p>
+          <a:endParaRPr lang="en-SG"/>
+        </a:p>
+      </dgm:t>
+    </dgm:pt>
+    <dgm:pt modelId="{69FA4947-1770-46EA-9922-19A1234AF826}" type="sibTrans" cxnId="{81D29D7B-E23B-4111-A790-0918DB523363}">
+      <dgm:prSet/>
+      <dgm:spPr/>
+      <dgm:t>
+        <a:bodyPr/>
+        <a:lstStyle/>
+        <a:p>
+          <a:endParaRPr lang="en-SG"/>
+        </a:p>
+      </dgm:t>
+    </dgm:pt>
     <dgm:pt modelId="{E042474C-A0A5-40D5-9B17-01117CC802AB}" type="pres">
       <dgm:prSet presAssocID="{349DE399-23D9-49D2-9DC7-5A910169EAD0}" presName="linear" presStyleCnt="0">
         <dgm:presLayoutVars>
@@ -10563,11 +11473,11 @@
       <dgm:spPr/>
     </dgm:pt>
     <dgm:pt modelId="{67677099-A951-42DB-A865-C04E4099B0BB}" type="pres">
-      <dgm:prSet presAssocID="{E15FECA5-30D6-4625-B47A-8153420E66D8}" presName="parentLeftMargin" presStyleLbl="node1" presStyleIdx="0" presStyleCnt="4"/>
+      <dgm:prSet presAssocID="{E15FECA5-30D6-4625-B47A-8153420E66D8}" presName="parentLeftMargin" presStyleLbl="node1" presStyleIdx="0" presStyleCnt="5"/>
       <dgm:spPr/>
     </dgm:pt>
     <dgm:pt modelId="{73D61383-A059-4CF8-9A37-12E533FCFC22}" type="pres">
-      <dgm:prSet presAssocID="{E15FECA5-30D6-4625-B47A-8153420E66D8}" presName="parentText" presStyleLbl="node1" presStyleIdx="0" presStyleCnt="4">
+      <dgm:prSet presAssocID="{E15FECA5-30D6-4625-B47A-8153420E66D8}" presName="parentText" presStyleLbl="node1" presStyleIdx="0" presStyleCnt="5">
         <dgm:presLayoutVars>
           <dgm:chMax val="0"/>
           <dgm:bulletEnabled val="1"/>
@@ -10580,7 +11490,7 @@
       <dgm:spPr/>
     </dgm:pt>
     <dgm:pt modelId="{81AB0DB0-4359-4ABA-B7E8-9D326E119CD8}" type="pres">
-      <dgm:prSet presAssocID="{E15FECA5-30D6-4625-B47A-8153420E66D8}" presName="childText" presStyleLbl="conFgAcc1" presStyleIdx="0" presStyleCnt="4">
+      <dgm:prSet presAssocID="{E15FECA5-30D6-4625-B47A-8153420E66D8}" presName="childText" presStyleLbl="conFgAcc1" presStyleIdx="0" presStyleCnt="5">
         <dgm:presLayoutVars>
           <dgm:bulletEnabled val="1"/>
         </dgm:presLayoutVars>
@@ -10591,16 +11501,16 @@
       <dgm:prSet presAssocID="{305EF0D4-61EE-4A6D-98E3-85819940A7C6}" presName="spaceBetweenRectangles" presStyleCnt="0"/>
       <dgm:spPr/>
     </dgm:pt>
-    <dgm:pt modelId="{3DBAE7C1-7E57-4E04-AE43-135D2BB6378C}" type="pres">
-      <dgm:prSet presAssocID="{DC5BB092-71E0-400B-BCB2-C56569729D80}" presName="parentLin" presStyleCnt="0"/>
-      <dgm:spPr/>
-    </dgm:pt>
-    <dgm:pt modelId="{435FD845-E0DA-45C2-99AB-681F807FC961}" type="pres">
-      <dgm:prSet presAssocID="{DC5BB092-71E0-400B-BCB2-C56569729D80}" presName="parentLeftMargin" presStyleLbl="node1" presStyleIdx="0" presStyleCnt="4"/>
-      <dgm:spPr/>
-    </dgm:pt>
-    <dgm:pt modelId="{7BA4BE36-552F-4B25-BF78-14B70D0E15A7}" type="pres">
-      <dgm:prSet presAssocID="{DC5BB092-71E0-400B-BCB2-C56569729D80}" presName="parentText" presStyleLbl="node1" presStyleIdx="1" presStyleCnt="4">
+    <dgm:pt modelId="{585D6820-41E2-44D8-B3CE-0C89AA767FC6}" type="pres">
+      <dgm:prSet presAssocID="{6937D720-2DCE-44A8-ACE1-57064280186A}" presName="parentLin" presStyleCnt="0"/>
+      <dgm:spPr/>
+    </dgm:pt>
+    <dgm:pt modelId="{2D521557-F57A-46EB-AFFE-DC5DC6543760}" type="pres">
+      <dgm:prSet presAssocID="{6937D720-2DCE-44A8-ACE1-57064280186A}" presName="parentLeftMargin" presStyleLbl="node1" presStyleIdx="0" presStyleCnt="5"/>
+      <dgm:spPr/>
+    </dgm:pt>
+    <dgm:pt modelId="{6E6F8F08-80B1-4ED5-9535-177F20B67890}" type="pres">
+      <dgm:prSet presAssocID="{6937D720-2DCE-44A8-ACE1-57064280186A}" presName="parentText" presStyleLbl="node1" presStyleIdx="1" presStyleCnt="5">
         <dgm:presLayoutVars>
           <dgm:chMax val="0"/>
           <dgm:bulletEnabled val="1"/>
@@ -10608,32 +11518,32 @@
       </dgm:prSet>
       <dgm:spPr/>
     </dgm:pt>
-    <dgm:pt modelId="{44517AE8-CCB2-4E31-865B-B9A80A7AA389}" type="pres">
-      <dgm:prSet presAssocID="{DC5BB092-71E0-400B-BCB2-C56569729D80}" presName="negativeSpace" presStyleCnt="0"/>
-      <dgm:spPr/>
-    </dgm:pt>
-    <dgm:pt modelId="{7917C87B-6C84-46AC-A0CC-40146E8D0C31}" type="pres">
-      <dgm:prSet presAssocID="{DC5BB092-71E0-400B-BCB2-C56569729D80}" presName="childText" presStyleLbl="conFgAcc1" presStyleIdx="1" presStyleCnt="4">
+    <dgm:pt modelId="{473AA82E-17AB-4859-89A4-06768D586EA0}" type="pres">
+      <dgm:prSet presAssocID="{6937D720-2DCE-44A8-ACE1-57064280186A}" presName="negativeSpace" presStyleCnt="0"/>
+      <dgm:spPr/>
+    </dgm:pt>
+    <dgm:pt modelId="{323AA25F-4521-439B-ABE8-76D0915CA15E}" type="pres">
+      <dgm:prSet presAssocID="{6937D720-2DCE-44A8-ACE1-57064280186A}" presName="childText" presStyleLbl="conFgAcc1" presStyleIdx="1" presStyleCnt="5">
         <dgm:presLayoutVars>
           <dgm:bulletEnabled val="1"/>
         </dgm:presLayoutVars>
       </dgm:prSet>
       <dgm:spPr/>
     </dgm:pt>
-    <dgm:pt modelId="{1D1D55CD-2025-44E1-813B-C15C114DF9C1}" type="pres">
-      <dgm:prSet presAssocID="{7B8A2AFC-89BF-4E18-A406-C0317E42B27B}" presName="spaceBetweenRectangles" presStyleCnt="0"/>
-      <dgm:spPr/>
-    </dgm:pt>
-    <dgm:pt modelId="{8773EE68-12BC-4B69-8C93-659C790897F4}" type="pres">
-      <dgm:prSet presAssocID="{DB96552C-2D53-49D2-8D90-E76A85981323}" presName="parentLin" presStyleCnt="0"/>
-      <dgm:spPr/>
-    </dgm:pt>
-    <dgm:pt modelId="{98379ACE-A084-41B6-B3B2-4E7CEABCB17E}" type="pres">
-      <dgm:prSet presAssocID="{DB96552C-2D53-49D2-8D90-E76A85981323}" presName="parentLeftMargin" presStyleLbl="node1" presStyleIdx="1" presStyleCnt="4"/>
-      <dgm:spPr/>
-    </dgm:pt>
-    <dgm:pt modelId="{BB4727C1-D41B-423B-93AE-9DC77DA899D5}" type="pres">
-      <dgm:prSet presAssocID="{DB96552C-2D53-49D2-8D90-E76A85981323}" presName="parentText" presStyleLbl="node1" presStyleIdx="2" presStyleCnt="4">
+    <dgm:pt modelId="{D7E96991-323A-4655-858F-70653A5C157B}" type="pres">
+      <dgm:prSet presAssocID="{B6823A25-2202-44D5-B956-E330B2C309D1}" presName="spaceBetweenRectangles" presStyleCnt="0"/>
+      <dgm:spPr/>
+    </dgm:pt>
+    <dgm:pt modelId="{3DBAE7C1-7E57-4E04-AE43-135D2BB6378C}" type="pres">
+      <dgm:prSet presAssocID="{DC5BB092-71E0-400B-BCB2-C56569729D80}" presName="parentLin" presStyleCnt="0"/>
+      <dgm:spPr/>
+    </dgm:pt>
+    <dgm:pt modelId="{435FD845-E0DA-45C2-99AB-681F807FC961}" type="pres">
+      <dgm:prSet presAssocID="{DC5BB092-71E0-400B-BCB2-C56569729D80}" presName="parentLeftMargin" presStyleLbl="node1" presStyleIdx="1" presStyleCnt="5"/>
+      <dgm:spPr/>
+    </dgm:pt>
+    <dgm:pt modelId="{7BA4BE36-552F-4B25-BF78-14B70D0E15A7}" type="pres">
+      <dgm:prSet presAssocID="{DC5BB092-71E0-400B-BCB2-C56569729D80}" presName="parentText" presStyleLbl="node1" presStyleIdx="2" presStyleCnt="5">
         <dgm:presLayoutVars>
           <dgm:chMax val="0"/>
           <dgm:bulletEnabled val="1"/>
@@ -10641,32 +11551,32 @@
       </dgm:prSet>
       <dgm:spPr/>
     </dgm:pt>
-    <dgm:pt modelId="{B86E05FE-7386-4795-8530-4F6A0FE04BC8}" type="pres">
-      <dgm:prSet presAssocID="{DB96552C-2D53-49D2-8D90-E76A85981323}" presName="negativeSpace" presStyleCnt="0"/>
-      <dgm:spPr/>
-    </dgm:pt>
-    <dgm:pt modelId="{1CAA899B-F6E6-4429-82FC-1AAFA4443513}" type="pres">
-      <dgm:prSet presAssocID="{DB96552C-2D53-49D2-8D90-E76A85981323}" presName="childText" presStyleLbl="conFgAcc1" presStyleIdx="2" presStyleCnt="4">
+    <dgm:pt modelId="{44517AE8-CCB2-4E31-865B-B9A80A7AA389}" type="pres">
+      <dgm:prSet presAssocID="{DC5BB092-71E0-400B-BCB2-C56569729D80}" presName="negativeSpace" presStyleCnt="0"/>
+      <dgm:spPr/>
+    </dgm:pt>
+    <dgm:pt modelId="{7917C87B-6C84-46AC-A0CC-40146E8D0C31}" type="pres">
+      <dgm:prSet presAssocID="{DC5BB092-71E0-400B-BCB2-C56569729D80}" presName="childText" presStyleLbl="conFgAcc1" presStyleIdx="2" presStyleCnt="5">
         <dgm:presLayoutVars>
           <dgm:bulletEnabled val="1"/>
         </dgm:presLayoutVars>
       </dgm:prSet>
       <dgm:spPr/>
     </dgm:pt>
-    <dgm:pt modelId="{4FD1A70F-23A9-41D7-A717-400E59C82B89}" type="pres">
-      <dgm:prSet presAssocID="{DD4D4728-97A6-4C2F-86EF-C012E2D24019}" presName="spaceBetweenRectangles" presStyleCnt="0"/>
-      <dgm:spPr/>
-    </dgm:pt>
-    <dgm:pt modelId="{7307C539-7BE1-4D3E-9F60-73B1657D2DE3}" type="pres">
-      <dgm:prSet presAssocID="{1C8723D1-5DB9-4581-BC75-9982AB696638}" presName="parentLin" presStyleCnt="0"/>
-      <dgm:spPr/>
-    </dgm:pt>
-    <dgm:pt modelId="{D57C1DB4-B9FC-4EED-841D-6C25049996BE}" type="pres">
-      <dgm:prSet presAssocID="{1C8723D1-5DB9-4581-BC75-9982AB696638}" presName="parentLeftMargin" presStyleLbl="node1" presStyleIdx="2" presStyleCnt="4"/>
-      <dgm:spPr/>
-    </dgm:pt>
-    <dgm:pt modelId="{BE6FFCE4-D821-4667-8F34-735CD66E39FD}" type="pres">
-      <dgm:prSet presAssocID="{1C8723D1-5DB9-4581-BC75-9982AB696638}" presName="parentText" presStyleLbl="node1" presStyleIdx="3" presStyleCnt="4">
+    <dgm:pt modelId="{1D1D55CD-2025-44E1-813B-C15C114DF9C1}" type="pres">
+      <dgm:prSet presAssocID="{7B8A2AFC-89BF-4E18-A406-C0317E42B27B}" presName="spaceBetweenRectangles" presStyleCnt="0"/>
+      <dgm:spPr/>
+    </dgm:pt>
+    <dgm:pt modelId="{8773EE68-12BC-4B69-8C93-659C790897F4}" type="pres">
+      <dgm:prSet presAssocID="{DB96552C-2D53-49D2-8D90-E76A85981323}" presName="parentLin" presStyleCnt="0"/>
+      <dgm:spPr/>
+    </dgm:pt>
+    <dgm:pt modelId="{98379ACE-A084-41B6-B3B2-4E7CEABCB17E}" type="pres">
+      <dgm:prSet presAssocID="{DB96552C-2D53-49D2-8D90-E76A85981323}" presName="parentLeftMargin" presStyleLbl="node1" presStyleIdx="2" presStyleCnt="5"/>
+      <dgm:spPr/>
+    </dgm:pt>
+    <dgm:pt modelId="{BB4727C1-D41B-423B-93AE-9DC77DA899D5}" type="pres">
+      <dgm:prSet presAssocID="{DB96552C-2D53-49D2-8D90-E76A85981323}" presName="parentText" presStyleLbl="node1" presStyleIdx="3" presStyleCnt="5">
         <dgm:presLayoutVars>
           <dgm:chMax val="0"/>
           <dgm:bulletEnabled val="1"/>
@@ -10674,66 +11584,436 @@
       </dgm:prSet>
       <dgm:spPr/>
     </dgm:pt>
-    <dgm:pt modelId="{0B6FF0A6-589B-46F7-873F-D987E65B5239}" type="pres">
-      <dgm:prSet presAssocID="{1C8723D1-5DB9-4581-BC75-9982AB696638}" presName="negativeSpace" presStyleCnt="0"/>
-      <dgm:spPr/>
-    </dgm:pt>
-    <dgm:pt modelId="{7A89284A-AC1B-4D70-9B1C-ADAF07F66E34}" type="pres">
-      <dgm:prSet presAssocID="{1C8723D1-5DB9-4581-BC75-9982AB696638}" presName="childText" presStyleLbl="conFgAcc1" presStyleIdx="3" presStyleCnt="4" custLinFactNeighborX="0" custLinFactNeighborY="-195">
+    <dgm:pt modelId="{B86E05FE-7386-4795-8530-4F6A0FE04BC8}" type="pres">
+      <dgm:prSet presAssocID="{DB96552C-2D53-49D2-8D90-E76A85981323}" presName="negativeSpace" presStyleCnt="0"/>
+      <dgm:spPr/>
+    </dgm:pt>
+    <dgm:pt modelId="{1CAA899B-F6E6-4429-82FC-1AAFA4443513}" type="pres">
+      <dgm:prSet presAssocID="{DB96552C-2D53-49D2-8D90-E76A85981323}" presName="childText" presStyleLbl="conFgAcc1" presStyleIdx="3" presStyleCnt="5">
         <dgm:presLayoutVars>
           <dgm:bulletEnabled val="1"/>
         </dgm:presLayoutVars>
       </dgm:prSet>
       <dgm:spPr/>
     </dgm:pt>
+    <dgm:pt modelId="{4FD1A70F-23A9-41D7-A717-400E59C82B89}" type="pres">
+      <dgm:prSet presAssocID="{DD4D4728-97A6-4C2F-86EF-C012E2D24019}" presName="spaceBetweenRectangles" presStyleCnt="0"/>
+      <dgm:spPr/>
+    </dgm:pt>
+    <dgm:pt modelId="{7307C539-7BE1-4D3E-9F60-73B1657D2DE3}" type="pres">
+      <dgm:prSet presAssocID="{1C8723D1-5DB9-4581-BC75-9982AB696638}" presName="parentLin" presStyleCnt="0"/>
+      <dgm:spPr/>
+    </dgm:pt>
+    <dgm:pt modelId="{D57C1DB4-B9FC-4EED-841D-6C25049996BE}" type="pres">
+      <dgm:prSet presAssocID="{1C8723D1-5DB9-4581-BC75-9982AB696638}" presName="parentLeftMargin" presStyleLbl="node1" presStyleIdx="3" presStyleCnt="5"/>
+      <dgm:spPr/>
+    </dgm:pt>
+    <dgm:pt modelId="{BE6FFCE4-D821-4667-8F34-735CD66E39FD}" type="pres">
+      <dgm:prSet presAssocID="{1C8723D1-5DB9-4581-BC75-9982AB696638}" presName="parentText" presStyleLbl="node1" presStyleIdx="4" presStyleCnt="5">
+        <dgm:presLayoutVars>
+          <dgm:chMax val="0"/>
+          <dgm:bulletEnabled val="1"/>
+        </dgm:presLayoutVars>
+      </dgm:prSet>
+      <dgm:spPr/>
+    </dgm:pt>
+    <dgm:pt modelId="{0B6FF0A6-589B-46F7-873F-D987E65B5239}" type="pres">
+      <dgm:prSet presAssocID="{1C8723D1-5DB9-4581-BC75-9982AB696638}" presName="negativeSpace" presStyleCnt="0"/>
+      <dgm:spPr/>
+    </dgm:pt>
+    <dgm:pt modelId="{7A89284A-AC1B-4D70-9B1C-ADAF07F66E34}" type="pres">
+      <dgm:prSet presAssocID="{1C8723D1-5DB9-4581-BC75-9982AB696638}" presName="childText" presStyleLbl="conFgAcc1" presStyleIdx="4" presStyleCnt="5" custLinFactNeighborX="0" custLinFactNeighborY="-195">
+        <dgm:presLayoutVars>
+          <dgm:bulletEnabled val="1"/>
+        </dgm:presLayoutVars>
+      </dgm:prSet>
+      <dgm:spPr/>
+    </dgm:pt>
   </dgm:ptLst>
   <dgm:cxnLst>
-    <dgm:cxn modelId="{03B2C20C-FBB4-4B54-8F90-E26A8502C39B}" type="presOf" srcId="{E15FECA5-30D6-4625-B47A-8153420E66D8}" destId="{73D61383-A059-4CF8-9A37-12E533FCFC22}" srcOrd="1" destOrd="0" presId="urn:microsoft.com/office/officeart/2005/8/layout/list1"/>
+    <dgm:cxn modelId="{EF8AD419-15B8-416C-924A-99250328F840}" srcId="{349DE399-23D9-49D2-9DC7-5A910169EAD0}" destId="{DC5BB092-71E0-400B-BCB2-C56569729D80}" srcOrd="2" destOrd="0" parTransId="{CB92CA03-3561-429F-A4D3-673A2173CEAE}" sibTransId="{7B8A2AFC-89BF-4E18-A406-C0317E42B27B}"/>
+    <dgm:cxn modelId="{7E832322-EC53-49BA-8CF9-B4704E959E59}" srcId="{349DE399-23D9-49D2-9DC7-5A910169EAD0}" destId="{DB96552C-2D53-49D2-8D90-E76A85981323}" srcOrd="3" destOrd="0" parTransId="{EFCCCCD6-962C-427A-B872-2550F0522C47}" sibTransId="{DD4D4728-97A6-4C2F-86EF-C012E2D24019}"/>
+    <dgm:cxn modelId="{0D1B3F23-C9D8-4056-8ABF-C5CC73E0860F}" type="presOf" srcId="{1C8723D1-5DB9-4581-BC75-9982AB696638}" destId="{BE6FFCE4-D821-4667-8F34-735CD66E39FD}" srcOrd="1" destOrd="0" presId="urn:microsoft.com/office/officeart/2005/8/layout/list1"/>
+    <dgm:cxn modelId="{DDCD1728-7101-454B-8739-1358BA882553}" type="presOf" srcId="{82F82B97-9A2B-482D-9198-E5AF696C82EB}" destId="{1CAA899B-F6E6-4429-82FC-1AAFA4443513}" srcOrd="0" destOrd="0" presId="urn:microsoft.com/office/officeart/2005/8/layout/list1"/>
+    <dgm:cxn modelId="{68353B32-C1D6-4A9E-9D0F-F683A7FE3006}" type="presOf" srcId="{6D66A3A7-0B33-485E-A5F8-C84599619975}" destId="{81AB0DB0-4359-4ABA-B7E8-9D326E119CD8}" srcOrd="0" destOrd="0" presId="urn:microsoft.com/office/officeart/2005/8/layout/list1"/>
+    <dgm:cxn modelId="{36428838-EF42-4B83-B49C-DE3FDD3CE6A8}" type="presOf" srcId="{DB96552C-2D53-49D2-8D90-E76A85981323}" destId="{98379ACE-A084-41B6-B3B2-4E7CEABCB17E}" srcOrd="0" destOrd="0" presId="urn:microsoft.com/office/officeart/2005/8/layout/list1"/>
+    <dgm:cxn modelId="{444FA162-949F-4632-BF58-F6FAC33C375A}" type="presOf" srcId="{DB96552C-2D53-49D2-8D90-E76A85981323}" destId="{BB4727C1-D41B-423B-93AE-9DC77DA899D5}" srcOrd="1" destOrd="0" presId="urn:microsoft.com/office/officeart/2005/8/layout/list1"/>
+    <dgm:cxn modelId="{6EC9A948-13B5-4223-ADF8-C40BA60B94BE}" type="presOf" srcId="{30DB91E6-37CC-4B0B-8CF6-B211AF361B3C}" destId="{7A89284A-AC1B-4D70-9B1C-ADAF07F66E34}" srcOrd="0" destOrd="0" presId="urn:microsoft.com/office/officeart/2005/8/layout/list1"/>
+    <dgm:cxn modelId="{1288DF4F-2F68-47D8-89C5-895C74177033}" srcId="{1C8723D1-5DB9-4581-BC75-9982AB696638}" destId="{10922B28-E9A1-48ED-9E5F-6AB236DBDC8D}" srcOrd="1" destOrd="0" parTransId="{8315A896-C0AC-4C55-AA39-C9C27689E450}" sibTransId="{167CCE70-34F6-4A44-9C86-57714B91D831}"/>
+    <dgm:cxn modelId="{B68F4A73-4717-4C1B-A04F-2E9816FF2A5B}" srcId="{6937D720-2DCE-44A8-ACE1-57064280186A}" destId="{8EB33104-D9F3-4D53-A914-670AA1E45747}" srcOrd="0" destOrd="0" parTransId="{15B5FE86-97E0-4CF2-91F4-EB4EA846C22C}" sibTransId="{57154F96-E9CC-4E39-ABCD-A60F9594EC48}"/>
+    <dgm:cxn modelId="{C0127078-1F33-48E6-9E81-894B99886FF0}" srcId="{DB96552C-2D53-49D2-8D90-E76A85981323}" destId="{82F82B97-9A2B-482D-9198-E5AF696C82EB}" srcOrd="0" destOrd="0" parTransId="{A2C6E84F-BCF5-4293-8E31-4F49F972F957}" sibTransId="{BCE20A6F-0D33-47D0-9EC2-A7E958324E80}"/>
+    <dgm:cxn modelId="{9816B278-46A8-4637-9BD5-911650555D9B}" type="presOf" srcId="{DC5BB092-71E0-400B-BCB2-C56569729D80}" destId="{7BA4BE36-552F-4B25-BF78-14B70D0E15A7}" srcOrd="1" destOrd="0" presId="urn:microsoft.com/office/officeart/2005/8/layout/list1"/>
+    <dgm:cxn modelId="{81D29D7B-E23B-4111-A790-0918DB523363}" srcId="{E15FECA5-30D6-4625-B47A-8153420E66D8}" destId="{6D66A3A7-0B33-485E-A5F8-C84599619975}" srcOrd="0" destOrd="0" parTransId="{79D53AFA-F5B3-4421-822C-6560FA3543B2}" sibTransId="{69FA4947-1770-46EA-9922-19A1234AF826}"/>
+    <dgm:cxn modelId="{E28C7394-5598-4C0C-B583-A784824C76F4}" type="presOf" srcId="{6937D720-2DCE-44A8-ACE1-57064280186A}" destId="{2D521557-F57A-46EB-AFFE-DC5DC6543760}" srcOrd="0" destOrd="0" presId="urn:microsoft.com/office/officeart/2005/8/layout/list1"/>
+    <dgm:cxn modelId="{FF26A3A6-AE70-4971-954C-EE1B3B07E1E4}" type="presOf" srcId="{E15FECA5-30D6-4625-B47A-8153420E66D8}" destId="{73D61383-A059-4CF8-9A37-12E533FCFC22}" srcOrd="1" destOrd="0" presId="urn:microsoft.com/office/officeart/2005/8/layout/list1"/>
+    <dgm:cxn modelId="{61854DA8-B0F8-41FB-B65B-6DD305ADA0CB}" type="presOf" srcId="{6937D720-2DCE-44A8-ACE1-57064280186A}" destId="{6E6F8F08-80B1-4ED5-9535-177F20B67890}" srcOrd="1" destOrd="0" presId="urn:microsoft.com/office/officeart/2005/8/layout/list1"/>
+    <dgm:cxn modelId="{3FC51DAD-A195-4AFB-A1BE-69D00E6FD393}" type="presOf" srcId="{E15FECA5-30D6-4625-B47A-8153420E66D8}" destId="{67677099-A951-42DB-A865-C04E4099B0BB}" srcOrd="0" destOrd="0" presId="urn:microsoft.com/office/officeart/2005/8/layout/list1"/>
+    <dgm:cxn modelId="{1949C1AD-3D1B-4F43-8624-009CDD3C7D5A}" srcId="{1C8723D1-5DB9-4581-BC75-9982AB696638}" destId="{30DB91E6-37CC-4B0B-8CF6-B211AF361B3C}" srcOrd="0" destOrd="0" parTransId="{1C1235CC-BBFC-40FE-9F2C-81FB8B860B93}" sibTransId="{F7255E64-CF54-4DF1-BD98-694B20A7CD94}"/>
+    <dgm:cxn modelId="{AB5B1EC1-3632-45DD-BEE2-D8DCCDCA2FDD}" srcId="{DC5BB092-71E0-400B-BCB2-C56569729D80}" destId="{DD31C33E-98CA-4AD6-BBA0-5ADDD2F67EC0}" srcOrd="0" destOrd="0" parTransId="{72256291-80F3-4E49-8A15-E6BF18D8A6AB}" sibTransId="{F8AB250B-A5D6-46E4-B19D-3ADD9E47F995}"/>
+    <dgm:cxn modelId="{B62F91C5-0114-4E25-846C-4A69DEB857A8}" type="presOf" srcId="{1C8723D1-5DB9-4581-BC75-9982AB696638}" destId="{D57C1DB4-B9FC-4EED-841D-6C25049996BE}" srcOrd="0" destOrd="0" presId="urn:microsoft.com/office/officeart/2005/8/layout/list1"/>
+    <dgm:cxn modelId="{BF6FE7C6-F8A7-45E9-9F59-BB1DA09EE8A7}" srcId="{349DE399-23D9-49D2-9DC7-5A910169EAD0}" destId="{E15FECA5-30D6-4625-B47A-8153420E66D8}" srcOrd="0" destOrd="0" parTransId="{F14BE1AB-D653-4B64-980B-86D582E904C4}" sibTransId="{305EF0D4-61EE-4A6D-98E3-85819940A7C6}"/>
+    <dgm:cxn modelId="{1A12D8D1-1BF6-4494-8003-293075975A0B}" type="presOf" srcId="{10922B28-E9A1-48ED-9E5F-6AB236DBDC8D}" destId="{7A89284A-AC1B-4D70-9B1C-ADAF07F66E34}" srcOrd="0" destOrd="1" presId="urn:microsoft.com/office/officeart/2005/8/layout/list1"/>
+    <dgm:cxn modelId="{65952DDB-46C8-4DE6-9CF2-AAD681FDE744}" srcId="{349DE399-23D9-49D2-9DC7-5A910169EAD0}" destId="{1C8723D1-5DB9-4581-BC75-9982AB696638}" srcOrd="4" destOrd="0" parTransId="{2C07BA3E-F8EC-4D3D-AC37-73D93CC1C605}" sibTransId="{7574D0EC-2572-47B2-8CBF-C5B46788A613}"/>
+    <dgm:cxn modelId="{830422E1-F417-437E-A47D-0D7CEA75E59C}" type="presOf" srcId="{8EB33104-D9F3-4D53-A914-670AA1E45747}" destId="{323AA25F-4521-439B-ABE8-76D0915CA15E}" srcOrd="0" destOrd="0" presId="urn:microsoft.com/office/officeart/2005/8/layout/list1"/>
+    <dgm:cxn modelId="{E5D1ABE3-9B55-4606-9619-8CDEA2EFFCF6}" type="presOf" srcId="{349DE399-23D9-49D2-9DC7-5A910169EAD0}" destId="{E042474C-A0A5-40D5-9B17-01117CC802AB}" srcOrd="0" destOrd="0" presId="urn:microsoft.com/office/officeart/2005/8/layout/list1"/>
+    <dgm:cxn modelId="{957B20E6-1448-4E2A-A2AD-31EAB1685856}" type="presOf" srcId="{DD31C33E-98CA-4AD6-BBA0-5ADDD2F67EC0}" destId="{7917C87B-6C84-46AC-A0CC-40146E8D0C31}" srcOrd="0" destOrd="0" presId="urn:microsoft.com/office/officeart/2005/8/layout/list1"/>
+    <dgm:cxn modelId="{17DC34E6-AE1E-4859-9915-10B54CF78ABD}" type="presOf" srcId="{DC5BB092-71E0-400B-BCB2-C56569729D80}" destId="{435FD845-E0DA-45C2-99AB-681F807FC961}" srcOrd="0" destOrd="0" presId="urn:microsoft.com/office/officeart/2005/8/layout/list1"/>
+    <dgm:cxn modelId="{AF3F18EA-F912-4416-BDCD-3971C5023534}" srcId="{349DE399-23D9-49D2-9DC7-5A910169EAD0}" destId="{6937D720-2DCE-44A8-ACE1-57064280186A}" srcOrd="1" destOrd="0" parTransId="{5E6B6DC4-1FB1-49A4-880B-287545157D07}" sibTransId="{B6823A25-2202-44D5-B956-E330B2C309D1}"/>
+    <dgm:cxn modelId="{5D987DC8-2407-4159-89BA-A764330CE01A}" type="presParOf" srcId="{E042474C-A0A5-40D5-9B17-01117CC802AB}" destId="{C01E9492-803A-4D1D-B092-0F5490EFE438}" srcOrd="0" destOrd="0" presId="urn:microsoft.com/office/officeart/2005/8/layout/list1"/>
+    <dgm:cxn modelId="{498BD3D9-5228-44B8-91C5-7D7866CBAF81}" type="presParOf" srcId="{C01E9492-803A-4D1D-B092-0F5490EFE438}" destId="{67677099-A951-42DB-A865-C04E4099B0BB}" srcOrd="0" destOrd="0" presId="urn:microsoft.com/office/officeart/2005/8/layout/list1"/>
+    <dgm:cxn modelId="{A4630649-9A31-45E2-BB92-036FB494972E}" type="presParOf" srcId="{C01E9492-803A-4D1D-B092-0F5490EFE438}" destId="{73D61383-A059-4CF8-9A37-12E533FCFC22}" srcOrd="1" destOrd="0" presId="urn:microsoft.com/office/officeart/2005/8/layout/list1"/>
+    <dgm:cxn modelId="{E06F6274-F0EC-49BA-A8DE-2A7D7E0B867A}" type="presParOf" srcId="{E042474C-A0A5-40D5-9B17-01117CC802AB}" destId="{2832EB8D-607B-4AC1-9DD6-D1A5BC95D550}" srcOrd="1" destOrd="0" presId="urn:microsoft.com/office/officeart/2005/8/layout/list1"/>
+    <dgm:cxn modelId="{C93DED32-FA3E-486A-BA17-213B364A0B08}" type="presParOf" srcId="{E042474C-A0A5-40D5-9B17-01117CC802AB}" destId="{81AB0DB0-4359-4ABA-B7E8-9D326E119CD8}" srcOrd="2" destOrd="0" presId="urn:microsoft.com/office/officeart/2005/8/layout/list1"/>
+    <dgm:cxn modelId="{70B29353-425B-457F-8394-8ACAA3D804BE}" type="presParOf" srcId="{E042474C-A0A5-40D5-9B17-01117CC802AB}" destId="{D90DA67C-BC96-4078-BBEB-E767EEDF2657}" srcOrd="3" destOrd="0" presId="urn:microsoft.com/office/officeart/2005/8/layout/list1"/>
+    <dgm:cxn modelId="{4C667FB5-511C-4A9C-96EF-9E5022D1B45D}" type="presParOf" srcId="{E042474C-A0A5-40D5-9B17-01117CC802AB}" destId="{585D6820-41E2-44D8-B3CE-0C89AA767FC6}" srcOrd="4" destOrd="0" presId="urn:microsoft.com/office/officeart/2005/8/layout/list1"/>
+    <dgm:cxn modelId="{149E05D5-7017-4E33-9807-ED637E8BEEFB}" type="presParOf" srcId="{585D6820-41E2-44D8-B3CE-0C89AA767FC6}" destId="{2D521557-F57A-46EB-AFFE-DC5DC6543760}" srcOrd="0" destOrd="0" presId="urn:microsoft.com/office/officeart/2005/8/layout/list1"/>
+    <dgm:cxn modelId="{BD2E38B7-4407-4639-BF91-F8C07DE66D1F}" type="presParOf" srcId="{585D6820-41E2-44D8-B3CE-0C89AA767FC6}" destId="{6E6F8F08-80B1-4ED5-9535-177F20B67890}" srcOrd="1" destOrd="0" presId="urn:microsoft.com/office/officeart/2005/8/layout/list1"/>
+    <dgm:cxn modelId="{E581A5D5-402E-40F1-B100-126808A28B52}" type="presParOf" srcId="{E042474C-A0A5-40D5-9B17-01117CC802AB}" destId="{473AA82E-17AB-4859-89A4-06768D586EA0}" srcOrd="5" destOrd="0" presId="urn:microsoft.com/office/officeart/2005/8/layout/list1"/>
+    <dgm:cxn modelId="{2A140CC2-3BA0-4DC7-A677-F8276C5B05ED}" type="presParOf" srcId="{E042474C-A0A5-40D5-9B17-01117CC802AB}" destId="{323AA25F-4521-439B-ABE8-76D0915CA15E}" srcOrd="6" destOrd="0" presId="urn:microsoft.com/office/officeart/2005/8/layout/list1"/>
+    <dgm:cxn modelId="{082E4906-B6A6-442D-9BAC-F76BCB6BEC12}" type="presParOf" srcId="{E042474C-A0A5-40D5-9B17-01117CC802AB}" destId="{D7E96991-323A-4655-858F-70653A5C157B}" srcOrd="7" destOrd="0" presId="urn:microsoft.com/office/officeart/2005/8/layout/list1"/>
+    <dgm:cxn modelId="{F461030A-EC5E-45E1-AE52-94E0D80FC63D}" type="presParOf" srcId="{E042474C-A0A5-40D5-9B17-01117CC802AB}" destId="{3DBAE7C1-7E57-4E04-AE43-135D2BB6378C}" srcOrd="8" destOrd="0" presId="urn:microsoft.com/office/officeart/2005/8/layout/list1"/>
+    <dgm:cxn modelId="{684C0408-6554-4787-961F-C6D88825CC02}" type="presParOf" srcId="{3DBAE7C1-7E57-4E04-AE43-135D2BB6378C}" destId="{435FD845-E0DA-45C2-99AB-681F807FC961}" srcOrd="0" destOrd="0" presId="urn:microsoft.com/office/officeart/2005/8/layout/list1"/>
+    <dgm:cxn modelId="{F6C5FB0B-9A13-4390-B0F3-BA8F47C6878B}" type="presParOf" srcId="{3DBAE7C1-7E57-4E04-AE43-135D2BB6378C}" destId="{7BA4BE36-552F-4B25-BF78-14B70D0E15A7}" srcOrd="1" destOrd="0" presId="urn:microsoft.com/office/officeart/2005/8/layout/list1"/>
+    <dgm:cxn modelId="{F17992DC-946D-4D53-AF85-7A6FD36B474D}" type="presParOf" srcId="{E042474C-A0A5-40D5-9B17-01117CC802AB}" destId="{44517AE8-CCB2-4E31-865B-B9A80A7AA389}" srcOrd="9" destOrd="0" presId="urn:microsoft.com/office/officeart/2005/8/layout/list1"/>
+    <dgm:cxn modelId="{41AF68CD-DE49-45F4-BA21-FB3E7783ABEE}" type="presParOf" srcId="{E042474C-A0A5-40D5-9B17-01117CC802AB}" destId="{7917C87B-6C84-46AC-A0CC-40146E8D0C31}" srcOrd="10" destOrd="0" presId="urn:microsoft.com/office/officeart/2005/8/layout/list1"/>
+    <dgm:cxn modelId="{1C135301-160F-4447-BEF8-2AD1F327C54E}" type="presParOf" srcId="{E042474C-A0A5-40D5-9B17-01117CC802AB}" destId="{1D1D55CD-2025-44E1-813B-C15C114DF9C1}" srcOrd="11" destOrd="0" presId="urn:microsoft.com/office/officeart/2005/8/layout/list1"/>
+    <dgm:cxn modelId="{AF163005-CE1E-4028-8AFD-9247184B75E1}" type="presParOf" srcId="{E042474C-A0A5-40D5-9B17-01117CC802AB}" destId="{8773EE68-12BC-4B69-8C93-659C790897F4}" srcOrd="12" destOrd="0" presId="urn:microsoft.com/office/officeart/2005/8/layout/list1"/>
+    <dgm:cxn modelId="{FB322EB6-FF1D-4E75-BD8C-BE27A1219759}" type="presParOf" srcId="{8773EE68-12BC-4B69-8C93-659C790897F4}" destId="{98379ACE-A084-41B6-B3B2-4E7CEABCB17E}" srcOrd="0" destOrd="0" presId="urn:microsoft.com/office/officeart/2005/8/layout/list1"/>
+    <dgm:cxn modelId="{2301B354-A8E7-4231-8095-9B4D31F2B94F}" type="presParOf" srcId="{8773EE68-12BC-4B69-8C93-659C790897F4}" destId="{BB4727C1-D41B-423B-93AE-9DC77DA899D5}" srcOrd="1" destOrd="0" presId="urn:microsoft.com/office/officeart/2005/8/layout/list1"/>
+    <dgm:cxn modelId="{1ACA09DE-6ACF-4C64-95AF-9AE71A4544AF}" type="presParOf" srcId="{E042474C-A0A5-40D5-9B17-01117CC802AB}" destId="{B86E05FE-7386-4795-8530-4F6A0FE04BC8}" srcOrd="13" destOrd="0" presId="urn:microsoft.com/office/officeart/2005/8/layout/list1"/>
+    <dgm:cxn modelId="{90E8CC7B-9ED1-4D19-A45A-B308BB453B62}" type="presParOf" srcId="{E042474C-A0A5-40D5-9B17-01117CC802AB}" destId="{1CAA899B-F6E6-4429-82FC-1AAFA4443513}" srcOrd="14" destOrd="0" presId="urn:microsoft.com/office/officeart/2005/8/layout/list1"/>
+    <dgm:cxn modelId="{F2149FAB-35D8-4AC6-8CBE-EDCEE6E46AD1}" type="presParOf" srcId="{E042474C-A0A5-40D5-9B17-01117CC802AB}" destId="{4FD1A70F-23A9-41D7-A717-400E59C82B89}" srcOrd="15" destOrd="0" presId="urn:microsoft.com/office/officeart/2005/8/layout/list1"/>
+    <dgm:cxn modelId="{ED36936B-D458-4667-B092-6D60F6FD0EAA}" type="presParOf" srcId="{E042474C-A0A5-40D5-9B17-01117CC802AB}" destId="{7307C539-7BE1-4D3E-9F60-73B1657D2DE3}" srcOrd="16" destOrd="0" presId="urn:microsoft.com/office/officeart/2005/8/layout/list1"/>
+    <dgm:cxn modelId="{96A6C029-DB7F-4C45-8059-3BC779E4A341}" type="presParOf" srcId="{7307C539-7BE1-4D3E-9F60-73B1657D2DE3}" destId="{D57C1DB4-B9FC-4EED-841D-6C25049996BE}" srcOrd="0" destOrd="0" presId="urn:microsoft.com/office/officeart/2005/8/layout/list1"/>
+    <dgm:cxn modelId="{73D81E83-4780-4ED0-8F10-474A76D5D132}" type="presParOf" srcId="{7307C539-7BE1-4D3E-9F60-73B1657D2DE3}" destId="{BE6FFCE4-D821-4667-8F34-735CD66E39FD}" srcOrd="1" destOrd="0" presId="urn:microsoft.com/office/officeart/2005/8/layout/list1"/>
+    <dgm:cxn modelId="{B215CDDC-8C7E-4FB7-9938-6D51B24F8E26}" type="presParOf" srcId="{E042474C-A0A5-40D5-9B17-01117CC802AB}" destId="{0B6FF0A6-589B-46F7-873F-D987E65B5239}" srcOrd="17" destOrd="0" presId="urn:microsoft.com/office/officeart/2005/8/layout/list1"/>
+    <dgm:cxn modelId="{B19EBDB5-B971-4EEC-830D-B35DF309755C}" type="presParOf" srcId="{E042474C-A0A5-40D5-9B17-01117CC802AB}" destId="{7A89284A-AC1B-4D70-9B1C-ADAF07F66E34}" srcOrd="18" destOrd="0" presId="urn:microsoft.com/office/officeart/2005/8/layout/list1"/>
+  </dgm:cxnLst>
+  <dgm:bg/>
+  <dgm:whole/>
+  <dgm:extLst>
+    <a:ext uri="http://schemas.microsoft.com/office/drawing/2008/diagram">
+      <dsp:dataModelExt xmlns:dsp="http://schemas.microsoft.com/office/drawing/2008/diagram" relId="rId6" minVer="http://schemas.openxmlformats.org/drawingml/2006/diagram"/>
+    </a:ext>
+  </dgm:extLst>
+</dgm:dataModel>
+</file>
+
+<file path=ppt/diagrams/data9.xml><?xml version="1.0" encoding="utf-8"?>
+<dgm:dataModel xmlns:dgm="http://schemas.openxmlformats.org/drawingml/2006/diagram" xmlns:a="http://schemas.openxmlformats.org/drawingml/2006/main">
+  <dgm:ptLst>
+    <dgm:pt modelId="{349DE399-23D9-49D2-9DC7-5A910169EAD0}" type="doc">
+      <dgm:prSet loTypeId="urn:microsoft.com/office/officeart/2005/8/layout/list1" loCatId="list" qsTypeId="urn:microsoft.com/office/officeart/2005/8/quickstyle/simple1" qsCatId="simple" csTypeId="urn:microsoft.com/office/officeart/2005/8/colors/accent1_2" csCatId="accent1" phldr="1"/>
+      <dgm:spPr/>
+      <dgm:t>
+        <a:bodyPr/>
+        <a:lstStyle/>
+        <a:p>
+          <a:endParaRPr lang="en-SG"/>
+        </a:p>
+      </dgm:t>
+    </dgm:pt>
+    <dgm:pt modelId="{E15FECA5-30D6-4625-B47A-8153420E66D8}">
+      <dgm:prSet custT="1"/>
+      <dgm:spPr/>
+      <dgm:t>
+        <a:bodyPr/>
+        <a:lstStyle/>
+        <a:p>
+          <a:pPr>
+            <a:buFont typeface="Wingdings" panose="05000000000000000000" pitchFamily="2" charset="2"/>
+            <a:buNone/>
+          </a:pPr>
+          <a:r>
+            <a:rPr lang="en-SG" sz="1400" b="1" dirty="0"/>
+            <a:t>Extended Neural Model Demos (Lightweight)</a:t>
+          </a:r>
+        </a:p>
+      </dgm:t>
+    </dgm:pt>
+    <dgm:pt modelId="{F14BE1AB-D653-4B64-980B-86D582E904C4}" type="parTrans" cxnId="{BF6FE7C6-F8A7-45E9-9F59-BB1DA09EE8A7}">
+      <dgm:prSet/>
+      <dgm:spPr/>
+      <dgm:t>
+        <a:bodyPr/>
+        <a:lstStyle/>
+        <a:p>
+          <a:endParaRPr lang="en-SG"/>
+        </a:p>
+      </dgm:t>
+    </dgm:pt>
+    <dgm:pt modelId="{305EF0D4-61EE-4A6D-98E3-85819940A7C6}" type="sibTrans" cxnId="{BF6FE7C6-F8A7-45E9-9F59-BB1DA09EE8A7}">
+      <dgm:prSet/>
+      <dgm:spPr/>
+      <dgm:t>
+        <a:bodyPr/>
+        <a:lstStyle/>
+        <a:p>
+          <a:endParaRPr lang="en-SG"/>
+        </a:p>
+      </dgm:t>
+    </dgm:pt>
+    <dgm:pt modelId="{DC5BB092-71E0-400B-BCB2-C56569729D80}">
+      <dgm:prSet custT="1"/>
+      <dgm:spPr/>
+      <dgm:t>
+        <a:bodyPr/>
+        <a:lstStyle/>
+        <a:p>
+          <a:pPr>
+            <a:buFont typeface="Wingdings" panose="05000000000000000000" pitchFamily="2" charset="2"/>
+            <a:buNone/>
+          </a:pPr>
+          <a:r>
+            <a:rPr lang="en-SG" sz="1400" b="1" dirty="0"/>
+            <a:t>Access</a:t>
+          </a:r>
+        </a:p>
+      </dgm:t>
+    </dgm:pt>
+    <dgm:pt modelId="{CB92CA03-3561-429F-A4D3-673A2173CEAE}" type="parTrans" cxnId="{EF8AD419-15B8-416C-924A-99250328F840}">
+      <dgm:prSet/>
+      <dgm:spPr/>
+      <dgm:t>
+        <a:bodyPr/>
+        <a:lstStyle/>
+        <a:p>
+          <a:endParaRPr lang="en-SG"/>
+        </a:p>
+      </dgm:t>
+    </dgm:pt>
+    <dgm:pt modelId="{7B8A2AFC-89BF-4E18-A406-C0317E42B27B}" type="sibTrans" cxnId="{EF8AD419-15B8-416C-924A-99250328F840}">
+      <dgm:prSet/>
+      <dgm:spPr/>
+      <dgm:t>
+        <a:bodyPr/>
+        <a:lstStyle/>
+        <a:p>
+          <a:endParaRPr lang="en-SG"/>
+        </a:p>
+      </dgm:t>
+    </dgm:pt>
+    <dgm:pt modelId="{DD31C33E-98CA-4AD6-BBA0-5ADDD2F67EC0}">
+      <dgm:prSet custT="1"/>
+      <dgm:spPr/>
+      <dgm:t>
+        <a:bodyPr/>
+        <a:lstStyle/>
+        <a:p>
+          <a:pPr>
+            <a:buFont typeface="Wingdings" panose="05000000000000000000" pitchFamily="2" charset="2"/>
+            <a:buChar char="Ø"/>
+          </a:pPr>
+          <a:r>
+            <a:rPr lang="en-SG" sz="1400" b="0" dirty="0"/>
+            <a:t> Full notebooks and notes available in repository
+ Designed for reproducibility and further experimentation</a:t>
+          </a:r>
+        </a:p>
+      </dgm:t>
+    </dgm:pt>
+    <dgm:pt modelId="{72256291-80F3-4E49-8A15-E6BF18D8A6AB}" type="parTrans" cxnId="{AB5B1EC1-3632-45DD-BEE2-D8DCCDCA2FDD}">
+      <dgm:prSet/>
+      <dgm:spPr/>
+      <dgm:t>
+        <a:bodyPr/>
+        <a:lstStyle/>
+        <a:p>
+          <a:endParaRPr lang="en-SG"/>
+        </a:p>
+      </dgm:t>
+    </dgm:pt>
+    <dgm:pt modelId="{F8AB250B-A5D6-46E4-B19D-3ADD9E47F995}" type="sibTrans" cxnId="{AB5B1EC1-3632-45DD-BEE2-D8DCCDCA2FDD}">
+      <dgm:prSet/>
+      <dgm:spPr/>
+      <dgm:t>
+        <a:bodyPr/>
+        <a:lstStyle/>
+        <a:p>
+          <a:endParaRPr lang="en-SG"/>
+        </a:p>
+      </dgm:t>
+    </dgm:pt>
+    <dgm:pt modelId="{6D66A3A7-0B33-485E-A5F8-C84599619975}">
+      <dgm:prSet custT="1"/>
+      <dgm:spPr/>
+      <dgm:t>
+        <a:bodyPr/>
+        <a:lstStyle/>
+        <a:p>
+          <a:pPr>
+            <a:buFont typeface="Wingdings" panose="05000000000000000000" pitchFamily="2" charset="2"/>
+            <a:buChar char="Ø"/>
+          </a:pPr>
+          <a:r>
+            <a:rPr lang="en-SG" sz="1400" b="0" dirty="0"/>
+            <a:t> TensorFlow / PyTorch recommender implementations
+ Neural ranking models with contrastive-style training (positive &amp; negative sampling)
+ Practical training practices across frameworks (TensorFlow / PyTorch)</a:t>
+          </a:r>
+        </a:p>
+      </dgm:t>
+    </dgm:pt>
+    <dgm:pt modelId="{79D53AFA-F5B3-4421-822C-6560FA3543B2}" type="parTrans" cxnId="{81D29D7B-E23B-4111-A790-0918DB523363}">
+      <dgm:prSet/>
+      <dgm:spPr/>
+      <dgm:t>
+        <a:bodyPr/>
+        <a:lstStyle/>
+        <a:p>
+          <a:endParaRPr lang="en-SG"/>
+        </a:p>
+      </dgm:t>
+    </dgm:pt>
+    <dgm:pt modelId="{69FA4947-1770-46EA-9922-19A1234AF826}" type="sibTrans" cxnId="{81D29D7B-E23B-4111-A790-0918DB523363}">
+      <dgm:prSet/>
+      <dgm:spPr/>
+      <dgm:t>
+        <a:bodyPr/>
+        <a:lstStyle/>
+        <a:p>
+          <a:endParaRPr lang="en-SG"/>
+        </a:p>
+      </dgm:t>
+    </dgm:pt>
+    <dgm:pt modelId="{4C55CBD0-ED17-4CC6-AE48-802C8D4E27B2}">
+      <dgm:prSet custT="1"/>
+      <dgm:spPr/>
+      <dgm:t>
+        <a:bodyPr/>
+        <a:lstStyle/>
+        <a:p>
+          <a:pPr>
+            <a:buFont typeface="Wingdings" panose="05000000000000000000" pitchFamily="2" charset="2"/>
+            <a:buChar char="Ø"/>
+          </a:pPr>
+          <a:r>
+            <a:rPr lang="en-SG" sz="1400" b="0" dirty="0"/>
+            <a:t> Practical ML/ Deep Learning Recommended Practices Memo</a:t>
+          </a:r>
+        </a:p>
+      </dgm:t>
+    </dgm:pt>
+    <dgm:pt modelId="{9033D59E-E2DB-4A9B-87A5-FD708DD27E28}" type="parTrans" cxnId="{A89C7B9D-E1FC-4DCB-BFFA-779E09968A2B}">
+      <dgm:prSet/>
+      <dgm:spPr/>
+      <dgm:t>
+        <a:bodyPr/>
+        <a:lstStyle/>
+        <a:p>
+          <a:endParaRPr lang="en-SG"/>
+        </a:p>
+      </dgm:t>
+    </dgm:pt>
+    <dgm:pt modelId="{708A9492-7D8F-44D1-AD84-F483246E582B}" type="sibTrans" cxnId="{A89C7B9D-E1FC-4DCB-BFFA-779E09968A2B}">
+      <dgm:prSet/>
+      <dgm:spPr/>
+      <dgm:t>
+        <a:bodyPr/>
+        <a:lstStyle/>
+        <a:p>
+          <a:endParaRPr lang="en-SG"/>
+        </a:p>
+      </dgm:t>
+    </dgm:pt>
+    <dgm:pt modelId="{E042474C-A0A5-40D5-9B17-01117CC802AB}" type="pres">
+      <dgm:prSet presAssocID="{349DE399-23D9-49D2-9DC7-5A910169EAD0}" presName="linear" presStyleCnt="0">
+        <dgm:presLayoutVars>
+          <dgm:dir/>
+          <dgm:animLvl val="lvl"/>
+          <dgm:resizeHandles val="exact"/>
+        </dgm:presLayoutVars>
+      </dgm:prSet>
+      <dgm:spPr/>
+    </dgm:pt>
+    <dgm:pt modelId="{C01E9492-803A-4D1D-B092-0F5490EFE438}" type="pres">
+      <dgm:prSet presAssocID="{E15FECA5-30D6-4625-B47A-8153420E66D8}" presName="parentLin" presStyleCnt="0"/>
+      <dgm:spPr/>
+    </dgm:pt>
+    <dgm:pt modelId="{67677099-A951-42DB-A865-C04E4099B0BB}" type="pres">
+      <dgm:prSet presAssocID="{E15FECA5-30D6-4625-B47A-8153420E66D8}" presName="parentLeftMargin" presStyleLbl="node1" presStyleIdx="0" presStyleCnt="2"/>
+      <dgm:spPr/>
+    </dgm:pt>
+    <dgm:pt modelId="{73D61383-A059-4CF8-9A37-12E533FCFC22}" type="pres">
+      <dgm:prSet presAssocID="{E15FECA5-30D6-4625-B47A-8153420E66D8}" presName="parentText" presStyleLbl="node1" presStyleIdx="0" presStyleCnt="2">
+        <dgm:presLayoutVars>
+          <dgm:chMax val="0"/>
+          <dgm:bulletEnabled val="1"/>
+        </dgm:presLayoutVars>
+      </dgm:prSet>
+      <dgm:spPr/>
+    </dgm:pt>
+    <dgm:pt modelId="{2832EB8D-607B-4AC1-9DD6-D1A5BC95D550}" type="pres">
+      <dgm:prSet presAssocID="{E15FECA5-30D6-4625-B47A-8153420E66D8}" presName="negativeSpace" presStyleCnt="0"/>
+      <dgm:spPr/>
+    </dgm:pt>
+    <dgm:pt modelId="{81AB0DB0-4359-4ABA-B7E8-9D326E119CD8}" type="pres">
+      <dgm:prSet presAssocID="{E15FECA5-30D6-4625-B47A-8153420E66D8}" presName="childText" presStyleLbl="conFgAcc1" presStyleIdx="0" presStyleCnt="2">
+        <dgm:presLayoutVars>
+          <dgm:bulletEnabled val="1"/>
+        </dgm:presLayoutVars>
+      </dgm:prSet>
+      <dgm:spPr/>
+    </dgm:pt>
+    <dgm:pt modelId="{D90DA67C-BC96-4078-BBEB-E767EEDF2657}" type="pres">
+      <dgm:prSet presAssocID="{305EF0D4-61EE-4A6D-98E3-85819940A7C6}" presName="spaceBetweenRectangles" presStyleCnt="0"/>
+      <dgm:spPr/>
+    </dgm:pt>
+    <dgm:pt modelId="{3DBAE7C1-7E57-4E04-AE43-135D2BB6378C}" type="pres">
+      <dgm:prSet presAssocID="{DC5BB092-71E0-400B-BCB2-C56569729D80}" presName="parentLin" presStyleCnt="0"/>
+      <dgm:spPr/>
+    </dgm:pt>
+    <dgm:pt modelId="{435FD845-E0DA-45C2-99AB-681F807FC961}" type="pres">
+      <dgm:prSet presAssocID="{DC5BB092-71E0-400B-BCB2-C56569729D80}" presName="parentLeftMargin" presStyleLbl="node1" presStyleIdx="0" presStyleCnt="2"/>
+      <dgm:spPr/>
+    </dgm:pt>
+    <dgm:pt modelId="{7BA4BE36-552F-4B25-BF78-14B70D0E15A7}" type="pres">
+      <dgm:prSet presAssocID="{DC5BB092-71E0-400B-BCB2-C56569729D80}" presName="parentText" presStyleLbl="node1" presStyleIdx="1" presStyleCnt="2">
+        <dgm:presLayoutVars>
+          <dgm:chMax val="0"/>
+          <dgm:bulletEnabled val="1"/>
+        </dgm:presLayoutVars>
+      </dgm:prSet>
+      <dgm:spPr/>
+    </dgm:pt>
+    <dgm:pt modelId="{44517AE8-CCB2-4E31-865B-B9A80A7AA389}" type="pres">
+      <dgm:prSet presAssocID="{DC5BB092-71E0-400B-BCB2-C56569729D80}" presName="negativeSpace" presStyleCnt="0"/>
+      <dgm:spPr/>
+    </dgm:pt>
+    <dgm:pt modelId="{7917C87B-6C84-46AC-A0CC-40146E8D0C31}" type="pres">
+      <dgm:prSet presAssocID="{DC5BB092-71E0-400B-BCB2-C56569729D80}" presName="childText" presStyleLbl="conFgAcc1" presStyleIdx="1" presStyleCnt="2">
+        <dgm:presLayoutVars>
+          <dgm:bulletEnabled val="1"/>
+        </dgm:presLayoutVars>
+      </dgm:prSet>
+      <dgm:spPr/>
+    </dgm:pt>
+  </dgm:ptLst>
+  <dgm:cxnLst>
     <dgm:cxn modelId="{EF8AD419-15B8-416C-924A-99250328F840}" srcId="{349DE399-23D9-49D2-9DC7-5A910169EAD0}" destId="{DC5BB092-71E0-400B-BCB2-C56569729D80}" srcOrd="1" destOrd="0" parTransId="{CB92CA03-3561-429F-A4D3-673A2173CEAE}" sibTransId="{7B8A2AFC-89BF-4E18-A406-C0317E42B27B}"/>
-    <dgm:cxn modelId="{0F26091C-822D-4785-94B6-04AFCFEE9063}" type="presOf" srcId="{DB96552C-2D53-49D2-8D90-E76A85981323}" destId="{98379ACE-A084-41B6-B3B2-4E7CEABCB17E}" srcOrd="0" destOrd="0" presId="urn:microsoft.com/office/officeart/2005/8/layout/list1"/>
-    <dgm:cxn modelId="{7E832322-EC53-49BA-8CF9-B4704E959E59}" srcId="{349DE399-23D9-49D2-9DC7-5A910169EAD0}" destId="{DB96552C-2D53-49D2-8D90-E76A85981323}" srcOrd="2" destOrd="0" parTransId="{EFCCCCD6-962C-427A-B872-2550F0522C47}" sibTransId="{DD4D4728-97A6-4C2F-86EF-C012E2D24019}"/>
-    <dgm:cxn modelId="{A62CD52B-6ABA-421B-919C-3230AE6375F8}" type="presOf" srcId="{DD31C33E-98CA-4AD6-BBA0-5ADDD2F67EC0}" destId="{7917C87B-6C84-46AC-A0CC-40146E8D0C31}" srcOrd="0" destOrd="0" presId="urn:microsoft.com/office/officeart/2005/8/layout/list1"/>
-    <dgm:cxn modelId="{228FA73A-6528-4EC8-B772-E4F6A0376B51}" type="presOf" srcId="{30DB91E6-37CC-4B0B-8CF6-B211AF361B3C}" destId="{7A89284A-AC1B-4D70-9B1C-ADAF07F66E34}" srcOrd="0" destOrd="0" presId="urn:microsoft.com/office/officeart/2005/8/layout/list1"/>
-    <dgm:cxn modelId="{4D0B8741-895C-4C66-B15D-E5D245D8184D}" type="presOf" srcId="{E15FECA5-30D6-4625-B47A-8153420E66D8}" destId="{67677099-A951-42DB-A865-C04E4099B0BB}" srcOrd="0" destOrd="0" presId="urn:microsoft.com/office/officeart/2005/8/layout/list1"/>
-    <dgm:cxn modelId="{1288DF4F-2F68-47D8-89C5-895C74177033}" srcId="{1C8723D1-5DB9-4581-BC75-9982AB696638}" destId="{10922B28-E9A1-48ED-9E5F-6AB236DBDC8D}" srcOrd="1" destOrd="0" parTransId="{8315A896-C0AC-4C55-AA39-C9C27689E450}" sibTransId="{167CCE70-34F6-4A44-9C86-57714B91D831}"/>
-    <dgm:cxn modelId="{B68F4A73-4717-4C1B-A04F-2E9816FF2A5B}" srcId="{E15FECA5-30D6-4625-B47A-8153420E66D8}" destId="{8EB33104-D9F3-4D53-A914-670AA1E45747}" srcOrd="0" destOrd="0" parTransId="{15B5FE86-97E0-4CF2-91F4-EB4EA846C22C}" sibTransId="{57154F96-E9CC-4E39-ABCD-A60F9594EC48}"/>
-    <dgm:cxn modelId="{C0127078-1F33-48E6-9E81-894B99886FF0}" srcId="{DB96552C-2D53-49D2-8D90-E76A85981323}" destId="{82F82B97-9A2B-482D-9198-E5AF696C82EB}" srcOrd="0" destOrd="0" parTransId="{A2C6E84F-BCF5-4293-8E31-4F49F972F957}" sibTransId="{BCE20A6F-0D33-47D0-9EC2-A7E958324E80}"/>
-    <dgm:cxn modelId="{AF2C4085-3EDE-4559-9F26-68AC7E277FF3}" type="presOf" srcId="{1C8723D1-5DB9-4581-BC75-9982AB696638}" destId="{D57C1DB4-B9FC-4EED-841D-6C25049996BE}" srcOrd="0" destOrd="0" presId="urn:microsoft.com/office/officeart/2005/8/layout/list1"/>
-    <dgm:cxn modelId="{1949C1AD-3D1B-4F43-8624-009CDD3C7D5A}" srcId="{1C8723D1-5DB9-4581-BC75-9982AB696638}" destId="{30DB91E6-37CC-4B0B-8CF6-B211AF361B3C}" srcOrd="0" destOrd="0" parTransId="{1C1235CC-BBFC-40FE-9F2C-81FB8B860B93}" sibTransId="{F7255E64-CF54-4DF1-BD98-694B20A7CD94}"/>
-    <dgm:cxn modelId="{C7B9D3AE-10B9-4550-97DE-78D71E5BC7FD}" type="presOf" srcId="{1C8723D1-5DB9-4581-BC75-9982AB696638}" destId="{BE6FFCE4-D821-4667-8F34-735CD66E39FD}" srcOrd="1" destOrd="0" presId="urn:microsoft.com/office/officeart/2005/8/layout/list1"/>
-    <dgm:cxn modelId="{AB47E1B3-BA36-4EA5-A00E-7633FDA6D80D}" type="presOf" srcId="{DB96552C-2D53-49D2-8D90-E76A85981323}" destId="{BB4727C1-D41B-423B-93AE-9DC77DA899D5}" srcOrd="1" destOrd="0" presId="urn:microsoft.com/office/officeart/2005/8/layout/list1"/>
+    <dgm:cxn modelId="{2112A827-322B-4934-B4A9-18D2237AB0CF}" type="presOf" srcId="{4C55CBD0-ED17-4CC6-AE48-802C8D4E27B2}" destId="{81AB0DB0-4359-4ABA-B7E8-9D326E119CD8}" srcOrd="0" destOrd="1" presId="urn:microsoft.com/office/officeart/2005/8/layout/list1"/>
+    <dgm:cxn modelId="{A5B7DF2C-63A0-4A34-8DBA-1583AB0C45C5}" type="presOf" srcId="{DD31C33E-98CA-4AD6-BBA0-5ADDD2F67EC0}" destId="{7917C87B-6C84-46AC-A0CC-40146E8D0C31}" srcOrd="0" destOrd="0" presId="urn:microsoft.com/office/officeart/2005/8/layout/list1"/>
+    <dgm:cxn modelId="{47F20F41-8180-456E-B088-6634DBD05A96}" type="presOf" srcId="{6D66A3A7-0B33-485E-A5F8-C84599619975}" destId="{81AB0DB0-4359-4ABA-B7E8-9D326E119CD8}" srcOrd="0" destOrd="0" presId="urn:microsoft.com/office/officeart/2005/8/layout/list1"/>
+    <dgm:cxn modelId="{81D29D7B-E23B-4111-A790-0918DB523363}" srcId="{E15FECA5-30D6-4625-B47A-8153420E66D8}" destId="{6D66A3A7-0B33-485E-A5F8-C84599619975}" srcOrd="0" destOrd="0" parTransId="{79D53AFA-F5B3-4421-822C-6560FA3543B2}" sibTransId="{69FA4947-1770-46EA-9922-19A1234AF826}"/>
+    <dgm:cxn modelId="{A89C7B9D-E1FC-4DCB-BFFA-779E09968A2B}" srcId="{E15FECA5-30D6-4625-B47A-8153420E66D8}" destId="{4C55CBD0-ED17-4CC6-AE48-802C8D4E27B2}" srcOrd="1" destOrd="0" parTransId="{9033D59E-E2DB-4A9B-87A5-FD708DD27E28}" sibTransId="{708A9492-7D8F-44D1-AD84-F483246E582B}"/>
+    <dgm:cxn modelId="{DA2FFCA2-DF6A-478A-8AF8-191DB2C39EF7}" type="presOf" srcId="{E15FECA5-30D6-4625-B47A-8153420E66D8}" destId="{73D61383-A059-4CF8-9A37-12E533FCFC22}" srcOrd="1" destOrd="0" presId="urn:microsoft.com/office/officeart/2005/8/layout/list1"/>
     <dgm:cxn modelId="{AB5B1EC1-3632-45DD-BEE2-D8DCCDCA2FDD}" srcId="{DC5BB092-71E0-400B-BCB2-C56569729D80}" destId="{DD31C33E-98CA-4AD6-BBA0-5ADDD2F67EC0}" srcOrd="0" destOrd="0" parTransId="{72256291-80F3-4E49-8A15-E6BF18D8A6AB}" sibTransId="{F8AB250B-A5D6-46E4-B19D-3ADD9E47F995}"/>
+    <dgm:cxn modelId="{393112C6-59CD-429E-8663-025072542D25}" type="presOf" srcId="{DC5BB092-71E0-400B-BCB2-C56569729D80}" destId="{7BA4BE36-552F-4B25-BF78-14B70D0E15A7}" srcOrd="1" destOrd="0" presId="urn:microsoft.com/office/officeart/2005/8/layout/list1"/>
     <dgm:cxn modelId="{BF6FE7C6-F8A7-45E9-9F59-BB1DA09EE8A7}" srcId="{349DE399-23D9-49D2-9DC7-5A910169EAD0}" destId="{E15FECA5-30D6-4625-B47A-8153420E66D8}" srcOrd="0" destOrd="0" parTransId="{F14BE1AB-D653-4B64-980B-86D582E904C4}" sibTransId="{305EF0D4-61EE-4A6D-98E3-85819940A7C6}"/>
-    <dgm:cxn modelId="{65952DDB-46C8-4DE6-9CF2-AAD681FDE744}" srcId="{349DE399-23D9-49D2-9DC7-5A910169EAD0}" destId="{1C8723D1-5DB9-4581-BC75-9982AB696638}" srcOrd="3" destOrd="0" parTransId="{2C07BA3E-F8EC-4D3D-AC37-73D93CC1C605}" sibTransId="{7574D0EC-2572-47B2-8CBF-C5B46788A613}"/>
-    <dgm:cxn modelId="{2D0E69DC-1D35-4B88-B8B5-7CAD838BC23C}" type="presOf" srcId="{10922B28-E9A1-48ED-9E5F-6AB236DBDC8D}" destId="{7A89284A-AC1B-4D70-9B1C-ADAF07F66E34}" srcOrd="0" destOrd="1" presId="urn:microsoft.com/office/officeart/2005/8/layout/list1"/>
-    <dgm:cxn modelId="{9F296DDC-764B-4D25-9BDB-74B9B33C11A6}" type="presOf" srcId="{DC5BB092-71E0-400B-BCB2-C56569729D80}" destId="{435FD845-E0DA-45C2-99AB-681F807FC961}" srcOrd="0" destOrd="0" presId="urn:microsoft.com/office/officeart/2005/8/layout/list1"/>
+    <dgm:cxn modelId="{E5DC68D6-4FC4-4B1D-AE27-4567D1D5D26C}" type="presOf" srcId="{E15FECA5-30D6-4625-B47A-8153420E66D8}" destId="{67677099-A951-42DB-A865-C04E4099B0BB}" srcOrd="0" destOrd="0" presId="urn:microsoft.com/office/officeart/2005/8/layout/list1"/>
+    <dgm:cxn modelId="{25B789DC-EDC4-40B2-A17B-9A45772404B5}" type="presOf" srcId="{DC5BB092-71E0-400B-BCB2-C56569729D80}" destId="{435FD845-E0DA-45C2-99AB-681F807FC961}" srcOrd="0" destOrd="0" presId="urn:microsoft.com/office/officeart/2005/8/layout/list1"/>
     <dgm:cxn modelId="{E5D1ABE3-9B55-4606-9619-8CDEA2EFFCF6}" type="presOf" srcId="{349DE399-23D9-49D2-9DC7-5A910169EAD0}" destId="{E042474C-A0A5-40D5-9B17-01117CC802AB}" srcOrd="0" destOrd="0" presId="urn:microsoft.com/office/officeart/2005/8/layout/list1"/>
-    <dgm:cxn modelId="{F7FCF5E6-ECD3-4183-B089-8611088F86FF}" type="presOf" srcId="{DC5BB092-71E0-400B-BCB2-C56569729D80}" destId="{7BA4BE36-552F-4B25-BF78-14B70D0E15A7}" srcOrd="1" destOrd="0" presId="urn:microsoft.com/office/officeart/2005/8/layout/list1"/>
-    <dgm:cxn modelId="{C57D36FB-E2FD-4910-A91D-0039B9085E42}" type="presOf" srcId="{82F82B97-9A2B-482D-9198-E5AF696C82EB}" destId="{1CAA899B-F6E6-4429-82FC-1AAFA4443513}" srcOrd="0" destOrd="0" presId="urn:microsoft.com/office/officeart/2005/8/layout/list1"/>
-    <dgm:cxn modelId="{382BB2FF-98C3-47DF-B6C0-78E617548A14}" type="presOf" srcId="{8EB33104-D9F3-4D53-A914-670AA1E45747}" destId="{81AB0DB0-4359-4ABA-B7E8-9D326E119CD8}" srcOrd="0" destOrd="0" presId="urn:microsoft.com/office/officeart/2005/8/layout/list1"/>
-    <dgm:cxn modelId="{CE29113F-73C3-489D-8603-B549A14A5C95}" type="presParOf" srcId="{E042474C-A0A5-40D5-9B17-01117CC802AB}" destId="{C01E9492-803A-4D1D-B092-0F5490EFE438}" srcOrd="0" destOrd="0" presId="urn:microsoft.com/office/officeart/2005/8/layout/list1"/>
-    <dgm:cxn modelId="{39722A95-30BC-4B2D-9330-AC14563CB5B5}" type="presParOf" srcId="{C01E9492-803A-4D1D-B092-0F5490EFE438}" destId="{67677099-A951-42DB-A865-C04E4099B0BB}" srcOrd="0" destOrd="0" presId="urn:microsoft.com/office/officeart/2005/8/layout/list1"/>
-    <dgm:cxn modelId="{534ADD8E-F1ED-4554-87A6-9AF351725881}" type="presParOf" srcId="{C01E9492-803A-4D1D-B092-0F5490EFE438}" destId="{73D61383-A059-4CF8-9A37-12E533FCFC22}" srcOrd="1" destOrd="0" presId="urn:microsoft.com/office/officeart/2005/8/layout/list1"/>
-    <dgm:cxn modelId="{BB1C3C1E-1A2E-4C56-BF0B-D869BA463F0B}" type="presParOf" srcId="{E042474C-A0A5-40D5-9B17-01117CC802AB}" destId="{2832EB8D-607B-4AC1-9DD6-D1A5BC95D550}" srcOrd="1" destOrd="0" presId="urn:microsoft.com/office/officeart/2005/8/layout/list1"/>
-    <dgm:cxn modelId="{63FF9F60-3AE7-43EA-9299-EE4468188090}" type="presParOf" srcId="{E042474C-A0A5-40D5-9B17-01117CC802AB}" destId="{81AB0DB0-4359-4ABA-B7E8-9D326E119CD8}" srcOrd="2" destOrd="0" presId="urn:microsoft.com/office/officeart/2005/8/layout/list1"/>
-    <dgm:cxn modelId="{EA94D4DD-E286-4D0C-83EB-0DD2D3FF9097}" type="presParOf" srcId="{E042474C-A0A5-40D5-9B17-01117CC802AB}" destId="{D90DA67C-BC96-4078-BBEB-E767EEDF2657}" srcOrd="3" destOrd="0" presId="urn:microsoft.com/office/officeart/2005/8/layout/list1"/>
-    <dgm:cxn modelId="{919BC7FD-655F-4D4D-89F9-61D68E494256}" type="presParOf" srcId="{E042474C-A0A5-40D5-9B17-01117CC802AB}" destId="{3DBAE7C1-7E57-4E04-AE43-135D2BB6378C}" srcOrd="4" destOrd="0" presId="urn:microsoft.com/office/officeart/2005/8/layout/list1"/>
-    <dgm:cxn modelId="{9BCF56A5-2D98-41BD-92BE-54B97C376FD6}" type="presParOf" srcId="{3DBAE7C1-7E57-4E04-AE43-135D2BB6378C}" destId="{435FD845-E0DA-45C2-99AB-681F807FC961}" srcOrd="0" destOrd="0" presId="urn:microsoft.com/office/officeart/2005/8/layout/list1"/>
-    <dgm:cxn modelId="{5146BED5-FDF8-4174-93CC-F873C696DC37}" type="presParOf" srcId="{3DBAE7C1-7E57-4E04-AE43-135D2BB6378C}" destId="{7BA4BE36-552F-4B25-BF78-14B70D0E15A7}" srcOrd="1" destOrd="0" presId="urn:microsoft.com/office/officeart/2005/8/layout/list1"/>
-    <dgm:cxn modelId="{D0709679-2490-4D8A-8EE7-A8091681EB28}" type="presParOf" srcId="{E042474C-A0A5-40D5-9B17-01117CC802AB}" destId="{44517AE8-CCB2-4E31-865B-B9A80A7AA389}" srcOrd="5" destOrd="0" presId="urn:microsoft.com/office/officeart/2005/8/layout/list1"/>
-    <dgm:cxn modelId="{2DD1EC9C-AC34-437D-8DD9-0584C0319189}" type="presParOf" srcId="{E042474C-A0A5-40D5-9B17-01117CC802AB}" destId="{7917C87B-6C84-46AC-A0CC-40146E8D0C31}" srcOrd="6" destOrd="0" presId="urn:microsoft.com/office/officeart/2005/8/layout/list1"/>
-    <dgm:cxn modelId="{58F73A23-FB48-44A7-A8B2-7AE53024F151}" type="presParOf" srcId="{E042474C-A0A5-40D5-9B17-01117CC802AB}" destId="{1D1D55CD-2025-44E1-813B-C15C114DF9C1}" srcOrd="7" destOrd="0" presId="urn:microsoft.com/office/officeart/2005/8/layout/list1"/>
-    <dgm:cxn modelId="{FE1C3150-C365-4761-ABA4-8A8785EE1C7A}" type="presParOf" srcId="{E042474C-A0A5-40D5-9B17-01117CC802AB}" destId="{8773EE68-12BC-4B69-8C93-659C790897F4}" srcOrd="8" destOrd="0" presId="urn:microsoft.com/office/officeart/2005/8/layout/list1"/>
-    <dgm:cxn modelId="{66E4E4D0-FF02-4776-A501-2537167F97FE}" type="presParOf" srcId="{8773EE68-12BC-4B69-8C93-659C790897F4}" destId="{98379ACE-A084-41B6-B3B2-4E7CEABCB17E}" srcOrd="0" destOrd="0" presId="urn:microsoft.com/office/officeart/2005/8/layout/list1"/>
-    <dgm:cxn modelId="{A9391336-02C6-4DDA-8796-A0C2356D7EAF}" type="presParOf" srcId="{8773EE68-12BC-4B69-8C93-659C790897F4}" destId="{BB4727C1-D41B-423B-93AE-9DC77DA899D5}" srcOrd="1" destOrd="0" presId="urn:microsoft.com/office/officeart/2005/8/layout/list1"/>
-    <dgm:cxn modelId="{BB1CD8DD-3AA5-4BD1-A536-9EA25F6F9037}" type="presParOf" srcId="{E042474C-A0A5-40D5-9B17-01117CC802AB}" destId="{B86E05FE-7386-4795-8530-4F6A0FE04BC8}" srcOrd="9" destOrd="0" presId="urn:microsoft.com/office/officeart/2005/8/layout/list1"/>
-    <dgm:cxn modelId="{051A3F65-DF5E-45BA-935C-F01A08B9B5BE}" type="presParOf" srcId="{E042474C-A0A5-40D5-9B17-01117CC802AB}" destId="{1CAA899B-F6E6-4429-82FC-1AAFA4443513}" srcOrd="10" destOrd="0" presId="urn:microsoft.com/office/officeart/2005/8/layout/list1"/>
-    <dgm:cxn modelId="{C96C5E07-0D55-48E7-BFF2-38A6B0B9DA1A}" type="presParOf" srcId="{E042474C-A0A5-40D5-9B17-01117CC802AB}" destId="{4FD1A70F-23A9-41D7-A717-400E59C82B89}" srcOrd="11" destOrd="0" presId="urn:microsoft.com/office/officeart/2005/8/layout/list1"/>
-    <dgm:cxn modelId="{F59743E5-62E4-4457-A1CF-0E1483BA5F6E}" type="presParOf" srcId="{E042474C-A0A5-40D5-9B17-01117CC802AB}" destId="{7307C539-7BE1-4D3E-9F60-73B1657D2DE3}" srcOrd="12" destOrd="0" presId="urn:microsoft.com/office/officeart/2005/8/layout/list1"/>
-    <dgm:cxn modelId="{5DF0EBC3-872B-4C28-8042-4E04F66B3CA7}" type="presParOf" srcId="{7307C539-7BE1-4D3E-9F60-73B1657D2DE3}" destId="{D57C1DB4-B9FC-4EED-841D-6C25049996BE}" srcOrd="0" destOrd="0" presId="urn:microsoft.com/office/officeart/2005/8/layout/list1"/>
-    <dgm:cxn modelId="{94FF6AE3-B449-4FB3-B475-2EE2155AB9EE}" type="presParOf" srcId="{7307C539-7BE1-4D3E-9F60-73B1657D2DE3}" destId="{BE6FFCE4-D821-4667-8F34-735CD66E39FD}" srcOrd="1" destOrd="0" presId="urn:microsoft.com/office/officeart/2005/8/layout/list1"/>
-    <dgm:cxn modelId="{2B6143DE-0083-4BC9-88CC-25BCA24C7BB8}" type="presParOf" srcId="{E042474C-A0A5-40D5-9B17-01117CC802AB}" destId="{0B6FF0A6-589B-46F7-873F-D987E65B5239}" srcOrd="13" destOrd="0" presId="urn:microsoft.com/office/officeart/2005/8/layout/list1"/>
-    <dgm:cxn modelId="{FFABD3B4-D1D9-46E3-9E3C-AA208716F864}" type="presParOf" srcId="{E042474C-A0A5-40D5-9B17-01117CC802AB}" destId="{7A89284A-AC1B-4D70-9B1C-ADAF07F66E34}" srcOrd="14" destOrd="0" presId="urn:microsoft.com/office/officeart/2005/8/layout/list1"/>
+    <dgm:cxn modelId="{0685E437-36D3-4D2B-8E19-6489DDC0DE78}" type="presParOf" srcId="{E042474C-A0A5-40D5-9B17-01117CC802AB}" destId="{C01E9492-803A-4D1D-B092-0F5490EFE438}" srcOrd="0" destOrd="0" presId="urn:microsoft.com/office/officeart/2005/8/layout/list1"/>
+    <dgm:cxn modelId="{CCB5DB3A-58A2-4D19-905A-C77D80AD74E5}" type="presParOf" srcId="{C01E9492-803A-4D1D-B092-0F5490EFE438}" destId="{67677099-A951-42DB-A865-C04E4099B0BB}" srcOrd="0" destOrd="0" presId="urn:microsoft.com/office/officeart/2005/8/layout/list1"/>
+    <dgm:cxn modelId="{E2D5C1A8-BC5C-4580-8610-C4ACE27483B5}" type="presParOf" srcId="{C01E9492-803A-4D1D-B092-0F5490EFE438}" destId="{73D61383-A059-4CF8-9A37-12E533FCFC22}" srcOrd="1" destOrd="0" presId="urn:microsoft.com/office/officeart/2005/8/layout/list1"/>
+    <dgm:cxn modelId="{FC4DA2E8-ACE5-44CE-ACA7-3B408BD71F8E}" type="presParOf" srcId="{E042474C-A0A5-40D5-9B17-01117CC802AB}" destId="{2832EB8D-607B-4AC1-9DD6-D1A5BC95D550}" srcOrd="1" destOrd="0" presId="urn:microsoft.com/office/officeart/2005/8/layout/list1"/>
+    <dgm:cxn modelId="{7A3EBEEB-634C-4545-8F32-24C5D5B73F42}" type="presParOf" srcId="{E042474C-A0A5-40D5-9B17-01117CC802AB}" destId="{81AB0DB0-4359-4ABA-B7E8-9D326E119CD8}" srcOrd="2" destOrd="0" presId="urn:microsoft.com/office/officeart/2005/8/layout/list1"/>
+    <dgm:cxn modelId="{390B6F45-DBA9-48FE-A128-A9A11E89F914}" type="presParOf" srcId="{E042474C-A0A5-40D5-9B17-01117CC802AB}" destId="{D90DA67C-BC96-4078-BBEB-E767EEDF2657}" srcOrd="3" destOrd="0" presId="urn:microsoft.com/office/officeart/2005/8/layout/list1"/>
+    <dgm:cxn modelId="{752ED4EE-641A-4D80-866B-74D795D65651}" type="presParOf" srcId="{E042474C-A0A5-40D5-9B17-01117CC802AB}" destId="{3DBAE7C1-7E57-4E04-AE43-135D2BB6378C}" srcOrd="4" destOrd="0" presId="urn:microsoft.com/office/officeart/2005/8/layout/list1"/>
+    <dgm:cxn modelId="{DB3B883C-F8CD-4C54-B4C7-1C3334402EAD}" type="presParOf" srcId="{3DBAE7C1-7E57-4E04-AE43-135D2BB6378C}" destId="{435FD845-E0DA-45C2-99AB-681F807FC961}" srcOrd="0" destOrd="0" presId="urn:microsoft.com/office/officeart/2005/8/layout/list1"/>
+    <dgm:cxn modelId="{E06EDB11-88F8-4D84-93FF-349642415A1A}" type="presParOf" srcId="{3DBAE7C1-7E57-4E04-AE43-135D2BB6378C}" destId="{7BA4BE36-552F-4B25-BF78-14B70D0E15A7}" srcOrd="1" destOrd="0" presId="urn:microsoft.com/office/officeart/2005/8/layout/list1"/>
+    <dgm:cxn modelId="{B4C7052E-BF2A-473D-9677-EE2F65D10144}" type="presParOf" srcId="{E042474C-A0A5-40D5-9B17-01117CC802AB}" destId="{44517AE8-CCB2-4E31-865B-B9A80A7AA389}" srcOrd="5" destOrd="0" presId="urn:microsoft.com/office/officeart/2005/8/layout/list1"/>
+    <dgm:cxn modelId="{75F0D807-9795-4D86-8D5D-A5E7522B3AA2}" type="presParOf" srcId="{E042474C-A0A5-40D5-9B17-01117CC802AB}" destId="{7917C87B-6C84-46AC-A0CC-40146E8D0C31}" srcOrd="6" destOrd="0" presId="urn:microsoft.com/office/officeart/2005/8/layout/list1"/>
   </dgm:cxnLst>
   <dgm:bg/>
   <dgm:whole/>
@@ -12190,8 +13470,8 @@
       </dsp:nvSpPr>
       <dsp:spPr>
         <a:xfrm>
-          <a:off x="0" y="271875"/>
-          <a:ext cx="10009185" cy="2945250"/>
+          <a:off x="0" y="175182"/>
+          <a:ext cx="10114372" cy="3465000"/>
         </a:xfrm>
         <a:prstGeom prst="rect">
           <a:avLst/>
@@ -12231,7 +13511,7 @@
         <a:fontRef idx="minor"/>
       </dsp:style>
       <dsp:txBody>
-        <a:bodyPr spcFirstLastPara="0" vert="horz" wrap="square" lIns="776824" tIns="354076" rIns="776824" bIns="99568" numCol="1" spcCol="1270" anchor="t" anchorCtr="0">
+        <a:bodyPr spcFirstLastPara="0" vert="horz" wrap="square" lIns="784988" tIns="229108" rIns="784988" bIns="99568" numCol="1" spcCol="1270" anchor="t" anchorCtr="0">
           <a:noAutofit/>
         </a:bodyPr>
         <a:lstStyle/>
@@ -12434,22 +13714,61 @@
           </a:pPr>
           <a:r>
             <a:rPr lang="en-SG" sz="1400" b="1" kern="1200" dirty="0"/>
-            <a:t>Potential Extensions </a:t>
+            <a:t>Potential Extensions</a:t>
+          </a:r>
+          <a:endParaRPr lang="en-SG" sz="1400" kern="1200" dirty="0"/>
+        </a:p>
+        <a:p>
+          <a:pPr marL="114300" lvl="1" indent="-114300" algn="just" defTabSz="622300">
+            <a:lnSpc>
+              <a:spcPct val="90000"/>
+            </a:lnSpc>
+            <a:spcBef>
+              <a:spcPct val="0"/>
+            </a:spcBef>
+            <a:spcAft>
+              <a:spcPct val="15000"/>
+            </a:spcAft>
+            <a:buFont typeface="Wingdings" panose="05000000000000000000" pitchFamily="2" charset="2"/>
+            <a:buChar char="Ø"/>
+          </a:pPr>
+          <a:r>
+            <a:rPr lang="en-SG" sz="1400" b="1" kern="1200" dirty="0"/>
+            <a:t> Deep Models (Two-Tower) with rich features</a:t>
+          </a:r>
+          <a:endParaRPr lang="en-SG" sz="1400" kern="1200" dirty="0"/>
+        </a:p>
+        <a:p>
+          <a:pPr marL="114300" lvl="1" indent="-114300" algn="just" defTabSz="622300">
+            <a:lnSpc>
+              <a:spcPct val="90000"/>
+            </a:lnSpc>
+            <a:spcBef>
+              <a:spcPct val="0"/>
+            </a:spcBef>
+            <a:spcAft>
+              <a:spcPct val="15000"/>
+            </a:spcAft>
+            <a:buFont typeface="Wingdings" panose="05000000000000000000" pitchFamily="2" charset="2"/>
+            <a:buChar char="Ø"/>
+          </a:pPr>
+          <a:r>
+            <a:rPr lang="en-SG" sz="1400" kern="1200" dirty="0"/>
+            <a:t> </a:t>
           </a:r>
           <a:r>
-            <a:rPr lang="en-SG" sz="1400" kern="1200" dirty="0"/>
-            <a:t>— </a:t>
+            <a:rPr lang="en-SG" sz="1400" b="0" kern="1200" dirty="0"/>
+            <a:t>Introduce </a:t>
           </a:r>
           <a:r>
             <a:rPr lang="en-SG" sz="1400" b="1" kern="1200" dirty="0"/>
-            <a:t>Deep Models (Two-Tower) with rich features</a:t>
+            <a:t>train/validation/test split with hyperparameter tuning and calibration to improve generalization</a:t>
           </a:r>
-          <a:endParaRPr lang="en-SG" sz="1400" kern="1200" dirty="0"/>
         </a:p>
       </dsp:txBody>
       <dsp:txXfrm>
-        <a:off x="0" y="271875"/>
-        <a:ext cx="10009185" cy="2945250"/>
+        <a:off x="0" y="175182"/>
+        <a:ext cx="10114372" cy="3465000"/>
       </dsp:txXfrm>
     </dsp:sp>
     <dsp:sp modelId="{098EEF58-BE4A-4205-A3D1-3F9A5D14AD06}">
@@ -12459,8 +13778,8 @@
       </dsp:nvSpPr>
       <dsp:spPr>
         <a:xfrm>
-          <a:off x="500459" y="20955"/>
-          <a:ext cx="7006429" cy="501840"/>
+          <a:off x="505718" y="12822"/>
+          <a:ext cx="7080060" cy="324720"/>
         </a:xfrm>
         <a:prstGeom prst="roundRect">
           <a:avLst/>
@@ -12501,7 +13820,7 @@
         </a:fontRef>
       </dsp:style>
       <dsp:txBody>
-        <a:bodyPr spcFirstLastPara="0" vert="horz" wrap="square" lIns="264826" tIns="0" rIns="264826" bIns="0" numCol="1" spcCol="1270" anchor="ctr" anchorCtr="0">
+        <a:bodyPr spcFirstLastPara="0" vert="horz" wrap="square" lIns="267609" tIns="0" rIns="267609" bIns="0" numCol="1" spcCol="1270" anchor="ctr" anchorCtr="0">
           <a:noAutofit/>
         </a:bodyPr>
         <a:lstStyle/>
@@ -12526,8 +13845,8 @@
         </a:p>
       </dsp:txBody>
       <dsp:txXfrm>
-        <a:off x="524957" y="45453"/>
-        <a:ext cx="6957433" cy="452844"/>
+        <a:off x="521570" y="28674"/>
+        <a:ext cx="7048356" cy="293016"/>
       </dsp:txXfrm>
     </dsp:sp>
     <dsp:sp modelId="{2981F39D-A336-4BB9-9956-AE5D996342D5}">
@@ -12537,8 +13856,8 @@
       </dsp:nvSpPr>
       <dsp:spPr>
         <a:xfrm>
-          <a:off x="0" y="3559845"/>
-          <a:ext cx="10009185" cy="1124550"/>
+          <a:off x="0" y="3861942"/>
+          <a:ext cx="10114372" cy="987525"/>
         </a:xfrm>
         <a:prstGeom prst="rect">
           <a:avLst/>
@@ -12578,7 +13897,7 @@
         <a:fontRef idx="minor"/>
       </dsp:style>
       <dsp:txBody>
-        <a:bodyPr spcFirstLastPara="0" vert="horz" wrap="square" lIns="776824" tIns="354076" rIns="776824" bIns="99568" numCol="1" spcCol="1270" anchor="t" anchorCtr="0">
+        <a:bodyPr spcFirstLastPara="0" vert="horz" wrap="square" lIns="784988" tIns="229108" rIns="784988" bIns="99568" numCol="1" spcCol="1270" anchor="t" anchorCtr="0">
           <a:noAutofit/>
         </a:bodyPr>
         <a:lstStyle/>
@@ -12651,8 +13970,8 @@
         </a:p>
       </dsp:txBody>
       <dsp:txXfrm>
-        <a:off x="0" y="3559845"/>
-        <a:ext cx="10009185" cy="1124550"/>
+        <a:off x="0" y="3861942"/>
+        <a:ext cx="10114372" cy="987525"/>
       </dsp:txXfrm>
     </dsp:sp>
     <dsp:sp modelId="{F0519E15-B7D6-48BA-B397-B1714BED6080}">
@@ -12662,8 +13981,8 @@
       </dsp:nvSpPr>
       <dsp:spPr>
         <a:xfrm>
-          <a:off x="500459" y="3308925"/>
-          <a:ext cx="7006429" cy="501840"/>
+          <a:off x="505718" y="3699582"/>
+          <a:ext cx="7080060" cy="324720"/>
         </a:xfrm>
         <a:prstGeom prst="roundRect">
           <a:avLst/>
@@ -12704,7 +14023,7 @@
         </a:fontRef>
       </dsp:style>
       <dsp:txBody>
-        <a:bodyPr spcFirstLastPara="0" vert="horz" wrap="square" lIns="264826" tIns="0" rIns="264826" bIns="0" numCol="1" spcCol="1270" anchor="ctr" anchorCtr="0">
+        <a:bodyPr spcFirstLastPara="0" vert="horz" wrap="square" lIns="267609" tIns="0" rIns="267609" bIns="0" numCol="1" spcCol="1270" anchor="ctr" anchorCtr="0">
           <a:noAutofit/>
         </a:bodyPr>
         <a:lstStyle/>
@@ -12728,8 +14047,8 @@
         </a:p>
       </dsp:txBody>
       <dsp:txXfrm>
-        <a:off x="524957" y="3333423"/>
-        <a:ext cx="6957433" cy="452844"/>
+        <a:off x="521570" y="3715434"/>
+        <a:ext cx="7048356" cy="293016"/>
       </dsp:txXfrm>
     </dsp:sp>
   </dsp:spTree>
@@ -15001,8 +16320,8 @@
       </dsp:nvSpPr>
       <dsp:spPr>
         <a:xfrm>
-          <a:off x="0" y="259737"/>
-          <a:ext cx="9085007" cy="774900"/>
+          <a:off x="0" y="174339"/>
+          <a:ext cx="9075727" cy="727650"/>
         </a:xfrm>
         <a:prstGeom prst="rect">
           <a:avLst/>
@@ -15042,7 +16361,7 @@
         <a:fontRef idx="minor"/>
       </dsp:style>
       <dsp:txBody>
-        <a:bodyPr spcFirstLastPara="0" vert="horz" wrap="square" lIns="705097" tIns="249936" rIns="705097" bIns="99568" numCol="1" spcCol="1270" anchor="t" anchorCtr="0">
+        <a:bodyPr spcFirstLastPara="0" vert="horz" wrap="square" lIns="704377" tIns="229108" rIns="704377" bIns="99568" numCol="1" spcCol="1270" anchor="t" anchorCtr="0">
           <a:noAutofit/>
         </a:bodyPr>
         <a:lstStyle/>
@@ -15061,19 +16380,14 @@
             <a:buChar char="Ø"/>
           </a:pPr>
           <a:r>
-            <a:rPr lang="en-SG" sz="1400" b="1" kern="1200" dirty="0"/>
-            <a:t> </a:t>
-          </a:r>
-          <a:r>
             <a:rPr lang="en-SG" sz="1400" b="0" kern="1200" dirty="0"/>
-            <a:t>Move beyond popularity baseline as interaction data grows
- Use collaborative filtering (TruncatedSVD) to improve relevance</a:t>
+            <a:t> Introduce train/validation/test split with hyperparameter tuning and calibration to improve generalization</a:t>
           </a:r>
         </a:p>
       </dsp:txBody>
       <dsp:txXfrm>
-        <a:off x="0" y="259737"/>
-        <a:ext cx="9085007" cy="774900"/>
+        <a:off x="0" y="174339"/>
+        <a:ext cx="9075727" cy="727650"/>
       </dsp:txXfrm>
     </dsp:sp>
     <dsp:sp modelId="{73D61383-A059-4CF8-9A37-12E533FCFC22}">
@@ -15083,8 +16397,8 @@
       </dsp:nvSpPr>
       <dsp:spPr>
         <a:xfrm>
-          <a:off x="454250" y="82617"/>
-          <a:ext cx="6359504" cy="354240"/>
+          <a:off x="453786" y="11979"/>
+          <a:ext cx="6353008" cy="324720"/>
         </a:xfrm>
         <a:prstGeom prst="roundRect">
           <a:avLst/>
@@ -15125,7 +16439,7 @@
         </a:fontRef>
       </dsp:style>
       <dsp:txBody>
-        <a:bodyPr spcFirstLastPara="0" vert="horz" wrap="square" lIns="240374" tIns="0" rIns="240374" bIns="0" numCol="1" spcCol="1270" anchor="ctr" anchorCtr="0">
+        <a:bodyPr spcFirstLastPara="0" vert="horz" wrap="square" lIns="240129" tIns="0" rIns="240129" bIns="0" numCol="1" spcCol="1270" anchor="ctr" anchorCtr="0">
           <a:noAutofit/>
         </a:bodyPr>
         <a:lstStyle/>
@@ -15145,24 +16459,24 @@
           </a:pPr>
           <a:r>
             <a:rPr lang="en-SG" sz="1400" b="1" kern="1200" dirty="0"/>
-            <a:t>Prioritize personalized ranking when sufficient data is observed</a:t>
+            <a:t>Modeling robustness &amp; generalization</a:t>
           </a:r>
         </a:p>
       </dsp:txBody>
       <dsp:txXfrm>
-        <a:off x="471543" y="99910"/>
-        <a:ext cx="6324918" cy="319654"/>
+        <a:off x="469638" y="27831"/>
+        <a:ext cx="6321304" cy="293016"/>
       </dsp:txXfrm>
     </dsp:sp>
-    <dsp:sp modelId="{7917C87B-6C84-46AC-A0CC-40146E8D0C31}">
+    <dsp:sp modelId="{323AA25F-4521-439B-ABE8-76D0915CA15E}">
       <dsp:nvSpPr>
         <dsp:cNvPr id="0" name=""/>
         <dsp:cNvSpPr/>
       </dsp:nvSpPr>
       <dsp:spPr>
         <a:xfrm>
-          <a:off x="0" y="1276557"/>
-          <a:ext cx="9085007" cy="774900"/>
+          <a:off x="0" y="1123749"/>
+          <a:ext cx="9075727" cy="762300"/>
         </a:xfrm>
         <a:prstGeom prst="rect">
           <a:avLst/>
@@ -15202,7 +16516,7 @@
         <a:fontRef idx="minor"/>
       </dsp:style>
       <dsp:txBody>
-        <a:bodyPr spcFirstLastPara="0" vert="horz" wrap="square" lIns="705097" tIns="249936" rIns="705097" bIns="99568" numCol="1" spcCol="1270" anchor="t" anchorCtr="0">
+        <a:bodyPr spcFirstLastPara="0" vert="horz" wrap="square" lIns="704377" tIns="229108" rIns="704377" bIns="99568" numCol="1" spcCol="1270" anchor="t" anchorCtr="0">
           <a:noAutofit/>
         </a:bodyPr>
         <a:lstStyle/>
@@ -15221,31 +16535,30 @@
             <a:buChar char="Ø"/>
           </a:pPr>
           <a:r>
-            <a:rPr lang="en-SG" sz="1400" b="0" kern="1200" dirty="0"/>
-            <a:t> Start with a simple single-stage ranking setup
- Transition to multi-stage retrieval + ranking only when scale </a:t>
+            <a:rPr lang="en-SG" sz="1400" b="1" kern="1200" dirty="0"/>
+            <a:t> </a:t>
           </a:r>
           <a:r>
-            <a:rPr lang="en-SG" sz="1400" b="0" kern="1200"/>
-            <a:t>justifies it</a:t>
+            <a:rPr lang="en-SG" sz="1400" b="0" kern="1200" dirty="0"/>
+            <a:t>Move beyond popularity baseline as interaction data grows
+ Use collaborative filtering (TruncatedSVD) to improve relevance</a:t>
           </a:r>
-          <a:endParaRPr lang="en-SG" sz="1400" b="0" kern="1200" dirty="0"/>
         </a:p>
       </dsp:txBody>
       <dsp:txXfrm>
-        <a:off x="0" y="1276557"/>
-        <a:ext cx="9085007" cy="774900"/>
+        <a:off x="0" y="1123749"/>
+        <a:ext cx="9075727" cy="762300"/>
       </dsp:txXfrm>
     </dsp:sp>
-    <dsp:sp modelId="{7BA4BE36-552F-4B25-BF78-14B70D0E15A7}">
+    <dsp:sp modelId="{6E6F8F08-80B1-4ED5-9535-177F20B67890}">
       <dsp:nvSpPr>
         <dsp:cNvPr id="0" name=""/>
         <dsp:cNvSpPr/>
       </dsp:nvSpPr>
       <dsp:spPr>
         <a:xfrm>
-          <a:off x="454250" y="1099437"/>
-          <a:ext cx="6359504" cy="354240"/>
+          <a:off x="453786" y="961389"/>
+          <a:ext cx="6353008" cy="324720"/>
         </a:xfrm>
         <a:prstGeom prst="roundRect">
           <a:avLst/>
@@ -15286,7 +16599,7 @@
         </a:fontRef>
       </dsp:style>
       <dsp:txBody>
-        <a:bodyPr spcFirstLastPara="0" vert="horz" wrap="square" lIns="240374" tIns="0" rIns="240374" bIns="0" numCol="1" spcCol="1270" anchor="ctr" anchorCtr="0">
+        <a:bodyPr spcFirstLastPara="0" vert="horz" wrap="square" lIns="240129" tIns="0" rIns="240129" bIns="0" numCol="1" spcCol="1270" anchor="ctr" anchorCtr="0">
           <a:noAutofit/>
         </a:bodyPr>
         <a:lstStyle/>
@@ -15305,25 +16618,26 @@
             <a:buNone/>
           </a:pPr>
           <a:r>
-            <a:rPr lang="en-SG" sz="1400" b="1" kern="1200" dirty="0"/>
-            <a:t>Evolve system complexity in stages</a:t>
+            <a:rPr lang="en-SG" sz="1400" b="1" kern="1200"/>
+            <a:t>Prioritize personalized ranking when sufficient data is observed</a:t>
           </a:r>
+          <a:endParaRPr lang="en-SG" sz="1400" b="1" kern="1200" dirty="0"/>
         </a:p>
       </dsp:txBody>
       <dsp:txXfrm>
-        <a:off x="471543" y="1116730"/>
-        <a:ext cx="6324918" cy="319654"/>
+        <a:off x="469638" y="977241"/>
+        <a:ext cx="6321304" cy="293016"/>
       </dsp:txXfrm>
     </dsp:sp>
-    <dsp:sp modelId="{1CAA899B-F6E6-4429-82FC-1AAFA4443513}">
+    <dsp:sp modelId="{7917C87B-6C84-46AC-A0CC-40146E8D0C31}">
       <dsp:nvSpPr>
         <dsp:cNvPr id="0" name=""/>
         <dsp:cNvSpPr/>
       </dsp:nvSpPr>
       <dsp:spPr>
         <a:xfrm>
-          <a:off x="0" y="2293377"/>
-          <a:ext cx="9085007" cy="1020600"/>
+          <a:off x="0" y="2107809"/>
+          <a:ext cx="9075727" cy="762300"/>
         </a:xfrm>
         <a:prstGeom prst="rect">
           <a:avLst/>
@@ -15363,7 +16677,7 @@
         <a:fontRef idx="minor"/>
       </dsp:style>
       <dsp:txBody>
-        <a:bodyPr spcFirstLastPara="0" vert="horz" wrap="square" lIns="705097" tIns="249936" rIns="705097" bIns="99568" numCol="1" spcCol="1270" anchor="t" anchorCtr="0">
+        <a:bodyPr spcFirstLastPara="0" vert="horz" wrap="square" lIns="704377" tIns="229108" rIns="704377" bIns="99568" numCol="1" spcCol="1270" anchor="t" anchorCtr="0">
           <a:noAutofit/>
         </a:bodyPr>
         <a:lstStyle/>
@@ -15383,27 +16697,25 @@
           </a:pPr>
           <a:r>
             <a:rPr lang="en-SG" sz="1400" b="0" kern="1200" dirty="0"/>
-            <a:t> Use popularity or simple heuristics as a fallback when interaction data is unavailable
- Incorporate lightweight signals (e.g., onboarding preferences or item metadata)
- Upgrade to personalized models after cold start is no longer an issue</a:t>
+            <a:t> Start with a simple single-stage ranking setup
+ Transition to multi-stage retrieval + ranking only when scale justifies it</a:t>
           </a:r>
-          <a:endParaRPr lang="en-SG" sz="1400" b="1" kern="1200" dirty="0"/>
         </a:p>
       </dsp:txBody>
       <dsp:txXfrm>
-        <a:off x="0" y="2293377"/>
-        <a:ext cx="9085007" cy="1020600"/>
+        <a:off x="0" y="2107809"/>
+        <a:ext cx="9075727" cy="762300"/>
       </dsp:txXfrm>
     </dsp:sp>
-    <dsp:sp modelId="{BB4727C1-D41B-423B-93AE-9DC77DA899D5}">
+    <dsp:sp modelId="{7BA4BE36-552F-4B25-BF78-14B70D0E15A7}">
       <dsp:nvSpPr>
         <dsp:cNvPr id="0" name=""/>
         <dsp:cNvSpPr/>
       </dsp:nvSpPr>
       <dsp:spPr>
         <a:xfrm>
-          <a:off x="454250" y="2116257"/>
-          <a:ext cx="6359504" cy="354240"/>
+          <a:off x="453786" y="1945449"/>
+          <a:ext cx="6353008" cy="324720"/>
         </a:xfrm>
         <a:prstGeom prst="roundRect">
           <a:avLst/>
@@ -15444,7 +16756,7 @@
         </a:fontRef>
       </dsp:style>
       <dsp:txBody>
-        <a:bodyPr spcFirstLastPara="0" vert="horz" wrap="square" lIns="240374" tIns="0" rIns="240374" bIns="0" numCol="1" spcCol="1270" anchor="ctr" anchorCtr="0">
+        <a:bodyPr spcFirstLastPara="0" vert="horz" wrap="square" lIns="240129" tIns="0" rIns="240129" bIns="0" numCol="1" spcCol="1270" anchor="ctr" anchorCtr="0">
           <a:noAutofit/>
         </a:bodyPr>
         <a:lstStyle/>
@@ -15459,28 +16771,29 @@
             <a:spcAft>
               <a:spcPct val="35000"/>
             </a:spcAft>
+            <a:buFont typeface="Wingdings" panose="05000000000000000000" pitchFamily="2" charset="2"/>
             <a:buNone/>
           </a:pPr>
           <a:r>
             <a:rPr lang="en-SG" sz="1400" b="1" kern="1200" dirty="0"/>
-            <a:t>Plan explicit fallback strategies for cold start</a:t>
+            <a:t>Evolve system complexity in stages</a:t>
           </a:r>
         </a:p>
       </dsp:txBody>
       <dsp:txXfrm>
-        <a:off x="471543" y="2133550"/>
-        <a:ext cx="6324918" cy="319654"/>
+        <a:off x="469638" y="1961301"/>
+        <a:ext cx="6321304" cy="293016"/>
       </dsp:txXfrm>
     </dsp:sp>
-    <dsp:sp modelId="{7A89284A-AC1B-4D70-9B1C-ADAF07F66E34}">
+    <dsp:sp modelId="{1CAA899B-F6E6-4429-82FC-1AAFA4443513}">
       <dsp:nvSpPr>
         <dsp:cNvPr id="0" name=""/>
         <dsp:cNvSpPr/>
       </dsp:nvSpPr>
       <dsp:spPr>
         <a:xfrm>
-          <a:off x="0" y="3555552"/>
-          <a:ext cx="9085007" cy="774900"/>
+          <a:off x="0" y="3091869"/>
+          <a:ext cx="9075727" cy="987525"/>
         </a:xfrm>
         <a:prstGeom prst="rect">
           <a:avLst/>
@@ -15520,7 +16833,164 @@
         <a:fontRef idx="minor"/>
       </dsp:style>
       <dsp:txBody>
-        <a:bodyPr spcFirstLastPara="0" vert="horz" wrap="square" lIns="705097" tIns="249936" rIns="705097" bIns="99568" numCol="1" spcCol="1270" anchor="t" anchorCtr="0">
+        <a:bodyPr spcFirstLastPara="0" vert="horz" wrap="square" lIns="704377" tIns="229108" rIns="704377" bIns="99568" numCol="1" spcCol="1270" anchor="t" anchorCtr="0">
+          <a:noAutofit/>
+        </a:bodyPr>
+        <a:lstStyle/>
+        <a:p>
+          <a:pPr marL="114300" lvl="1" indent="-114300" algn="l" defTabSz="622300">
+            <a:lnSpc>
+              <a:spcPct val="90000"/>
+            </a:lnSpc>
+            <a:spcBef>
+              <a:spcPct val="0"/>
+            </a:spcBef>
+            <a:spcAft>
+              <a:spcPct val="15000"/>
+            </a:spcAft>
+            <a:buFont typeface="Wingdings" panose="05000000000000000000" pitchFamily="2" charset="2"/>
+            <a:buChar char="Ø"/>
+          </a:pPr>
+          <a:r>
+            <a:rPr lang="en-SG" sz="1400" b="0" kern="1200" dirty="0"/>
+            <a:t> Use popularity or simple heuristics as a fallback when interaction data is unavailable
+ Incorporate lightweight signals (e.g., onboarding preferences or item metadata)
+ Upgrade to personalized models after cold start is no longer an issue</a:t>
+          </a:r>
+          <a:endParaRPr lang="en-SG" sz="1400" b="1" kern="1200" dirty="0"/>
+        </a:p>
+      </dsp:txBody>
+      <dsp:txXfrm>
+        <a:off x="0" y="3091869"/>
+        <a:ext cx="9075727" cy="987525"/>
+      </dsp:txXfrm>
+    </dsp:sp>
+    <dsp:sp modelId="{BB4727C1-D41B-423B-93AE-9DC77DA899D5}">
+      <dsp:nvSpPr>
+        <dsp:cNvPr id="0" name=""/>
+        <dsp:cNvSpPr/>
+      </dsp:nvSpPr>
+      <dsp:spPr>
+        <a:xfrm>
+          <a:off x="453786" y="2929509"/>
+          <a:ext cx="6353008" cy="324720"/>
+        </a:xfrm>
+        <a:prstGeom prst="roundRect">
+          <a:avLst/>
+        </a:prstGeom>
+        <a:solidFill>
+          <a:schemeClr val="accent1">
+            <a:hueOff val="0"/>
+            <a:satOff val="0"/>
+            <a:lumOff val="0"/>
+            <a:alphaOff val="0"/>
+          </a:schemeClr>
+        </a:solidFill>
+        <a:ln w="15875" cap="rnd" cmpd="sng" algn="ctr">
+          <a:solidFill>
+            <a:schemeClr val="lt1">
+              <a:hueOff val="0"/>
+              <a:satOff val="0"/>
+              <a:lumOff val="0"/>
+              <a:alphaOff val="0"/>
+            </a:schemeClr>
+          </a:solidFill>
+          <a:prstDash val="solid"/>
+        </a:ln>
+        <a:effectLst/>
+      </dsp:spPr>
+      <dsp:style>
+        <a:lnRef idx="2">
+          <a:scrgbClr r="0" g="0" b="0"/>
+        </a:lnRef>
+        <a:fillRef idx="1">
+          <a:scrgbClr r="0" g="0" b="0"/>
+        </a:fillRef>
+        <a:effectRef idx="0">
+          <a:scrgbClr r="0" g="0" b="0"/>
+        </a:effectRef>
+        <a:fontRef idx="minor">
+          <a:schemeClr val="lt1"/>
+        </a:fontRef>
+      </dsp:style>
+      <dsp:txBody>
+        <a:bodyPr spcFirstLastPara="0" vert="horz" wrap="square" lIns="240129" tIns="0" rIns="240129" bIns="0" numCol="1" spcCol="1270" anchor="ctr" anchorCtr="0">
+          <a:noAutofit/>
+        </a:bodyPr>
+        <a:lstStyle/>
+        <a:p>
+          <a:pPr marL="0" lvl="0" indent="0" algn="l" defTabSz="622300">
+            <a:lnSpc>
+              <a:spcPct val="90000"/>
+            </a:lnSpc>
+            <a:spcBef>
+              <a:spcPct val="0"/>
+            </a:spcBef>
+            <a:spcAft>
+              <a:spcPct val="35000"/>
+            </a:spcAft>
+            <a:buNone/>
+          </a:pPr>
+          <a:r>
+            <a:rPr lang="en-SG" sz="1400" b="1" kern="1200" dirty="0"/>
+            <a:t>Plan explicit fallback strategies for cold start</a:t>
+          </a:r>
+        </a:p>
+      </dsp:txBody>
+      <dsp:txXfrm>
+        <a:off x="469638" y="2945361"/>
+        <a:ext cx="6321304" cy="293016"/>
+      </dsp:txXfrm>
+    </dsp:sp>
+    <dsp:sp modelId="{7A89284A-AC1B-4D70-9B1C-ADAF07F66E34}">
+      <dsp:nvSpPr>
+        <dsp:cNvPr id="0" name=""/>
+        <dsp:cNvSpPr/>
+      </dsp:nvSpPr>
+      <dsp:spPr>
+        <a:xfrm>
+          <a:off x="0" y="4300837"/>
+          <a:ext cx="9075727" cy="762300"/>
+        </a:xfrm>
+        <a:prstGeom prst="rect">
+          <a:avLst/>
+        </a:prstGeom>
+        <a:solidFill>
+          <a:schemeClr val="lt1">
+            <a:alpha val="90000"/>
+            <a:hueOff val="0"/>
+            <a:satOff val="0"/>
+            <a:lumOff val="0"/>
+            <a:alphaOff val="0"/>
+          </a:schemeClr>
+        </a:solidFill>
+        <a:ln w="15875" cap="rnd" cmpd="sng" algn="ctr">
+          <a:solidFill>
+            <a:schemeClr val="accent1">
+              <a:hueOff val="0"/>
+              <a:satOff val="0"/>
+              <a:lumOff val="0"/>
+              <a:alphaOff val="0"/>
+            </a:schemeClr>
+          </a:solidFill>
+          <a:prstDash val="solid"/>
+        </a:ln>
+        <a:effectLst/>
+      </dsp:spPr>
+      <dsp:style>
+        <a:lnRef idx="2">
+          <a:scrgbClr r="0" g="0" b="0"/>
+        </a:lnRef>
+        <a:fillRef idx="1">
+          <a:scrgbClr r="0" g="0" b="0"/>
+        </a:fillRef>
+        <a:effectRef idx="0">
+          <a:scrgbClr r="0" g="0" b="0"/>
+        </a:effectRef>
+        <a:fontRef idx="minor"/>
+      </dsp:style>
+      <dsp:txBody>
+        <a:bodyPr spcFirstLastPara="0" vert="horz" wrap="square" lIns="704377" tIns="229108" rIns="704377" bIns="99568" numCol="1" spcCol="1270" anchor="t" anchorCtr="0">
           <a:noAutofit/>
         </a:bodyPr>
         <a:lstStyle/>
@@ -15566,8 +17036,8 @@
         </a:p>
       </dsp:txBody>
       <dsp:txXfrm>
-        <a:off x="0" y="3555552"/>
-        <a:ext cx="9085007" cy="774900"/>
+        <a:off x="0" y="4300837"/>
+        <a:ext cx="9075727" cy="762300"/>
       </dsp:txXfrm>
     </dsp:sp>
     <dsp:sp modelId="{BE6FFCE4-D821-4667-8F34-735CD66E39FD}">
@@ -15577,8 +17047,8 @@
       </dsp:nvSpPr>
       <dsp:spPr>
         <a:xfrm>
-          <a:off x="454250" y="3378777"/>
-          <a:ext cx="6359504" cy="354240"/>
+          <a:off x="453786" y="4138794"/>
+          <a:ext cx="6353008" cy="324720"/>
         </a:xfrm>
         <a:prstGeom prst="roundRect">
           <a:avLst/>
@@ -15619,7 +17089,7 @@
         </a:fontRef>
       </dsp:style>
       <dsp:txBody>
-        <a:bodyPr spcFirstLastPara="0" vert="horz" wrap="square" lIns="240374" tIns="0" rIns="240374" bIns="0" numCol="1" spcCol="1270" anchor="ctr" anchorCtr="0">
+        <a:bodyPr spcFirstLastPara="0" vert="horz" wrap="square" lIns="240129" tIns="0" rIns="240129" bIns="0" numCol="1" spcCol="1270" anchor="ctr" anchorCtr="0">
           <a:noAutofit/>
         </a:bodyPr>
         <a:lstStyle/>
@@ -15643,8 +17113,352 @@
         </a:p>
       </dsp:txBody>
       <dsp:txXfrm>
-        <a:off x="471543" y="3396070"/>
-        <a:ext cx="6324918" cy="319654"/>
+        <a:off x="469638" y="4154646"/>
+        <a:ext cx="6321304" cy="293016"/>
+      </dsp:txXfrm>
+    </dsp:sp>
+  </dsp:spTree>
+</dsp:drawing>
+</file>
+
+<file path=ppt/diagrams/drawing9.xml><?xml version="1.0" encoding="utf-8"?>
+<dsp:drawing xmlns:dgm="http://schemas.openxmlformats.org/drawingml/2006/diagram" xmlns:dsp="http://schemas.microsoft.com/office/drawing/2008/diagram" xmlns:a="http://schemas.openxmlformats.org/drawingml/2006/main">
+  <dsp:spTree>
+    <dsp:nvGrpSpPr>
+      <dsp:cNvPr id="0" name=""/>
+      <dsp:cNvGrpSpPr/>
+    </dsp:nvGrpSpPr>
+    <dsp:grpSpPr/>
+    <dsp:sp modelId="{81AB0DB0-4359-4ABA-B7E8-9D326E119CD8}">
+      <dsp:nvSpPr>
+        <dsp:cNvPr id="0" name=""/>
+        <dsp:cNvSpPr/>
+      </dsp:nvSpPr>
+      <dsp:spPr>
+        <a:xfrm>
+          <a:off x="0" y="286789"/>
+          <a:ext cx="8890792" cy="1406475"/>
+        </a:xfrm>
+        <a:prstGeom prst="rect">
+          <a:avLst/>
+        </a:prstGeom>
+        <a:solidFill>
+          <a:schemeClr val="lt1">
+            <a:alpha val="90000"/>
+            <a:hueOff val="0"/>
+            <a:satOff val="0"/>
+            <a:lumOff val="0"/>
+            <a:alphaOff val="0"/>
+          </a:schemeClr>
+        </a:solidFill>
+        <a:ln w="15875" cap="rnd" cmpd="sng" algn="ctr">
+          <a:solidFill>
+            <a:schemeClr val="accent1">
+              <a:hueOff val="0"/>
+              <a:satOff val="0"/>
+              <a:lumOff val="0"/>
+              <a:alphaOff val="0"/>
+            </a:schemeClr>
+          </a:solidFill>
+          <a:prstDash val="solid"/>
+        </a:ln>
+        <a:effectLst/>
+      </dsp:spPr>
+      <dsp:style>
+        <a:lnRef idx="2">
+          <a:scrgbClr r="0" g="0" b="0"/>
+        </a:lnRef>
+        <a:fillRef idx="1">
+          <a:scrgbClr r="0" g="0" b="0"/>
+        </a:fillRef>
+        <a:effectRef idx="0">
+          <a:scrgbClr r="0" g="0" b="0"/>
+        </a:effectRef>
+        <a:fontRef idx="minor"/>
+      </dsp:style>
+      <dsp:txBody>
+        <a:bodyPr spcFirstLastPara="0" vert="horz" wrap="square" lIns="690024" tIns="395732" rIns="690024" bIns="99568" numCol="1" spcCol="1270" anchor="t" anchorCtr="0">
+          <a:noAutofit/>
+        </a:bodyPr>
+        <a:lstStyle/>
+        <a:p>
+          <a:pPr marL="114300" lvl="1" indent="-114300" algn="l" defTabSz="622300">
+            <a:lnSpc>
+              <a:spcPct val="90000"/>
+            </a:lnSpc>
+            <a:spcBef>
+              <a:spcPct val="0"/>
+            </a:spcBef>
+            <a:spcAft>
+              <a:spcPct val="15000"/>
+            </a:spcAft>
+            <a:buFont typeface="Wingdings" panose="05000000000000000000" pitchFamily="2" charset="2"/>
+            <a:buChar char="Ø"/>
+          </a:pPr>
+          <a:r>
+            <a:rPr lang="en-SG" sz="1400" b="0" kern="1200" dirty="0"/>
+            <a:t> TensorFlow / PyTorch recommender implementations
+ Neural ranking models with contrastive-style training (positive &amp; negative sampling)
+ Practical training practices across frameworks (TensorFlow / PyTorch)</a:t>
+          </a:r>
+        </a:p>
+        <a:p>
+          <a:pPr marL="114300" lvl="1" indent="-114300" algn="l" defTabSz="622300">
+            <a:lnSpc>
+              <a:spcPct val="90000"/>
+            </a:lnSpc>
+            <a:spcBef>
+              <a:spcPct val="0"/>
+            </a:spcBef>
+            <a:spcAft>
+              <a:spcPct val="15000"/>
+            </a:spcAft>
+            <a:buFont typeface="Wingdings" panose="05000000000000000000" pitchFamily="2" charset="2"/>
+            <a:buChar char="Ø"/>
+          </a:pPr>
+          <a:r>
+            <a:rPr lang="en-SG" sz="1400" b="0" kern="1200" dirty="0"/>
+            <a:t> Practical ML/ Deep Learning Recommended Practices Memo</a:t>
+          </a:r>
+        </a:p>
+      </dsp:txBody>
+      <dsp:txXfrm>
+        <a:off x="0" y="286789"/>
+        <a:ext cx="8890792" cy="1406475"/>
+      </dsp:txXfrm>
+    </dsp:sp>
+    <dsp:sp modelId="{73D61383-A059-4CF8-9A37-12E533FCFC22}">
+      <dsp:nvSpPr>
+        <dsp:cNvPr id="0" name=""/>
+        <dsp:cNvSpPr/>
+      </dsp:nvSpPr>
+      <dsp:spPr>
+        <a:xfrm>
+          <a:off x="444539" y="6349"/>
+          <a:ext cx="6223554" cy="560880"/>
+        </a:xfrm>
+        <a:prstGeom prst="roundRect">
+          <a:avLst/>
+        </a:prstGeom>
+        <a:solidFill>
+          <a:schemeClr val="accent1">
+            <a:hueOff val="0"/>
+            <a:satOff val="0"/>
+            <a:lumOff val="0"/>
+            <a:alphaOff val="0"/>
+          </a:schemeClr>
+        </a:solidFill>
+        <a:ln w="15875" cap="rnd" cmpd="sng" algn="ctr">
+          <a:solidFill>
+            <a:schemeClr val="lt1">
+              <a:hueOff val="0"/>
+              <a:satOff val="0"/>
+              <a:lumOff val="0"/>
+              <a:alphaOff val="0"/>
+            </a:schemeClr>
+          </a:solidFill>
+          <a:prstDash val="solid"/>
+        </a:ln>
+        <a:effectLst/>
+      </dsp:spPr>
+      <dsp:style>
+        <a:lnRef idx="2">
+          <a:scrgbClr r="0" g="0" b="0"/>
+        </a:lnRef>
+        <a:fillRef idx="1">
+          <a:scrgbClr r="0" g="0" b="0"/>
+        </a:fillRef>
+        <a:effectRef idx="0">
+          <a:scrgbClr r="0" g="0" b="0"/>
+        </a:effectRef>
+        <a:fontRef idx="minor">
+          <a:schemeClr val="lt1"/>
+        </a:fontRef>
+      </dsp:style>
+      <dsp:txBody>
+        <a:bodyPr spcFirstLastPara="0" vert="horz" wrap="square" lIns="235236" tIns="0" rIns="235236" bIns="0" numCol="1" spcCol="1270" anchor="ctr" anchorCtr="0">
+          <a:noAutofit/>
+        </a:bodyPr>
+        <a:lstStyle/>
+        <a:p>
+          <a:pPr marL="0" lvl="0" indent="0" algn="l" defTabSz="622300">
+            <a:lnSpc>
+              <a:spcPct val="90000"/>
+            </a:lnSpc>
+            <a:spcBef>
+              <a:spcPct val="0"/>
+            </a:spcBef>
+            <a:spcAft>
+              <a:spcPct val="35000"/>
+            </a:spcAft>
+            <a:buFont typeface="Wingdings" panose="05000000000000000000" pitchFamily="2" charset="2"/>
+            <a:buNone/>
+          </a:pPr>
+          <a:r>
+            <a:rPr lang="en-SG" sz="1400" b="1" kern="1200" dirty="0"/>
+            <a:t>Extended Neural Model Demos (Lightweight)</a:t>
+          </a:r>
+        </a:p>
+      </dsp:txBody>
+      <dsp:txXfrm>
+        <a:off x="471919" y="33729"/>
+        <a:ext cx="6168794" cy="506120"/>
+      </dsp:txXfrm>
+    </dsp:sp>
+    <dsp:sp modelId="{7917C87B-6C84-46AC-A0CC-40146E8D0C31}">
+      <dsp:nvSpPr>
+        <dsp:cNvPr id="0" name=""/>
+        <dsp:cNvSpPr/>
+      </dsp:nvSpPr>
+      <dsp:spPr>
+        <a:xfrm>
+          <a:off x="0" y="2076304"/>
+          <a:ext cx="8890792" cy="927675"/>
+        </a:xfrm>
+        <a:prstGeom prst="rect">
+          <a:avLst/>
+        </a:prstGeom>
+        <a:solidFill>
+          <a:schemeClr val="lt1">
+            <a:alpha val="90000"/>
+            <a:hueOff val="0"/>
+            <a:satOff val="0"/>
+            <a:lumOff val="0"/>
+            <a:alphaOff val="0"/>
+          </a:schemeClr>
+        </a:solidFill>
+        <a:ln w="15875" cap="rnd" cmpd="sng" algn="ctr">
+          <a:solidFill>
+            <a:schemeClr val="accent1">
+              <a:hueOff val="0"/>
+              <a:satOff val="0"/>
+              <a:lumOff val="0"/>
+              <a:alphaOff val="0"/>
+            </a:schemeClr>
+          </a:solidFill>
+          <a:prstDash val="solid"/>
+        </a:ln>
+        <a:effectLst/>
+      </dsp:spPr>
+      <dsp:style>
+        <a:lnRef idx="2">
+          <a:scrgbClr r="0" g="0" b="0"/>
+        </a:lnRef>
+        <a:fillRef idx="1">
+          <a:scrgbClr r="0" g="0" b="0"/>
+        </a:fillRef>
+        <a:effectRef idx="0">
+          <a:scrgbClr r="0" g="0" b="0"/>
+        </a:effectRef>
+        <a:fontRef idx="minor"/>
+      </dsp:style>
+      <dsp:txBody>
+        <a:bodyPr spcFirstLastPara="0" vert="horz" wrap="square" lIns="690024" tIns="395732" rIns="690024" bIns="99568" numCol="1" spcCol="1270" anchor="t" anchorCtr="0">
+          <a:noAutofit/>
+        </a:bodyPr>
+        <a:lstStyle/>
+        <a:p>
+          <a:pPr marL="114300" lvl="1" indent="-114300" algn="l" defTabSz="622300">
+            <a:lnSpc>
+              <a:spcPct val="90000"/>
+            </a:lnSpc>
+            <a:spcBef>
+              <a:spcPct val="0"/>
+            </a:spcBef>
+            <a:spcAft>
+              <a:spcPct val="15000"/>
+            </a:spcAft>
+            <a:buFont typeface="Wingdings" panose="05000000000000000000" pitchFamily="2" charset="2"/>
+            <a:buChar char="Ø"/>
+          </a:pPr>
+          <a:r>
+            <a:rPr lang="en-SG" sz="1400" b="0" kern="1200" dirty="0"/>
+            <a:t> Full notebooks and notes available in repository
+ Designed for reproducibility and further experimentation</a:t>
+          </a:r>
+        </a:p>
+      </dsp:txBody>
+      <dsp:txXfrm>
+        <a:off x="0" y="2076304"/>
+        <a:ext cx="8890792" cy="927675"/>
+      </dsp:txXfrm>
+    </dsp:sp>
+    <dsp:sp modelId="{7BA4BE36-552F-4B25-BF78-14B70D0E15A7}">
+      <dsp:nvSpPr>
+        <dsp:cNvPr id="0" name=""/>
+        <dsp:cNvSpPr/>
+      </dsp:nvSpPr>
+      <dsp:spPr>
+        <a:xfrm>
+          <a:off x="444539" y="1795864"/>
+          <a:ext cx="6223554" cy="560880"/>
+        </a:xfrm>
+        <a:prstGeom prst="roundRect">
+          <a:avLst/>
+        </a:prstGeom>
+        <a:solidFill>
+          <a:schemeClr val="accent1">
+            <a:hueOff val="0"/>
+            <a:satOff val="0"/>
+            <a:lumOff val="0"/>
+            <a:alphaOff val="0"/>
+          </a:schemeClr>
+        </a:solidFill>
+        <a:ln w="15875" cap="rnd" cmpd="sng" algn="ctr">
+          <a:solidFill>
+            <a:schemeClr val="lt1">
+              <a:hueOff val="0"/>
+              <a:satOff val="0"/>
+              <a:lumOff val="0"/>
+              <a:alphaOff val="0"/>
+            </a:schemeClr>
+          </a:solidFill>
+          <a:prstDash val="solid"/>
+        </a:ln>
+        <a:effectLst/>
+      </dsp:spPr>
+      <dsp:style>
+        <a:lnRef idx="2">
+          <a:scrgbClr r="0" g="0" b="0"/>
+        </a:lnRef>
+        <a:fillRef idx="1">
+          <a:scrgbClr r="0" g="0" b="0"/>
+        </a:fillRef>
+        <a:effectRef idx="0">
+          <a:scrgbClr r="0" g="0" b="0"/>
+        </a:effectRef>
+        <a:fontRef idx="minor">
+          <a:schemeClr val="lt1"/>
+        </a:fontRef>
+      </dsp:style>
+      <dsp:txBody>
+        <a:bodyPr spcFirstLastPara="0" vert="horz" wrap="square" lIns="235236" tIns="0" rIns="235236" bIns="0" numCol="1" spcCol="1270" anchor="ctr" anchorCtr="0">
+          <a:noAutofit/>
+        </a:bodyPr>
+        <a:lstStyle/>
+        <a:p>
+          <a:pPr marL="0" lvl="0" indent="0" algn="l" defTabSz="622300">
+            <a:lnSpc>
+              <a:spcPct val="90000"/>
+            </a:lnSpc>
+            <a:spcBef>
+              <a:spcPct val="0"/>
+            </a:spcBef>
+            <a:spcAft>
+              <a:spcPct val="35000"/>
+            </a:spcAft>
+            <a:buFont typeface="Wingdings" panose="05000000000000000000" pitchFamily="2" charset="2"/>
+            <a:buNone/>
+          </a:pPr>
+          <a:r>
+            <a:rPr lang="en-SG" sz="1400" b="1" kern="1200" dirty="0"/>
+            <a:t>Access</a:t>
+          </a:r>
+        </a:p>
+      </dsp:txBody>
+      <dsp:txXfrm>
+        <a:off x="471919" y="1823244"/>
+        <a:ext cx="6168794" cy="506120"/>
       </dsp:txXfrm>
     </dsp:sp>
   </dsp:spTree>
@@ -17375,6 +19189,231 @@
 </dgm:layoutDef>
 </file>
 
+<file path=ppt/diagrams/layout9.xml><?xml version="1.0" encoding="utf-8"?>
+<dgm:layoutDef xmlns:dgm="http://schemas.openxmlformats.org/drawingml/2006/diagram" xmlns:a="http://schemas.openxmlformats.org/drawingml/2006/main" uniqueId="urn:microsoft.com/office/officeart/2005/8/layout/list1">
+  <dgm:title val=""/>
+  <dgm:desc val=""/>
+  <dgm:catLst>
+    <dgm:cat type="list" pri="4000"/>
+  </dgm:catLst>
+  <dgm:sampData>
+    <dgm:dataModel>
+      <dgm:ptLst>
+        <dgm:pt modelId="0" type="doc"/>
+        <dgm:pt modelId="1">
+          <dgm:prSet phldr="1"/>
+        </dgm:pt>
+        <dgm:pt modelId="2">
+          <dgm:prSet phldr="1"/>
+        </dgm:pt>
+        <dgm:pt modelId="3">
+          <dgm:prSet phldr="1"/>
+        </dgm:pt>
+      </dgm:ptLst>
+      <dgm:cxnLst>
+        <dgm:cxn modelId="4" srcId="0" destId="1" srcOrd="0" destOrd="0"/>
+        <dgm:cxn modelId="5" srcId="0" destId="2" srcOrd="1" destOrd="0"/>
+        <dgm:cxn modelId="6" srcId="0" destId="3" srcOrd="2" destOrd="0"/>
+      </dgm:cxnLst>
+      <dgm:bg/>
+      <dgm:whole/>
+    </dgm:dataModel>
+  </dgm:sampData>
+  <dgm:styleData>
+    <dgm:dataModel>
+      <dgm:ptLst>
+        <dgm:pt modelId="0" type="doc"/>
+        <dgm:pt modelId="1"/>
+        <dgm:pt modelId="2"/>
+      </dgm:ptLst>
+      <dgm:cxnLst>
+        <dgm:cxn modelId="4" srcId="0" destId="1" srcOrd="0" destOrd="0"/>
+        <dgm:cxn modelId="5" srcId="0" destId="2" srcOrd="1" destOrd="0"/>
+      </dgm:cxnLst>
+      <dgm:bg/>
+      <dgm:whole/>
+    </dgm:dataModel>
+  </dgm:styleData>
+  <dgm:clrData>
+    <dgm:dataModel>
+      <dgm:ptLst>
+        <dgm:pt modelId="0" type="doc"/>
+        <dgm:pt modelId="1"/>
+        <dgm:pt modelId="2"/>
+        <dgm:pt modelId="3"/>
+        <dgm:pt modelId="4"/>
+      </dgm:ptLst>
+      <dgm:cxnLst>
+        <dgm:cxn modelId="5" srcId="0" destId="1" srcOrd="0" destOrd="0"/>
+        <dgm:cxn modelId="6" srcId="0" destId="2" srcOrd="1" destOrd="0"/>
+        <dgm:cxn modelId="7" srcId="0" destId="3" srcOrd="2" destOrd="0"/>
+        <dgm:cxn modelId="8" srcId="0" destId="4" srcOrd="3" destOrd="0"/>
+      </dgm:cxnLst>
+      <dgm:bg/>
+      <dgm:whole/>
+    </dgm:dataModel>
+  </dgm:clrData>
+  <dgm:layoutNode name="linear">
+    <dgm:varLst>
+      <dgm:dir/>
+      <dgm:animLvl val="lvl"/>
+      <dgm:resizeHandles val="exact"/>
+    </dgm:varLst>
+    <dgm:choose name="Name0">
+      <dgm:if name="Name1" func="var" arg="dir" op="equ" val="norm">
+        <dgm:alg type="lin">
+          <dgm:param type="linDir" val="fromT"/>
+          <dgm:param type="vertAlign" val="mid"/>
+          <dgm:param type="horzAlign" val="l"/>
+          <dgm:param type="nodeHorzAlign" val="l"/>
+        </dgm:alg>
+      </dgm:if>
+      <dgm:else name="Name2">
+        <dgm:alg type="lin">
+          <dgm:param type="linDir" val="fromT"/>
+          <dgm:param type="vertAlign" val="mid"/>
+          <dgm:param type="horzAlign" val="r"/>
+          <dgm:param type="nodeHorzAlign" val="r"/>
+        </dgm:alg>
+      </dgm:else>
+    </dgm:choose>
+    <dgm:shape xmlns:r="http://schemas.openxmlformats.org/officeDocument/2006/relationships" r:blip="">
+      <dgm:adjLst/>
+    </dgm:shape>
+    <dgm:presOf/>
+    <dgm:constrLst>
+      <dgm:constr type="w" for="ch" forName="parentLin" refType="w"/>
+      <dgm:constr type="h" for="ch" forName="parentLin" val="INF"/>
+      <dgm:constr type="w" for="des" forName="parentLeftMargin" refType="w" fact="0.05"/>
+      <dgm:constr type="w" for="des" forName="parentText" refType="w" fact="0.7"/>
+      <dgm:constr type="h" for="des" forName="parentText" refType="primFontSz" refFor="des" refForName="parentText" fact="0.82"/>
+      <dgm:constr type="h" for="ch" forName="negativeSpace" refType="primFontSz" refFor="des" refForName="parentText" fact="-0.41"/>
+      <dgm:constr type="h" for="ch" forName="negativeSpace" refType="h" refFor="des" refForName="parentText" op="lte" fact="-0.82"/>
+      <dgm:constr type="h" for="ch" forName="negativeSpace" refType="h" refFor="des" refForName="parentText" op="gte" fact="-0.82"/>
+      <dgm:constr type="w" for="ch" forName="childText" refType="w"/>
+      <dgm:constr type="h" for="ch" forName="childText" refType="primFontSz" refFor="des" refForName="parentText" fact="0.7"/>
+      <dgm:constr type="primFontSz" for="des" forName="parentText" val="65"/>
+      <dgm:constr type="primFontSz" for="ch" forName="childText" refType="primFontSz" refFor="des" refForName="parentText"/>
+      <dgm:constr type="tMarg" for="ch" forName="childText" refType="primFontSz" refFor="des" refForName="parentText" fact="1.64"/>
+      <dgm:constr type="tMarg" for="ch" forName="childText" refType="h" refFor="des" refForName="parentText" op="lte" fact="3.28"/>
+      <dgm:constr type="tMarg" for="ch" forName="childText" refType="h" refFor="des" refForName="parentText" op="gte" fact="3.28"/>
+      <dgm:constr type="lMarg" for="ch" forName="childText" refType="w" fact="0.22"/>
+      <dgm:constr type="rMarg" for="ch" forName="childText" refType="lMarg" refFor="ch" refForName="childText"/>
+      <dgm:constr type="lMarg" for="des" forName="parentText" refType="w" fact="0.075"/>
+      <dgm:constr type="rMarg" for="des" forName="parentText" refType="lMarg" refFor="des" refForName="parentText"/>
+      <dgm:constr type="h" for="ch" forName="spaceBetweenRectangles" refType="primFontSz" refFor="des" refForName="parentText" fact="0.15"/>
+    </dgm:constrLst>
+    <dgm:ruleLst>
+      <dgm:rule type="primFontSz" for="des" forName="parentText" val="5" fact="NaN" max="NaN"/>
+    </dgm:ruleLst>
+    <dgm:forEach name="Name3" axis="ch" ptType="node">
+      <dgm:layoutNode name="parentLin">
+        <dgm:choose name="Name4">
+          <dgm:if name="Name5" func="var" arg="dir" op="equ" val="norm">
+            <dgm:alg type="lin">
+              <dgm:param type="linDir" val="fromL"/>
+              <dgm:param type="horzAlign" val="l"/>
+              <dgm:param type="nodeHorzAlign" val="l"/>
+            </dgm:alg>
+          </dgm:if>
+          <dgm:else name="Name6">
+            <dgm:alg type="lin">
+              <dgm:param type="linDir" val="fromR"/>
+              <dgm:param type="horzAlign" val="r"/>
+              <dgm:param type="nodeHorzAlign" val="r"/>
+            </dgm:alg>
+          </dgm:else>
+        </dgm:choose>
+        <dgm:shape xmlns:r="http://schemas.openxmlformats.org/officeDocument/2006/relationships" r:blip="">
+          <dgm:adjLst/>
+        </dgm:shape>
+        <dgm:presOf/>
+        <dgm:constrLst/>
+        <dgm:ruleLst/>
+        <dgm:layoutNode name="parentLeftMargin">
+          <dgm:alg type="sp"/>
+          <dgm:shape xmlns:r="http://schemas.openxmlformats.org/officeDocument/2006/relationships" type="rect" r:blip="" hideGeom="1">
+            <dgm:adjLst/>
+          </dgm:shape>
+          <dgm:presOf axis="self"/>
+          <dgm:constrLst>
+            <dgm:constr type="h"/>
+          </dgm:constrLst>
+          <dgm:ruleLst/>
+        </dgm:layoutNode>
+        <dgm:layoutNode name="parentText" styleLbl="node1">
+          <dgm:varLst>
+            <dgm:chMax val="0"/>
+            <dgm:bulletEnabled val="1"/>
+          </dgm:varLst>
+          <dgm:choose name="Name7">
+            <dgm:if name="Name8" func="var" arg="dir" op="equ" val="norm">
+              <dgm:alg type="tx">
+                <dgm:param type="parTxLTRAlign" val="l"/>
+                <dgm:param type="parTxRTLAlign" val="l"/>
+              </dgm:alg>
+            </dgm:if>
+            <dgm:else name="Name9">
+              <dgm:alg type="tx">
+                <dgm:param type="parTxLTRAlign" val="r"/>
+                <dgm:param type="parTxRTLAlign" val="r"/>
+              </dgm:alg>
+            </dgm:else>
+          </dgm:choose>
+          <dgm:shape xmlns:r="http://schemas.openxmlformats.org/officeDocument/2006/relationships" type="roundRect" r:blip="">
+            <dgm:adjLst/>
+          </dgm:shape>
+          <dgm:presOf axis="self" ptType="node"/>
+          <dgm:constrLst>
+            <dgm:constr type="tMarg"/>
+            <dgm:constr type="bMarg"/>
+          </dgm:constrLst>
+          <dgm:ruleLst/>
+        </dgm:layoutNode>
+      </dgm:layoutNode>
+      <dgm:layoutNode name="negativeSpace">
+        <dgm:alg type="sp"/>
+        <dgm:shape xmlns:r="http://schemas.openxmlformats.org/officeDocument/2006/relationships" r:blip="">
+          <dgm:adjLst/>
+        </dgm:shape>
+        <dgm:presOf/>
+        <dgm:constrLst/>
+        <dgm:ruleLst/>
+      </dgm:layoutNode>
+      <dgm:layoutNode name="childText" styleLbl="conFgAcc1">
+        <dgm:varLst>
+          <dgm:bulletEnabled val="1"/>
+        </dgm:varLst>
+        <dgm:alg type="tx">
+          <dgm:param type="stBulletLvl" val="1"/>
+        </dgm:alg>
+        <dgm:shape xmlns:r="http://schemas.openxmlformats.org/officeDocument/2006/relationships" type="rect" r:blip="" zOrderOff="-2">
+          <dgm:adjLst/>
+        </dgm:shape>
+        <dgm:presOf axis="des" ptType="node"/>
+        <dgm:constrLst>
+          <dgm:constr type="secFontSz" refType="primFontSz"/>
+        </dgm:constrLst>
+        <dgm:ruleLst>
+          <dgm:rule type="h" val="INF" fact="NaN" max="NaN"/>
+        </dgm:ruleLst>
+      </dgm:layoutNode>
+      <dgm:forEach name="Name10" axis="followSib" ptType="sibTrans" cnt="1">
+        <dgm:layoutNode name="spaceBetweenRectangles">
+          <dgm:alg type="sp"/>
+          <dgm:shape xmlns:r="http://schemas.openxmlformats.org/officeDocument/2006/relationships" r:blip="">
+            <dgm:adjLst/>
+          </dgm:shape>
+          <dgm:presOf/>
+          <dgm:constrLst/>
+          <dgm:ruleLst/>
+        </dgm:layoutNode>
+      </dgm:forEach>
+    </dgm:forEach>
+  </dgm:layoutNode>
+</dgm:layoutDef>
+</file>
+
 <file path=ppt/diagrams/quickStyle1.xml><?xml version="1.0" encoding="utf-8"?>
 <dgm:styleDef xmlns:dgm="http://schemas.openxmlformats.org/drawingml/2006/diagram" xmlns:a="http://schemas.openxmlformats.org/drawingml/2006/main" uniqueId="urn:microsoft.com/office/officeart/2005/8/quickstyle/simple1">
   <dgm:title val=""/>
@@ -24614,6 +26653,1040 @@
 </file>
 
 <file path=ppt/diagrams/quickStyle8.xml><?xml version="1.0" encoding="utf-8"?>
+<dgm:styleDef xmlns:dgm="http://schemas.openxmlformats.org/drawingml/2006/diagram" xmlns:a="http://schemas.openxmlformats.org/drawingml/2006/main" uniqueId="urn:microsoft.com/office/officeart/2005/8/quickstyle/simple1">
+  <dgm:title val=""/>
+  <dgm:desc val=""/>
+  <dgm:catLst>
+    <dgm:cat type="simple" pri="10100"/>
+  </dgm:catLst>
+  <dgm:scene3d>
+    <a:camera prst="orthographicFront"/>
+    <a:lightRig rig="threePt" dir="t"/>
+  </dgm:scene3d>
+  <dgm:styleLbl name="node0">
+    <dgm:scene3d>
+      <a:camera prst="orthographicFront"/>
+      <a:lightRig rig="threePt" dir="t"/>
+    </dgm:scene3d>
+    <dgm:sp3d/>
+    <dgm:txPr/>
+    <dgm:style>
+      <a:lnRef idx="2">
+        <a:scrgbClr r="0" g="0" b="0"/>
+      </a:lnRef>
+      <a:fillRef idx="1">
+        <a:scrgbClr r="0" g="0" b="0"/>
+      </a:fillRef>
+      <a:effectRef idx="0">
+        <a:scrgbClr r="0" g="0" b="0"/>
+      </a:effectRef>
+      <a:fontRef idx="minor">
+        <a:schemeClr val="lt1"/>
+      </a:fontRef>
+    </dgm:style>
+  </dgm:styleLbl>
+  <dgm:styleLbl name="lnNode1">
+    <dgm:scene3d>
+      <a:camera prst="orthographicFront"/>
+      <a:lightRig rig="threePt" dir="t"/>
+    </dgm:scene3d>
+    <dgm:sp3d/>
+    <dgm:txPr/>
+    <dgm:style>
+      <a:lnRef idx="2">
+        <a:scrgbClr r="0" g="0" b="0"/>
+      </a:lnRef>
+      <a:fillRef idx="1">
+        <a:scrgbClr r="0" g="0" b="0"/>
+      </a:fillRef>
+      <a:effectRef idx="0">
+        <a:scrgbClr r="0" g="0" b="0"/>
+      </a:effectRef>
+      <a:fontRef idx="minor">
+        <a:schemeClr val="lt1"/>
+      </a:fontRef>
+    </dgm:style>
+  </dgm:styleLbl>
+  <dgm:styleLbl name="vennNode1">
+    <dgm:scene3d>
+      <a:camera prst="orthographicFront"/>
+      <a:lightRig rig="threePt" dir="t"/>
+    </dgm:scene3d>
+    <dgm:sp3d/>
+    <dgm:txPr/>
+    <dgm:style>
+      <a:lnRef idx="2">
+        <a:scrgbClr r="0" g="0" b="0"/>
+      </a:lnRef>
+      <a:fillRef idx="1">
+        <a:scrgbClr r="0" g="0" b="0"/>
+      </a:fillRef>
+      <a:effectRef idx="0">
+        <a:scrgbClr r="0" g="0" b="0"/>
+      </a:effectRef>
+      <a:fontRef idx="minor">
+        <a:schemeClr val="tx1"/>
+      </a:fontRef>
+    </dgm:style>
+  </dgm:styleLbl>
+  <dgm:styleLbl name="alignNode1">
+    <dgm:scene3d>
+      <a:camera prst="orthographicFront"/>
+      <a:lightRig rig="threePt" dir="t"/>
+    </dgm:scene3d>
+    <dgm:sp3d/>
+    <dgm:txPr/>
+    <dgm:style>
+      <a:lnRef idx="2">
+        <a:scrgbClr r="0" g="0" b="0"/>
+      </a:lnRef>
+      <a:fillRef idx="1">
+        <a:scrgbClr r="0" g="0" b="0"/>
+      </a:fillRef>
+      <a:effectRef idx="0">
+        <a:scrgbClr r="0" g="0" b="0"/>
+      </a:effectRef>
+      <a:fontRef idx="minor">
+        <a:schemeClr val="lt1"/>
+      </a:fontRef>
+    </dgm:style>
+  </dgm:styleLbl>
+  <dgm:styleLbl name="node1">
+    <dgm:scene3d>
+      <a:camera prst="orthographicFront"/>
+      <a:lightRig rig="threePt" dir="t"/>
+    </dgm:scene3d>
+    <dgm:sp3d/>
+    <dgm:txPr/>
+    <dgm:style>
+      <a:lnRef idx="2">
+        <a:scrgbClr r="0" g="0" b="0"/>
+      </a:lnRef>
+      <a:fillRef idx="1">
+        <a:scrgbClr r="0" g="0" b="0"/>
+      </a:fillRef>
+      <a:effectRef idx="0">
+        <a:scrgbClr r="0" g="0" b="0"/>
+      </a:effectRef>
+      <a:fontRef idx="minor">
+        <a:schemeClr val="lt1"/>
+      </a:fontRef>
+    </dgm:style>
+  </dgm:styleLbl>
+  <dgm:styleLbl name="node2">
+    <dgm:scene3d>
+      <a:camera prst="orthographicFront"/>
+      <a:lightRig rig="threePt" dir="t"/>
+    </dgm:scene3d>
+    <dgm:sp3d/>
+    <dgm:txPr/>
+    <dgm:style>
+      <a:lnRef idx="2">
+        <a:scrgbClr r="0" g="0" b="0"/>
+      </a:lnRef>
+      <a:fillRef idx="1">
+        <a:scrgbClr r="0" g="0" b="0"/>
+      </a:fillRef>
+      <a:effectRef idx="0">
+        <a:scrgbClr r="0" g="0" b="0"/>
+      </a:effectRef>
+      <a:fontRef idx="minor">
+        <a:schemeClr val="lt1"/>
+      </a:fontRef>
+    </dgm:style>
+  </dgm:styleLbl>
+  <dgm:styleLbl name="node3">
+    <dgm:scene3d>
+      <a:camera prst="orthographicFront"/>
+      <a:lightRig rig="threePt" dir="t"/>
+    </dgm:scene3d>
+    <dgm:sp3d/>
+    <dgm:txPr/>
+    <dgm:style>
+      <a:lnRef idx="2">
+        <a:scrgbClr r="0" g="0" b="0"/>
+      </a:lnRef>
+      <a:fillRef idx="1">
+        <a:scrgbClr r="0" g="0" b="0"/>
+      </a:fillRef>
+      <a:effectRef idx="0">
+        <a:scrgbClr r="0" g="0" b="0"/>
+      </a:effectRef>
+      <a:fontRef idx="minor">
+        <a:schemeClr val="lt1"/>
+      </a:fontRef>
+    </dgm:style>
+  </dgm:styleLbl>
+  <dgm:styleLbl name="node4">
+    <dgm:scene3d>
+      <a:camera prst="orthographicFront"/>
+      <a:lightRig rig="threePt" dir="t"/>
+    </dgm:scene3d>
+    <dgm:sp3d/>
+    <dgm:txPr/>
+    <dgm:style>
+      <a:lnRef idx="2">
+        <a:scrgbClr r="0" g="0" b="0"/>
+      </a:lnRef>
+      <a:fillRef idx="1">
+        <a:scrgbClr r="0" g="0" b="0"/>
+      </a:fillRef>
+      <a:effectRef idx="0">
+        <a:scrgbClr r="0" g="0" b="0"/>
+      </a:effectRef>
+      <a:fontRef idx="minor">
+        <a:schemeClr val="lt1"/>
+      </a:fontRef>
+    </dgm:style>
+  </dgm:styleLbl>
+  <dgm:styleLbl name="fgImgPlace1">
+    <dgm:scene3d>
+      <a:camera prst="orthographicFront"/>
+      <a:lightRig rig="threePt" dir="t"/>
+    </dgm:scene3d>
+    <dgm:sp3d/>
+    <dgm:txPr/>
+    <dgm:style>
+      <a:lnRef idx="2">
+        <a:scrgbClr r="0" g="0" b="0"/>
+      </a:lnRef>
+      <a:fillRef idx="1">
+        <a:scrgbClr r="0" g="0" b="0"/>
+      </a:fillRef>
+      <a:effectRef idx="0">
+        <a:scrgbClr r="0" g="0" b="0"/>
+      </a:effectRef>
+      <a:fontRef idx="minor"/>
+    </dgm:style>
+  </dgm:styleLbl>
+  <dgm:styleLbl name="alignImgPlace1">
+    <dgm:scene3d>
+      <a:camera prst="orthographicFront"/>
+      <a:lightRig rig="threePt" dir="t"/>
+    </dgm:scene3d>
+    <dgm:sp3d/>
+    <dgm:txPr/>
+    <dgm:style>
+      <a:lnRef idx="2">
+        <a:scrgbClr r="0" g="0" b="0"/>
+      </a:lnRef>
+      <a:fillRef idx="1">
+        <a:scrgbClr r="0" g="0" b="0"/>
+      </a:fillRef>
+      <a:effectRef idx="0">
+        <a:scrgbClr r="0" g="0" b="0"/>
+      </a:effectRef>
+      <a:fontRef idx="minor"/>
+    </dgm:style>
+  </dgm:styleLbl>
+  <dgm:styleLbl name="bgImgPlace1">
+    <dgm:scene3d>
+      <a:camera prst="orthographicFront"/>
+      <a:lightRig rig="threePt" dir="t"/>
+    </dgm:scene3d>
+    <dgm:sp3d/>
+    <dgm:txPr/>
+    <dgm:style>
+      <a:lnRef idx="2">
+        <a:scrgbClr r="0" g="0" b="0"/>
+      </a:lnRef>
+      <a:fillRef idx="1">
+        <a:scrgbClr r="0" g="0" b="0"/>
+      </a:fillRef>
+      <a:effectRef idx="0">
+        <a:scrgbClr r="0" g="0" b="0"/>
+      </a:effectRef>
+      <a:fontRef idx="minor"/>
+    </dgm:style>
+  </dgm:styleLbl>
+  <dgm:styleLbl name="sibTrans2D1">
+    <dgm:scene3d>
+      <a:camera prst="orthographicFront"/>
+      <a:lightRig rig="threePt" dir="t"/>
+    </dgm:scene3d>
+    <dgm:sp3d/>
+    <dgm:txPr/>
+    <dgm:style>
+      <a:lnRef idx="0">
+        <a:scrgbClr r="0" g="0" b="0"/>
+      </a:lnRef>
+      <a:fillRef idx="1">
+        <a:scrgbClr r="0" g="0" b="0"/>
+      </a:fillRef>
+      <a:effectRef idx="0">
+        <a:scrgbClr r="0" g="0" b="0"/>
+      </a:effectRef>
+      <a:fontRef idx="minor">
+        <a:schemeClr val="lt1"/>
+      </a:fontRef>
+    </dgm:style>
+  </dgm:styleLbl>
+  <dgm:styleLbl name="fgSibTrans2D1">
+    <dgm:scene3d>
+      <a:camera prst="orthographicFront"/>
+      <a:lightRig rig="threePt" dir="t"/>
+    </dgm:scene3d>
+    <dgm:sp3d/>
+    <dgm:txPr/>
+    <dgm:style>
+      <a:lnRef idx="0">
+        <a:scrgbClr r="0" g="0" b="0"/>
+      </a:lnRef>
+      <a:fillRef idx="1">
+        <a:scrgbClr r="0" g="0" b="0"/>
+      </a:fillRef>
+      <a:effectRef idx="0">
+        <a:scrgbClr r="0" g="0" b="0"/>
+      </a:effectRef>
+      <a:fontRef idx="minor">
+        <a:schemeClr val="lt1"/>
+      </a:fontRef>
+    </dgm:style>
+  </dgm:styleLbl>
+  <dgm:styleLbl name="bgSibTrans2D1">
+    <dgm:scene3d>
+      <a:camera prst="orthographicFront"/>
+      <a:lightRig rig="threePt" dir="t"/>
+    </dgm:scene3d>
+    <dgm:sp3d/>
+    <dgm:txPr/>
+    <dgm:style>
+      <a:lnRef idx="0">
+        <a:scrgbClr r="0" g="0" b="0"/>
+      </a:lnRef>
+      <a:fillRef idx="1">
+        <a:scrgbClr r="0" g="0" b="0"/>
+      </a:fillRef>
+      <a:effectRef idx="0">
+        <a:scrgbClr r="0" g="0" b="0"/>
+      </a:effectRef>
+      <a:fontRef idx="minor">
+        <a:schemeClr val="lt1"/>
+      </a:fontRef>
+    </dgm:style>
+  </dgm:styleLbl>
+  <dgm:styleLbl name="sibTrans1D1">
+    <dgm:scene3d>
+      <a:camera prst="orthographicFront"/>
+      <a:lightRig rig="threePt" dir="t"/>
+    </dgm:scene3d>
+    <dgm:sp3d/>
+    <dgm:txPr/>
+    <dgm:style>
+      <a:lnRef idx="1">
+        <a:scrgbClr r="0" g="0" b="0"/>
+      </a:lnRef>
+      <a:fillRef idx="0">
+        <a:scrgbClr r="0" g="0" b="0"/>
+      </a:fillRef>
+      <a:effectRef idx="0">
+        <a:scrgbClr r="0" g="0" b="0"/>
+      </a:effectRef>
+      <a:fontRef idx="minor"/>
+    </dgm:style>
+  </dgm:styleLbl>
+  <dgm:styleLbl name="callout">
+    <dgm:scene3d>
+      <a:camera prst="orthographicFront"/>
+      <a:lightRig rig="threePt" dir="t"/>
+    </dgm:scene3d>
+    <dgm:sp3d/>
+    <dgm:txPr/>
+    <dgm:style>
+      <a:lnRef idx="2">
+        <a:scrgbClr r="0" g="0" b="0"/>
+      </a:lnRef>
+      <a:fillRef idx="1">
+        <a:scrgbClr r="0" g="0" b="0"/>
+      </a:fillRef>
+      <a:effectRef idx="0">
+        <a:scrgbClr r="0" g="0" b="0"/>
+      </a:effectRef>
+      <a:fontRef idx="minor"/>
+    </dgm:style>
+  </dgm:styleLbl>
+  <dgm:styleLbl name="asst0">
+    <dgm:scene3d>
+      <a:camera prst="orthographicFront"/>
+      <a:lightRig rig="threePt" dir="t"/>
+    </dgm:scene3d>
+    <dgm:sp3d/>
+    <dgm:txPr/>
+    <dgm:style>
+      <a:lnRef idx="2">
+        <a:scrgbClr r="0" g="0" b="0"/>
+      </a:lnRef>
+      <a:fillRef idx="1">
+        <a:scrgbClr r="0" g="0" b="0"/>
+      </a:fillRef>
+      <a:effectRef idx="0">
+        <a:scrgbClr r="0" g="0" b="0"/>
+      </a:effectRef>
+      <a:fontRef idx="minor">
+        <a:schemeClr val="lt1"/>
+      </a:fontRef>
+    </dgm:style>
+  </dgm:styleLbl>
+  <dgm:styleLbl name="asst1">
+    <dgm:scene3d>
+      <a:camera prst="orthographicFront"/>
+      <a:lightRig rig="threePt" dir="t"/>
+    </dgm:scene3d>
+    <dgm:sp3d/>
+    <dgm:txPr/>
+    <dgm:style>
+      <a:lnRef idx="2">
+        <a:scrgbClr r="0" g="0" b="0"/>
+      </a:lnRef>
+      <a:fillRef idx="1">
+        <a:scrgbClr r="0" g="0" b="0"/>
+      </a:fillRef>
+      <a:effectRef idx="0">
+        <a:scrgbClr r="0" g="0" b="0"/>
+      </a:effectRef>
+      <a:fontRef idx="minor">
+        <a:schemeClr val="lt1"/>
+      </a:fontRef>
+    </dgm:style>
+  </dgm:styleLbl>
+  <dgm:styleLbl name="asst2">
+    <dgm:scene3d>
+      <a:camera prst="orthographicFront"/>
+      <a:lightRig rig="threePt" dir="t"/>
+    </dgm:scene3d>
+    <dgm:sp3d/>
+    <dgm:txPr/>
+    <dgm:style>
+      <a:lnRef idx="2">
+        <a:scrgbClr r="0" g="0" b="0"/>
+      </a:lnRef>
+      <a:fillRef idx="1">
+        <a:scrgbClr r="0" g="0" b="0"/>
+      </a:fillRef>
+      <a:effectRef idx="0">
+        <a:scrgbClr r="0" g="0" b="0"/>
+      </a:effectRef>
+      <a:fontRef idx="minor">
+        <a:schemeClr val="lt1"/>
+      </a:fontRef>
+    </dgm:style>
+  </dgm:styleLbl>
+  <dgm:styleLbl name="asst3">
+    <dgm:scene3d>
+      <a:camera prst="orthographicFront"/>
+      <a:lightRig rig="threePt" dir="t"/>
+    </dgm:scene3d>
+    <dgm:sp3d/>
+    <dgm:txPr/>
+    <dgm:style>
+      <a:lnRef idx="2">
+        <a:scrgbClr r="0" g="0" b="0"/>
+      </a:lnRef>
+      <a:fillRef idx="1">
+        <a:scrgbClr r="0" g="0" b="0"/>
+      </a:fillRef>
+      <a:effectRef idx="0">
+        <a:scrgbClr r="0" g="0" b="0"/>
+      </a:effectRef>
+      <a:fontRef idx="minor">
+        <a:schemeClr val="lt1"/>
+      </a:fontRef>
+    </dgm:style>
+  </dgm:styleLbl>
+  <dgm:styleLbl name="asst4">
+    <dgm:scene3d>
+      <a:camera prst="orthographicFront"/>
+      <a:lightRig rig="threePt" dir="t"/>
+    </dgm:scene3d>
+    <dgm:sp3d/>
+    <dgm:txPr/>
+    <dgm:style>
+      <a:lnRef idx="2">
+        <a:scrgbClr r="0" g="0" b="0"/>
+      </a:lnRef>
+      <a:fillRef idx="1">
+        <a:scrgbClr r="0" g="0" b="0"/>
+      </a:fillRef>
+      <a:effectRef idx="0">
+        <a:scrgbClr r="0" g="0" b="0"/>
+      </a:effectRef>
+      <a:fontRef idx="minor">
+        <a:schemeClr val="lt1"/>
+      </a:fontRef>
+    </dgm:style>
+  </dgm:styleLbl>
+  <dgm:styleLbl name="parChTrans2D1">
+    <dgm:scene3d>
+      <a:camera prst="orthographicFront"/>
+      <a:lightRig rig="threePt" dir="t"/>
+    </dgm:scene3d>
+    <dgm:sp3d/>
+    <dgm:txPr/>
+    <dgm:style>
+      <a:lnRef idx="2">
+        <a:scrgbClr r="0" g="0" b="0"/>
+      </a:lnRef>
+      <a:fillRef idx="1">
+        <a:scrgbClr r="0" g="0" b="0"/>
+      </a:fillRef>
+      <a:effectRef idx="0">
+        <a:scrgbClr r="0" g="0" b="0"/>
+      </a:effectRef>
+      <a:fontRef idx="minor">
+        <a:schemeClr val="lt1"/>
+      </a:fontRef>
+    </dgm:style>
+  </dgm:styleLbl>
+  <dgm:styleLbl name="parChTrans2D2">
+    <dgm:scene3d>
+      <a:camera prst="orthographicFront"/>
+      <a:lightRig rig="threePt" dir="t"/>
+    </dgm:scene3d>
+    <dgm:sp3d/>
+    <dgm:txPr/>
+    <dgm:style>
+      <a:lnRef idx="2">
+        <a:scrgbClr r="0" g="0" b="0"/>
+      </a:lnRef>
+      <a:fillRef idx="1">
+        <a:scrgbClr r="0" g="0" b="0"/>
+      </a:fillRef>
+      <a:effectRef idx="0">
+        <a:scrgbClr r="0" g="0" b="0"/>
+      </a:effectRef>
+      <a:fontRef idx="minor">
+        <a:schemeClr val="lt1"/>
+      </a:fontRef>
+    </dgm:style>
+  </dgm:styleLbl>
+  <dgm:styleLbl name="parChTrans2D3">
+    <dgm:scene3d>
+      <a:camera prst="orthographicFront"/>
+      <a:lightRig rig="threePt" dir="t"/>
+    </dgm:scene3d>
+    <dgm:sp3d/>
+    <dgm:txPr/>
+    <dgm:style>
+      <a:lnRef idx="2">
+        <a:scrgbClr r="0" g="0" b="0"/>
+      </a:lnRef>
+      <a:fillRef idx="1">
+        <a:scrgbClr r="0" g="0" b="0"/>
+      </a:fillRef>
+      <a:effectRef idx="0">
+        <a:scrgbClr r="0" g="0" b="0"/>
+      </a:effectRef>
+      <a:fontRef idx="minor">
+        <a:schemeClr val="lt1"/>
+      </a:fontRef>
+    </dgm:style>
+  </dgm:styleLbl>
+  <dgm:styleLbl name="parChTrans2D4">
+    <dgm:scene3d>
+      <a:camera prst="orthographicFront"/>
+      <a:lightRig rig="threePt" dir="t"/>
+    </dgm:scene3d>
+    <dgm:sp3d/>
+    <dgm:txPr/>
+    <dgm:style>
+      <a:lnRef idx="2">
+        <a:scrgbClr r="0" g="0" b="0"/>
+      </a:lnRef>
+      <a:fillRef idx="1">
+        <a:scrgbClr r="0" g="0" b="0"/>
+      </a:fillRef>
+      <a:effectRef idx="0">
+        <a:scrgbClr r="0" g="0" b="0"/>
+      </a:effectRef>
+      <a:fontRef idx="minor">
+        <a:schemeClr val="lt1"/>
+      </a:fontRef>
+    </dgm:style>
+  </dgm:styleLbl>
+  <dgm:styleLbl name="parChTrans1D1">
+    <dgm:scene3d>
+      <a:camera prst="orthographicFront"/>
+      <a:lightRig rig="threePt" dir="t"/>
+    </dgm:scene3d>
+    <dgm:sp3d/>
+    <dgm:txPr/>
+    <dgm:style>
+      <a:lnRef idx="2">
+        <a:scrgbClr r="0" g="0" b="0"/>
+      </a:lnRef>
+      <a:fillRef idx="0">
+        <a:scrgbClr r="0" g="0" b="0"/>
+      </a:fillRef>
+      <a:effectRef idx="0">
+        <a:scrgbClr r="0" g="0" b="0"/>
+      </a:effectRef>
+      <a:fontRef idx="minor"/>
+    </dgm:style>
+  </dgm:styleLbl>
+  <dgm:styleLbl name="parChTrans1D2">
+    <dgm:scene3d>
+      <a:camera prst="orthographicFront"/>
+      <a:lightRig rig="threePt" dir="t"/>
+    </dgm:scene3d>
+    <dgm:sp3d/>
+    <dgm:txPr/>
+    <dgm:style>
+      <a:lnRef idx="2">
+        <a:scrgbClr r="0" g="0" b="0"/>
+      </a:lnRef>
+      <a:fillRef idx="0">
+        <a:scrgbClr r="0" g="0" b="0"/>
+      </a:fillRef>
+      <a:effectRef idx="0">
+        <a:scrgbClr r="0" g="0" b="0"/>
+      </a:effectRef>
+      <a:fontRef idx="minor"/>
+    </dgm:style>
+  </dgm:styleLbl>
+  <dgm:styleLbl name="parChTrans1D3">
+    <dgm:scene3d>
+      <a:camera prst="orthographicFront"/>
+      <a:lightRig rig="threePt" dir="t"/>
+    </dgm:scene3d>
+    <dgm:sp3d/>
+    <dgm:txPr/>
+    <dgm:style>
+      <a:lnRef idx="2">
+        <a:scrgbClr r="0" g="0" b="0"/>
+      </a:lnRef>
+      <a:fillRef idx="0">
+        <a:scrgbClr r="0" g="0" b="0"/>
+      </a:fillRef>
+      <a:effectRef idx="0">
+        <a:scrgbClr r="0" g="0" b="0"/>
+      </a:effectRef>
+      <a:fontRef idx="minor"/>
+    </dgm:style>
+  </dgm:styleLbl>
+  <dgm:styleLbl name="parChTrans1D4">
+    <dgm:scene3d>
+      <a:camera prst="orthographicFront"/>
+      <a:lightRig rig="threePt" dir="t"/>
+    </dgm:scene3d>
+    <dgm:sp3d/>
+    <dgm:txPr/>
+    <dgm:style>
+      <a:lnRef idx="2">
+        <a:scrgbClr r="0" g="0" b="0"/>
+      </a:lnRef>
+      <a:fillRef idx="0">
+        <a:scrgbClr r="0" g="0" b="0"/>
+      </a:fillRef>
+      <a:effectRef idx="0">
+        <a:scrgbClr r="0" g="0" b="0"/>
+      </a:effectRef>
+      <a:fontRef idx="minor"/>
+    </dgm:style>
+  </dgm:styleLbl>
+  <dgm:styleLbl name="fgAcc1">
+    <dgm:scene3d>
+      <a:camera prst="orthographicFront"/>
+      <a:lightRig rig="threePt" dir="t"/>
+    </dgm:scene3d>
+    <dgm:sp3d/>
+    <dgm:txPr/>
+    <dgm:style>
+      <a:lnRef idx="2">
+        <a:scrgbClr r="0" g="0" b="0"/>
+      </a:lnRef>
+      <a:fillRef idx="1">
+        <a:scrgbClr r="0" g="0" b="0"/>
+      </a:fillRef>
+      <a:effectRef idx="0">
+        <a:scrgbClr r="0" g="0" b="0"/>
+      </a:effectRef>
+      <a:fontRef idx="minor"/>
+    </dgm:style>
+  </dgm:styleLbl>
+  <dgm:styleLbl name="conFgAcc1">
+    <dgm:scene3d>
+      <a:camera prst="orthographicFront"/>
+      <a:lightRig rig="threePt" dir="t"/>
+    </dgm:scene3d>
+    <dgm:sp3d/>
+    <dgm:txPr/>
+    <dgm:style>
+      <a:lnRef idx="2">
+        <a:scrgbClr r="0" g="0" b="0"/>
+      </a:lnRef>
+      <a:fillRef idx="1">
+        <a:scrgbClr r="0" g="0" b="0"/>
+      </a:fillRef>
+      <a:effectRef idx="0">
+        <a:scrgbClr r="0" g="0" b="0"/>
+      </a:effectRef>
+      <a:fontRef idx="minor"/>
+    </dgm:style>
+  </dgm:styleLbl>
+  <dgm:styleLbl name="alignAcc1">
+    <dgm:scene3d>
+      <a:camera prst="orthographicFront"/>
+      <a:lightRig rig="threePt" dir="t"/>
+    </dgm:scene3d>
+    <dgm:sp3d/>
+    <dgm:txPr/>
+    <dgm:style>
+      <a:lnRef idx="2">
+        <a:scrgbClr r="0" g="0" b="0"/>
+      </a:lnRef>
+      <a:fillRef idx="1">
+        <a:scrgbClr r="0" g="0" b="0"/>
+      </a:fillRef>
+      <a:effectRef idx="0">
+        <a:scrgbClr r="0" g="0" b="0"/>
+      </a:effectRef>
+      <a:fontRef idx="minor"/>
+    </dgm:style>
+  </dgm:styleLbl>
+  <dgm:styleLbl name="trAlignAcc1">
+    <dgm:scene3d>
+      <a:camera prst="orthographicFront"/>
+      <a:lightRig rig="threePt" dir="t"/>
+    </dgm:scene3d>
+    <dgm:sp3d/>
+    <dgm:txPr/>
+    <dgm:style>
+      <a:lnRef idx="1">
+        <a:scrgbClr r="0" g="0" b="0"/>
+      </a:lnRef>
+      <a:fillRef idx="1">
+        <a:scrgbClr r="0" g="0" b="0"/>
+      </a:fillRef>
+      <a:effectRef idx="0">
+        <a:scrgbClr r="0" g="0" b="0"/>
+      </a:effectRef>
+      <a:fontRef idx="minor"/>
+    </dgm:style>
+  </dgm:styleLbl>
+  <dgm:styleLbl name="bgAcc1">
+    <dgm:scene3d>
+      <a:camera prst="orthographicFront"/>
+      <a:lightRig rig="threePt" dir="t"/>
+    </dgm:scene3d>
+    <dgm:sp3d/>
+    <dgm:txPr/>
+    <dgm:style>
+      <a:lnRef idx="2">
+        <a:scrgbClr r="0" g="0" b="0"/>
+      </a:lnRef>
+      <a:fillRef idx="1">
+        <a:scrgbClr r="0" g="0" b="0"/>
+      </a:fillRef>
+      <a:effectRef idx="0">
+        <a:scrgbClr r="0" g="0" b="0"/>
+      </a:effectRef>
+      <a:fontRef idx="minor"/>
+    </dgm:style>
+  </dgm:styleLbl>
+  <dgm:styleLbl name="solidFgAcc1">
+    <dgm:scene3d>
+      <a:camera prst="orthographicFront"/>
+      <a:lightRig rig="threePt" dir="t"/>
+    </dgm:scene3d>
+    <dgm:sp3d/>
+    <dgm:txPr/>
+    <dgm:style>
+      <a:lnRef idx="2">
+        <a:scrgbClr r="0" g="0" b="0"/>
+      </a:lnRef>
+      <a:fillRef idx="1">
+        <a:scrgbClr r="0" g="0" b="0"/>
+      </a:fillRef>
+      <a:effectRef idx="0">
+        <a:scrgbClr r="0" g="0" b="0"/>
+      </a:effectRef>
+      <a:fontRef idx="minor"/>
+    </dgm:style>
+  </dgm:styleLbl>
+  <dgm:styleLbl name="solidAlignAcc1">
+    <dgm:scene3d>
+      <a:camera prst="orthographicFront"/>
+      <a:lightRig rig="threePt" dir="t"/>
+    </dgm:scene3d>
+    <dgm:sp3d/>
+    <dgm:txPr/>
+    <dgm:style>
+      <a:lnRef idx="2">
+        <a:scrgbClr r="0" g="0" b="0"/>
+      </a:lnRef>
+      <a:fillRef idx="1">
+        <a:scrgbClr r="0" g="0" b="0"/>
+      </a:fillRef>
+      <a:effectRef idx="0">
+        <a:scrgbClr r="0" g="0" b="0"/>
+      </a:effectRef>
+      <a:fontRef idx="minor"/>
+    </dgm:style>
+  </dgm:styleLbl>
+  <dgm:styleLbl name="solidBgAcc1">
+    <dgm:scene3d>
+      <a:camera prst="orthographicFront"/>
+      <a:lightRig rig="threePt" dir="t"/>
+    </dgm:scene3d>
+    <dgm:sp3d/>
+    <dgm:txPr/>
+    <dgm:style>
+      <a:lnRef idx="2">
+        <a:scrgbClr r="0" g="0" b="0"/>
+      </a:lnRef>
+      <a:fillRef idx="1">
+        <a:scrgbClr r="0" g="0" b="0"/>
+      </a:fillRef>
+      <a:effectRef idx="0">
+        <a:scrgbClr r="0" g="0" b="0"/>
+      </a:effectRef>
+      <a:fontRef idx="minor"/>
+    </dgm:style>
+  </dgm:styleLbl>
+  <dgm:styleLbl name="fgAccFollowNode1">
+    <dgm:scene3d>
+      <a:camera prst="orthographicFront"/>
+      <a:lightRig rig="threePt" dir="t"/>
+    </dgm:scene3d>
+    <dgm:sp3d/>
+    <dgm:txPr/>
+    <dgm:style>
+      <a:lnRef idx="2">
+        <a:scrgbClr r="0" g="0" b="0"/>
+      </a:lnRef>
+      <a:fillRef idx="1">
+        <a:scrgbClr r="0" g="0" b="0"/>
+      </a:fillRef>
+      <a:effectRef idx="0">
+        <a:scrgbClr r="0" g="0" b="0"/>
+      </a:effectRef>
+      <a:fontRef idx="minor"/>
+    </dgm:style>
+  </dgm:styleLbl>
+  <dgm:styleLbl name="alignAccFollowNode1">
+    <dgm:scene3d>
+      <a:camera prst="orthographicFront"/>
+      <a:lightRig rig="threePt" dir="t"/>
+    </dgm:scene3d>
+    <dgm:sp3d/>
+    <dgm:txPr/>
+    <dgm:style>
+      <a:lnRef idx="2">
+        <a:scrgbClr r="0" g="0" b="0"/>
+      </a:lnRef>
+      <a:fillRef idx="1">
+        <a:scrgbClr r="0" g="0" b="0"/>
+      </a:fillRef>
+      <a:effectRef idx="0">
+        <a:scrgbClr r="0" g="0" b="0"/>
+      </a:effectRef>
+      <a:fontRef idx="minor"/>
+    </dgm:style>
+  </dgm:styleLbl>
+  <dgm:styleLbl name="bgAccFollowNode1">
+    <dgm:scene3d>
+      <a:camera prst="orthographicFront"/>
+      <a:lightRig rig="threePt" dir="t"/>
+    </dgm:scene3d>
+    <dgm:sp3d/>
+    <dgm:txPr/>
+    <dgm:style>
+      <a:lnRef idx="2">
+        <a:scrgbClr r="0" g="0" b="0"/>
+      </a:lnRef>
+      <a:fillRef idx="1">
+        <a:scrgbClr r="0" g="0" b="0"/>
+      </a:fillRef>
+      <a:effectRef idx="0">
+        <a:scrgbClr r="0" g="0" b="0"/>
+      </a:effectRef>
+      <a:fontRef idx="minor"/>
+    </dgm:style>
+  </dgm:styleLbl>
+  <dgm:styleLbl name="fgAcc0">
+    <dgm:scene3d>
+      <a:camera prst="orthographicFront"/>
+      <a:lightRig rig="threePt" dir="t"/>
+    </dgm:scene3d>
+    <dgm:sp3d/>
+    <dgm:txPr/>
+    <dgm:style>
+      <a:lnRef idx="2">
+        <a:scrgbClr r="0" g="0" b="0"/>
+      </a:lnRef>
+      <a:fillRef idx="1">
+        <a:scrgbClr r="0" g="0" b="0"/>
+      </a:fillRef>
+      <a:effectRef idx="0">
+        <a:scrgbClr r="0" g="0" b="0"/>
+      </a:effectRef>
+      <a:fontRef idx="minor"/>
+    </dgm:style>
+  </dgm:styleLbl>
+  <dgm:styleLbl name="fgAcc2">
+    <dgm:scene3d>
+      <a:camera prst="orthographicFront"/>
+      <a:lightRig rig="threePt" dir="t"/>
+    </dgm:scene3d>
+    <dgm:sp3d/>
+    <dgm:txPr/>
+    <dgm:style>
+      <a:lnRef idx="2">
+        <a:scrgbClr r="0" g="0" b="0"/>
+      </a:lnRef>
+      <a:fillRef idx="1">
+        <a:scrgbClr r="0" g="0" b="0"/>
+      </a:fillRef>
+      <a:effectRef idx="0">
+        <a:scrgbClr r="0" g="0" b="0"/>
+      </a:effectRef>
+      <a:fontRef idx="minor"/>
+    </dgm:style>
+  </dgm:styleLbl>
+  <dgm:styleLbl name="fgAcc3">
+    <dgm:scene3d>
+      <a:camera prst="orthographicFront"/>
+      <a:lightRig rig="threePt" dir="t"/>
+    </dgm:scene3d>
+    <dgm:sp3d/>
+    <dgm:txPr/>
+    <dgm:style>
+      <a:lnRef idx="2">
+        <a:scrgbClr r="0" g="0" b="0"/>
+      </a:lnRef>
+      <a:fillRef idx="1">
+        <a:scrgbClr r="0" g="0" b="0"/>
+      </a:fillRef>
+      <a:effectRef idx="0">
+        <a:scrgbClr r="0" g="0" b="0"/>
+      </a:effectRef>
+      <a:fontRef idx="minor"/>
+    </dgm:style>
+  </dgm:styleLbl>
+  <dgm:styleLbl name="fgAcc4">
+    <dgm:scene3d>
+      <a:camera prst="orthographicFront"/>
+      <a:lightRig rig="threePt" dir="t"/>
+    </dgm:scene3d>
+    <dgm:sp3d/>
+    <dgm:txPr/>
+    <dgm:style>
+      <a:lnRef idx="2">
+        <a:scrgbClr r="0" g="0" b="0"/>
+      </a:lnRef>
+      <a:fillRef idx="1">
+        <a:scrgbClr r="0" g="0" b="0"/>
+      </a:fillRef>
+      <a:effectRef idx="0">
+        <a:scrgbClr r="0" g="0" b="0"/>
+      </a:effectRef>
+      <a:fontRef idx="minor"/>
+    </dgm:style>
+  </dgm:styleLbl>
+  <dgm:styleLbl name="bgShp">
+    <dgm:scene3d>
+      <a:camera prst="orthographicFront"/>
+      <a:lightRig rig="threePt" dir="t"/>
+    </dgm:scene3d>
+    <dgm:sp3d/>
+    <dgm:txPr/>
+    <dgm:style>
+      <a:lnRef idx="0">
+        <a:scrgbClr r="0" g="0" b="0"/>
+      </a:lnRef>
+      <a:fillRef idx="1">
+        <a:scrgbClr r="0" g="0" b="0"/>
+      </a:fillRef>
+      <a:effectRef idx="0">
+        <a:scrgbClr r="0" g="0" b="0"/>
+      </a:effectRef>
+      <a:fontRef idx="minor"/>
+    </dgm:style>
+  </dgm:styleLbl>
+  <dgm:styleLbl name="dkBgShp">
+    <dgm:scene3d>
+      <a:camera prst="orthographicFront"/>
+      <a:lightRig rig="threePt" dir="t"/>
+    </dgm:scene3d>
+    <dgm:sp3d/>
+    <dgm:txPr/>
+    <dgm:style>
+      <a:lnRef idx="0">
+        <a:scrgbClr r="0" g="0" b="0"/>
+      </a:lnRef>
+      <a:fillRef idx="1">
+        <a:scrgbClr r="0" g="0" b="0"/>
+      </a:fillRef>
+      <a:effectRef idx="0">
+        <a:scrgbClr r="0" g="0" b="0"/>
+      </a:effectRef>
+      <a:fontRef idx="minor"/>
+    </dgm:style>
+  </dgm:styleLbl>
+  <dgm:styleLbl name="trBgShp">
+    <dgm:scene3d>
+      <a:camera prst="orthographicFront"/>
+      <a:lightRig rig="threePt" dir="t"/>
+    </dgm:scene3d>
+    <dgm:sp3d/>
+    <dgm:txPr/>
+    <dgm:style>
+      <a:lnRef idx="0">
+        <a:scrgbClr r="0" g="0" b="0"/>
+      </a:lnRef>
+      <a:fillRef idx="1">
+        <a:scrgbClr r="0" g="0" b="0"/>
+      </a:fillRef>
+      <a:effectRef idx="0">
+        <a:scrgbClr r="0" g="0" b="0"/>
+      </a:effectRef>
+      <a:fontRef idx="minor"/>
+    </dgm:style>
+  </dgm:styleLbl>
+  <dgm:styleLbl name="fgShp">
+    <dgm:scene3d>
+      <a:camera prst="orthographicFront"/>
+      <a:lightRig rig="threePt" dir="t"/>
+    </dgm:scene3d>
+    <dgm:sp3d/>
+    <dgm:txPr/>
+    <dgm:style>
+      <a:lnRef idx="2">
+        <a:scrgbClr r="0" g="0" b="0"/>
+      </a:lnRef>
+      <a:fillRef idx="1">
+        <a:scrgbClr r="0" g="0" b="0"/>
+      </a:fillRef>
+      <a:effectRef idx="0">
+        <a:scrgbClr r="0" g="0" b="0"/>
+      </a:effectRef>
+      <a:fontRef idx="minor"/>
+    </dgm:style>
+  </dgm:styleLbl>
+  <dgm:styleLbl name="revTx">
+    <dgm:scene3d>
+      <a:camera prst="orthographicFront"/>
+      <a:lightRig rig="threePt" dir="t"/>
+    </dgm:scene3d>
+    <dgm:sp3d/>
+    <dgm:txPr/>
+    <dgm:style>
+      <a:lnRef idx="0">
+        <a:scrgbClr r="0" g="0" b="0"/>
+      </a:lnRef>
+      <a:fillRef idx="0">
+        <a:scrgbClr r="0" g="0" b="0"/>
+      </a:fillRef>
+      <a:effectRef idx="0">
+        <a:scrgbClr r="0" g="0" b="0"/>
+      </a:effectRef>
+      <a:fontRef idx="minor"/>
+    </dgm:style>
+  </dgm:styleLbl>
+</dgm:styleDef>
+</file>
+
+<file path=ppt/diagrams/quickStyle9.xml><?xml version="1.0" encoding="utf-8"?>
 <dgm:styleDef xmlns:dgm="http://schemas.openxmlformats.org/drawingml/2006/diagram" xmlns:a="http://schemas.openxmlformats.org/drawingml/2006/main" uniqueId="urn:microsoft.com/office/officeart/2005/8/quickstyle/simple1">
   <dgm:title val=""/>
   <dgm:desc val=""/>
@@ -25729,7 +28802,7 @@
           <a:p>
             <a:fld id="{840FFE86-F4EF-4C24-B61E-A4ACE1AB3F28}" type="datetimeFigureOut">
               <a:rPr lang="en-SG" smtClean="0"/>
-              <a:t>31/3/2026</a:t>
+              <a:t>1/4/2026</a:t>
             </a:fld>
             <a:endParaRPr lang="en-SG" dirty="0"/>
           </a:p>
@@ -26276,7 +29349,7 @@
           <a:p>
             <a:fld id="{DA1CC2BE-6A0F-4071-BFB7-8FB97E7BF62D}" type="datetimeFigureOut">
               <a:rPr lang="en-SG" smtClean="0"/>
-              <a:t>31/3/2026</a:t>
+              <a:t>1/4/2026</a:t>
             </a:fld>
             <a:endParaRPr lang="en-SG" dirty="0"/>
           </a:p>
@@ -26621,7 +29694,7 @@
           <a:p>
             <a:fld id="{DA1CC2BE-6A0F-4071-BFB7-8FB97E7BF62D}" type="datetimeFigureOut">
               <a:rPr lang="en-SG" smtClean="0"/>
-              <a:t>31/3/2026</a:t>
+              <a:t>1/4/2026</a:t>
             </a:fld>
             <a:endParaRPr lang="en-SG" dirty="0"/>
           </a:p>
@@ -27029,7 +30102,7 @@
           <a:p>
             <a:fld id="{DA1CC2BE-6A0F-4071-BFB7-8FB97E7BF62D}" type="datetimeFigureOut">
               <a:rPr lang="en-SG" smtClean="0"/>
-              <a:t>31/3/2026</a:t>
+              <a:t>1/4/2026</a:t>
             </a:fld>
             <a:endParaRPr lang="en-SG" dirty="0"/>
           </a:p>
@@ -27372,7 +30445,7 @@
           <a:p>
             <a:fld id="{DA1CC2BE-6A0F-4071-BFB7-8FB97E7BF62D}" type="datetimeFigureOut">
               <a:rPr lang="en-SG" smtClean="0"/>
-              <a:t>31/3/2026</a:t>
+              <a:t>1/4/2026</a:t>
             </a:fld>
             <a:endParaRPr lang="en-SG" dirty="0"/>
           </a:p>
@@ -27699,7 +30772,7 @@
           <a:p>
             <a:fld id="{DA1CC2BE-6A0F-4071-BFB7-8FB97E7BF62D}" type="datetimeFigureOut">
               <a:rPr lang="en-SG" smtClean="0"/>
-              <a:t>31/3/2026</a:t>
+              <a:t>1/4/2026</a:t>
             </a:fld>
             <a:endParaRPr lang="en-SG" dirty="0"/>
           </a:p>
@@ -28102,7 +31175,7 @@
           <a:p>
             <a:fld id="{DA1CC2BE-6A0F-4071-BFB7-8FB97E7BF62D}" type="datetimeFigureOut">
               <a:rPr lang="en-SG" smtClean="0"/>
-              <a:t>31/3/2026</a:t>
+              <a:t>1/4/2026</a:t>
             </a:fld>
             <a:endParaRPr lang="en-SG" dirty="0"/>
           </a:p>
@@ -28366,7 +31439,7 @@
           <a:p>
             <a:fld id="{DA1CC2BE-6A0F-4071-BFB7-8FB97E7BF62D}" type="datetimeFigureOut">
               <a:rPr lang="en-SG" smtClean="0"/>
-              <a:t>31/3/2026</a:t>
+              <a:t>1/4/2026</a:t>
             </a:fld>
             <a:endParaRPr lang="en-SG" dirty="0"/>
           </a:p>
@@ -28635,7 +31708,7 @@
           <a:p>
             <a:fld id="{DA1CC2BE-6A0F-4071-BFB7-8FB97E7BF62D}" type="datetimeFigureOut">
               <a:rPr lang="en-SG" smtClean="0"/>
-              <a:t>31/3/2026</a:t>
+              <a:t>1/4/2026</a:t>
             </a:fld>
             <a:endParaRPr lang="en-SG" dirty="0"/>
           </a:p>
@@ -28899,7 +31972,7 @@
           <a:p>
             <a:fld id="{DA1CC2BE-6A0F-4071-BFB7-8FB97E7BF62D}" type="datetimeFigureOut">
               <a:rPr lang="en-SG" smtClean="0"/>
-              <a:t>31/3/2026</a:t>
+              <a:t>1/4/2026</a:t>
             </a:fld>
             <a:endParaRPr lang="en-SG" dirty="0"/>
           </a:p>
@@ -29079,7 +32152,7 @@
           <a:p>
             <a:fld id="{DA1CC2BE-6A0F-4071-BFB7-8FB97E7BF62D}" type="datetimeFigureOut">
               <a:rPr lang="en-SG" smtClean="0"/>
-              <a:t>31/3/2026</a:t>
+              <a:t>1/4/2026</a:t>
             </a:fld>
             <a:endParaRPr lang="en-SG" dirty="0"/>
           </a:p>
@@ -29415,7 +32488,7 @@
           <a:p>
             <a:fld id="{DA1CC2BE-6A0F-4071-BFB7-8FB97E7BF62D}" type="datetimeFigureOut">
               <a:rPr lang="en-SG" smtClean="0"/>
-              <a:t>31/3/2026</a:t>
+              <a:t>1/4/2026</a:t>
             </a:fld>
             <a:endParaRPr lang="en-SG" dirty="0"/>
           </a:p>
@@ -29745,7 +32818,7 @@
           <a:p>
             <a:fld id="{DA1CC2BE-6A0F-4071-BFB7-8FB97E7BF62D}" type="datetimeFigureOut">
               <a:rPr lang="en-SG" smtClean="0"/>
-              <a:t>31/3/2026</a:t>
+              <a:t>1/4/2026</a:t>
             </a:fld>
             <a:endParaRPr lang="en-SG" dirty="0"/>
           </a:p>
@@ -30209,7 +33282,7 @@
           <a:p>
             <a:fld id="{DA1CC2BE-6A0F-4071-BFB7-8FB97E7BF62D}" type="datetimeFigureOut">
               <a:rPr lang="en-SG" smtClean="0"/>
-              <a:t>31/3/2026</a:t>
+              <a:t>1/4/2026</a:t>
             </a:fld>
             <a:endParaRPr lang="en-SG" dirty="0"/>
           </a:p>
@@ -30421,7 +33494,7 @@
           <a:p>
             <a:fld id="{DA1CC2BE-6A0F-4071-BFB7-8FB97E7BF62D}" type="datetimeFigureOut">
               <a:rPr lang="en-SG" smtClean="0"/>
-              <a:t>31/3/2026</a:t>
+              <a:t>1/4/2026</a:t>
             </a:fld>
             <a:endParaRPr lang="en-SG" dirty="0"/>
           </a:p>
@@ -30605,7 +33678,7 @@
           <a:p>
             <a:fld id="{DA1CC2BE-6A0F-4071-BFB7-8FB97E7BF62D}" type="datetimeFigureOut">
               <a:rPr lang="en-SG" smtClean="0"/>
-              <a:t>31/3/2026</a:t>
+              <a:t>1/4/2026</a:t>
             </a:fld>
             <a:endParaRPr lang="en-SG" dirty="0"/>
           </a:p>
@@ -30945,7 +34018,7 @@
           <a:p>
             <a:fld id="{DA1CC2BE-6A0F-4071-BFB7-8FB97E7BF62D}" type="datetimeFigureOut">
               <a:rPr lang="en-SG" smtClean="0"/>
-              <a:t>31/3/2026</a:t>
+              <a:t>1/4/2026</a:t>
             </a:fld>
             <a:endParaRPr lang="en-SG" dirty="0"/>
           </a:p>
@@ -31296,7 +34369,7 @@
           <a:p>
             <a:fld id="{DA1CC2BE-6A0F-4071-BFB7-8FB97E7BF62D}" type="datetimeFigureOut">
               <a:rPr lang="en-SG" smtClean="0"/>
-              <a:t>31/3/2026</a:t>
+              <a:t>1/4/2026</a:t>
             </a:fld>
             <a:endParaRPr lang="en-SG" dirty="0"/>
           </a:p>
@@ -33595,7 +36668,7 @@
           <a:p>
             <a:fld id="{DA1CC2BE-6A0F-4071-BFB7-8FB97E7BF62D}" type="datetimeFigureOut">
               <a:rPr lang="en-SG" smtClean="0"/>
-              <a:t>31/3/2026</a:t>
+              <a:t>1/4/2026</a:t>
             </a:fld>
             <a:endParaRPr lang="en-SG" dirty="0"/>
           </a:p>
@@ -34200,6 +37273,106 @@
 </file>
 
 <file path=ppt/slides/slide10.xml><?xml version="1.0" encoding="utf-8"?>
+<p:sld xmlns:a="http://schemas.openxmlformats.org/drawingml/2006/main" xmlns:r="http://schemas.openxmlformats.org/officeDocument/2006/relationships" xmlns:p="http://schemas.openxmlformats.org/presentationml/2006/main">
+  <p:cSld>
+    <p:spTree>
+      <p:nvGrpSpPr>
+        <p:cNvPr id="1" name="">
+          <a:extLst>
+            <a:ext uri="{FF2B5EF4-FFF2-40B4-BE49-F238E27FC236}">
+              <a16:creationId xmlns:a16="http://schemas.microsoft.com/office/drawing/2014/main" id="{88D72886-1124-2041-4AD7-9CE8A180B7BC}"/>
+            </a:ext>
+          </a:extLst>
+        </p:cNvPr>
+        <p:cNvGrpSpPr/>
+        <p:nvPr/>
+      </p:nvGrpSpPr>
+      <p:grpSpPr>
+        <a:xfrm>
+          <a:off x="0" y="0"/>
+          <a:ext cx="0" cy="0"/>
+          <a:chOff x="0" y="0"/>
+          <a:chExt cx="0" cy="0"/>
+        </a:xfrm>
+      </p:grpSpPr>
+      <p:sp>
+        <p:nvSpPr>
+          <p:cNvPr id="2" name="Title 1">
+            <a:extLst>
+              <a:ext uri="{FF2B5EF4-FFF2-40B4-BE49-F238E27FC236}">
+                <a16:creationId xmlns:a16="http://schemas.microsoft.com/office/drawing/2014/main" id="{29523985-5248-591A-93B9-E3260A7697A6}"/>
+              </a:ext>
+            </a:extLst>
+          </p:cNvPr>
+          <p:cNvSpPr>
+            <a:spLocks noGrp="1"/>
+          </p:cNvSpPr>
+          <p:nvPr>
+            <p:ph type="title"/>
+          </p:nvPr>
+        </p:nvSpPr>
+        <p:spPr>
+          <a:xfrm>
+            <a:off x="1222626" y="624110"/>
+            <a:ext cx="10281986" cy="670434"/>
+          </a:xfrm>
+        </p:spPr>
+        <p:txBody>
+          <a:bodyPr/>
+          <a:lstStyle/>
+          <a:p>
+            <a:r>
+              <a:rPr lang="en-SG" dirty="0"/>
+              <a:t>Appendix - Additional Experiments &amp; Demos</a:t>
+            </a:r>
+          </a:p>
+        </p:txBody>
+      </p:sp>
+      <p:graphicFrame>
+        <p:nvGraphicFramePr>
+          <p:cNvPr id="6" name="Content Placeholder 3">
+            <a:extLst>
+              <a:ext uri="{FF2B5EF4-FFF2-40B4-BE49-F238E27FC236}">
+                <a16:creationId xmlns:a16="http://schemas.microsoft.com/office/drawing/2014/main" id="{F579417D-CC35-1E78-A607-1043413298FA}"/>
+              </a:ext>
+            </a:extLst>
+          </p:cNvPr>
+          <p:cNvGraphicFramePr>
+            <a:graphicFrameLocks noGrp="1"/>
+          </p:cNvGraphicFramePr>
+          <p:nvPr>
+            <p:ph sz="quarter" idx="13"/>
+            <p:extLst>
+              <p:ext uri="{D42A27DB-BD31-4B8C-83A1-F6EECF244321}">
+                <p14:modId xmlns:p14="http://schemas.microsoft.com/office/powerpoint/2010/main" val="1425314906"/>
+              </p:ext>
+            </p:extLst>
+          </p:nvPr>
+        </p:nvGraphicFramePr>
+        <p:xfrm>
+          <a:off x="1424462" y="1818525"/>
+          <a:ext cx="8890792" cy="3010329"/>
+        </p:xfrm>
+        <a:graphic>
+          <a:graphicData uri="http://schemas.openxmlformats.org/drawingml/2006/diagram">
+            <dgm:relIds xmlns:dgm="http://schemas.openxmlformats.org/drawingml/2006/diagram" xmlns:r="http://schemas.openxmlformats.org/officeDocument/2006/relationships" r:dm="rId2" r:lo="rId3" r:qs="rId4" r:cs="rId5"/>
+          </a:graphicData>
+        </a:graphic>
+      </p:graphicFrame>
+    </p:spTree>
+    <p:extLst>
+      <p:ext uri="{BB962C8B-B14F-4D97-AF65-F5344CB8AC3E}">
+        <p14:creationId xmlns:p14="http://schemas.microsoft.com/office/powerpoint/2010/main" val="2491464440"/>
+      </p:ext>
+    </p:extLst>
+  </p:cSld>
+  <p:clrMapOvr>
+    <a:masterClrMapping/>
+  </p:clrMapOvr>
+</p:sld>
+</file>
+
+<file path=ppt/slides/slide11.xml><?xml version="1.0" encoding="utf-8"?>
 <p:sld xmlns:a="http://schemas.openxmlformats.org/drawingml/2006/main" xmlns:r="http://schemas.openxmlformats.org/officeDocument/2006/relationships" xmlns:p="http://schemas.openxmlformats.org/presentationml/2006/main">
   <p:cSld>
     <p:spTree>
@@ -35722,14 +38895,14 @@
             <p:ph sz="quarter" idx="13"/>
             <p:extLst>
               <p:ext uri="{D42A27DB-BD31-4B8C-83A1-F6EECF244321}">
-                <p14:modId xmlns:p14="http://schemas.microsoft.com/office/powerpoint/2010/main" val="3081497103"/>
+                <p14:modId xmlns:p14="http://schemas.microsoft.com/office/powerpoint/2010/main" val="4033188409"/>
               </p:ext>
             </p:extLst>
           </p:nvPr>
         </p:nvGraphicFramePr>
         <p:xfrm>
           <a:off x="1495426" y="1371600"/>
-          <a:ext cx="10009185" cy="4705350"/>
+          <a:ext cx="10114372" cy="4862290"/>
         </p:xfrm>
         <a:graphic>
           <a:graphicData uri="http://schemas.openxmlformats.org/drawingml/2006/diagram">
@@ -38450,14 +41623,14 @@
             <p:ph sz="quarter" idx="13"/>
             <p:extLst>
               <p:ext uri="{D42A27DB-BD31-4B8C-83A1-F6EECF244321}">
-                <p14:modId xmlns:p14="http://schemas.microsoft.com/office/powerpoint/2010/main" val="1891390064"/>
+                <p14:modId xmlns:p14="http://schemas.microsoft.com/office/powerpoint/2010/main" val="1314438815"/>
               </p:ext>
             </p:extLst>
           </p:nvPr>
         </p:nvGraphicFramePr>
         <p:xfrm>
-          <a:off x="1681316" y="1446612"/>
-          <a:ext cx="9085007" cy="4413415"/>
+          <a:off x="1681316" y="1294544"/>
+          <a:ext cx="9075727" cy="5075434"/>
         </p:xfrm>
         <a:graphic>
           <a:graphicData uri="http://schemas.openxmlformats.org/drawingml/2006/diagram">

</xml_diff>